<commit_message>
chore: update year to 2026 in cover and closing slides
</commit_message>
<xml_diff>
--- a/MIS_Altera_Brandbook.pptx
+++ b/MIS_Altera_Brandbook.pptx
@@ -2110,7 +2110,7 @@
                 <a:ea typeface="Liberation Sans Narrow" pitchFamily="34" charset="-122"/>
                 <a:cs typeface="Liberation Sans Narrow" pitchFamily="34" charset="-120"/>
               </a:rPr>
-              <a:t>BRAND BOOK · 2025</a:t>
+              <a:t>BRAND BOOK · 2026</a:t>
             </a:r>
             <a:endParaRPr lang="en-US" sz="800" dirty="0"/>
           </a:p>
@@ -5285,7 +5285,7 @@
       </p:sp>
       <p:pic>
         <p:nvPicPr>
-          <p:cNvPr id="4" name="Image 1" descr="/tmp/h2p-svg-1786013072856-4hw4d0.png">    </p:cNvPr>
+          <p:cNvPr id="4" name="Image 1" descr="/tmp/h2p-svg-1786014518137-xrn8kb.png">    </p:cNvPr>
           <p:cNvPicPr>
             <a:picLocks noChangeAspect="1"/>
           </p:cNvPicPr>
@@ -8479,7 +8479,7 @@
       </p:grpSpPr>
       <p:pic>
         <p:nvPicPr>
-          <p:cNvPr id="2" name="Image 0" descr="/tmp/h2p-fit-1786013073155-4i6n5d.png">    </p:cNvPr>
+          <p:cNvPr id="2" name="Image 0" descr="/tmp/h2p-fit-1786014517824-4yjs8y.png">    </p:cNvPr>
           <p:cNvPicPr>
             <a:picLocks noChangeAspect="1"/>
           </p:cNvPicPr>
@@ -8971,7 +8971,7 @@
                 <a:ea typeface="Carlito" pitchFamily="34" charset="-122"/>
                 <a:cs typeface="Carlito" pitchFamily="34" charset="-120"/>
               </a:rPr>
-              <a:t>МИС АЛЬТЕРА · БРЕНД-БУК · 2025</a:t>
+              <a:t>МИС АЛЬТЕРА · БРЕНД-БУК · 2026</a:t>
             </a:r>
             <a:endParaRPr lang="en-US" sz="800" dirty="0"/>
           </a:p>

</xml_diff>

<commit_message>
fix: embed Inter + Playfair Display fonts into .pptx
- Add @font-face declarations in global.css pointing to local TTF files
- Patch html2pptx1.js to pass-through 'Inter' and 'Playfair Display'
  as PPT-safe (instead of mapping to Carlito/Tinos)
- Embed 7 TTF files (5 Inter weights + 2 Playfair variable) into
  ppt/fonts/*.fntdata via <p:embeddedFontLst> in presentation.xml
- .pptx now displays correct brand fonts on any viewer (PowerPoint,
  Keynote, LibreOffice) without requiring local font installation
- File size: 1.8 MB -> 3.0 MB (+718 KB embedded fonts)
</commit_message>
<xml_diff>
--- a/MIS_Altera_Brandbook.pptx
+++ b/MIS_Altera_Brandbook.pptx
@@ -1,6 +1,18 @@
 
 <file path=ppt/presentation.xml><?xml version="1.0" encoding="utf-8"?>
 <p:presentation xmlns:a="http://schemas.openxmlformats.org/drawingml/2006/main" xmlns:r="http://schemas.openxmlformats.org/officeDocument/2006/relationships" xmlns:p="http://schemas.openxmlformats.org/presentationml/2006/main" saveSubsetFonts="1" autoCompressPictures="0">
+  <p:embeddedFontLst>
+    <p:embeddedFont>
+      <p:font typeface="Inter"/>
+      <p:bold r:id="rId21"/>
+      <p:regular r:id="rId22"/>
+    </p:embeddedFont>
+    <p:embeddedFont>
+      <p:font typeface="Playfair Display"/>
+      <p:italic r:id="rId26"/>
+      <p:regular r:id="rId27"/>
+    </p:embeddedFont>
+  </p:embeddedFontLst>
   <p:sldMasterIdLst>
     <p:sldMasterId id="2147483648" r:id="rId1"/>
   </p:sldMasterIdLst>
@@ -2080,8 +2092,8 @@
         </p:nvSpPr>
         <p:spPr>
           <a:xfrm>
-            <a:off x="3934085" y="1001241"/>
-            <a:ext cx="1775799" cy="170021"/>
+            <a:off x="3924709" y="1001241"/>
+            <a:ext cx="1801902" cy="170021"/>
           </a:xfrm>
           <a:prstGeom prst="rect">
             <a:avLst/>
@@ -2124,7 +2136,7 @@
         </p:nvSpPr>
         <p:spPr>
           <a:xfrm>
-            <a:off x="3932523" y="1337667"/>
+            <a:off x="3932634" y="1337667"/>
             <a:ext cx="1278731" cy="1278731"/>
           </a:xfrm>
           <a:prstGeom prst="ellipse">
@@ -2161,7 +2173,7 @@
         </p:nvSpPr>
         <p:spPr>
           <a:xfrm>
-            <a:off x="4074683" y="1479828"/>
+            <a:off x="4074795" y="1479828"/>
             <a:ext cx="994410" cy="994410"/>
           </a:xfrm>
           <a:prstGeom prst="rect">
@@ -2200,8 +2212,8 @@
         </p:nvSpPr>
         <p:spPr>
           <a:xfrm>
-            <a:off x="3832622" y="2748558"/>
-            <a:ext cx="2217967" cy="334770"/>
+            <a:off x="3849030" y="2748558"/>
+            <a:ext cx="2168909" cy="334770"/>
           </a:xfrm>
           <a:prstGeom prst="rect">
             <a:avLst/>
@@ -2224,9 +2236,9 @@
                 <a:solidFill>
                   <a:srgbClr val="FFFFFF"/>
                 </a:solidFill>
-                <a:latin typeface="Tinos" pitchFamily="34" charset="0"/>
-                <a:ea typeface="Tinos" pitchFamily="34" charset="-122"/>
-                <a:cs typeface="Tinos" pitchFamily="34" charset="-120"/>
+                <a:latin typeface="Playfair Display" pitchFamily="34" charset="0"/>
+                <a:ea typeface="Playfair Display" pitchFamily="34" charset="-122"/>
+                <a:cs typeface="Playfair Display" pitchFamily="34" charset="-120"/>
               </a:rPr>
               <a:t>АЛЬТЕРА</a:t>
             </a:r>
@@ -2243,7 +2255,7 @@
         <p:spPr>
           <a:xfrm>
             <a:off x="274320" y="3258555"/>
-            <a:ext cx="8595248" cy="475211"/>
+            <a:ext cx="8595360" cy="475211"/>
           </a:xfrm>
           <a:prstGeom prst="rect">
             <a:avLst/>
@@ -2266,9 +2278,9 @@
                 <a:solidFill>
                   <a:srgbClr val="FFFFFF"/>
                 </a:solidFill>
-                <a:latin typeface="Tinos" pitchFamily="34" charset="0"/>
-                <a:ea typeface="Tinos" pitchFamily="34" charset="-122"/>
-                <a:cs typeface="Tinos" pitchFamily="34" charset="-120"/>
+                <a:latin typeface="Playfair Display" pitchFamily="34" charset="0"/>
+                <a:ea typeface="Playfair Display" pitchFamily="34" charset="-122"/>
+                <a:cs typeface="Playfair Display" pitchFamily="34" charset="-120"/>
               </a:rPr>
               <a:t>МИС Альтера. Бренд-бук.</a:t>
             </a:r>
@@ -2284,8 +2296,8 @@
         </p:nvSpPr>
         <p:spPr>
           <a:xfrm>
-            <a:off x="3205075" y="3898590"/>
-            <a:ext cx="2733851" cy="263042"/>
+            <a:off x="3260408" y="3898590"/>
+            <a:ext cx="2623185" cy="263042"/>
           </a:xfrm>
           <a:prstGeom prst="rect">
             <a:avLst/>
@@ -2310,9 +2322,9 @@
                     <a:alpha val="90000"/>
                   </a:srgbClr>
                 </a:solidFill>
-                <a:latin typeface="Carlito" pitchFamily="34" charset="0"/>
-                <a:ea typeface="Carlito" pitchFamily="34" charset="-122"/>
-                <a:cs typeface="Carlito" pitchFamily="34" charset="-120"/>
+                <a:latin typeface="Inter" pitchFamily="34" charset="0"/>
+                <a:ea typeface="Inter" pitchFamily="34" charset="-122"/>
+                <a:cs typeface="Inter" pitchFamily="34" charset="-120"/>
               </a:rPr>
               <a:t>Технологии, которые заботятся.</a:t>
             </a:r>
@@ -2360,8 +2372,8 @@
         </p:nvSpPr>
         <p:spPr>
           <a:xfrm>
-            <a:off x="3486277" y="4610621"/>
-            <a:ext cx="2171335" cy="170021"/>
+            <a:off x="3463247" y="4610621"/>
+            <a:ext cx="2217505" cy="170021"/>
           </a:xfrm>
           <a:prstGeom prst="rect">
             <a:avLst/>
@@ -2386,9 +2398,9 @@
                     <a:alpha val="70000"/>
                   </a:srgbClr>
                 </a:solidFill>
-                <a:latin typeface="Carlito" pitchFamily="34" charset="0"/>
-                <a:ea typeface="Carlito" pitchFamily="34" charset="-122"/>
-                <a:cs typeface="Carlito" pitchFamily="34" charset="-120"/>
+                <a:latin typeface="Inter" pitchFamily="34" charset="0"/>
+                <a:ea typeface="Inter" pitchFamily="34" charset="-122"/>
+                <a:cs typeface="Inter" pitchFamily="34" charset="-120"/>
               </a:rPr>
               <a:t>ОТДЕЛ ДИЗАЙНА И МАРКЕТИНГА</a:t>
             </a:r>
@@ -2576,9 +2588,9 @@
                 <a:solidFill>
                   <a:srgbClr val="46B0A3"/>
                 </a:solidFill>
-                <a:latin typeface="Carlito" pitchFamily="34" charset="0"/>
-                <a:ea typeface="Carlito" pitchFamily="34" charset="-122"/>
-                <a:cs typeface="Carlito" pitchFamily="34" charset="-120"/>
+                <a:latin typeface="Inter" pitchFamily="34" charset="0"/>
+                <a:ea typeface="Inter" pitchFamily="34" charset="-122"/>
+                <a:cs typeface="Inter" pitchFamily="34" charset="-120"/>
               </a:rPr>
               <a:t>10 — ДЕЛОВАЯ ДОКУМЕНТАЦИЯ</a:t>
             </a:r>
@@ -2618,9 +2630,9 @@
                 <a:solidFill>
                   <a:srgbClr val="1A1F2E"/>
                 </a:solidFill>
-                <a:latin typeface="Tinos" pitchFamily="34" charset="0"/>
-                <a:ea typeface="Tinos" pitchFamily="34" charset="-122"/>
-                <a:cs typeface="Tinos" pitchFamily="34" charset="-120"/>
+                <a:latin typeface="Playfair Display" pitchFamily="34" charset="0"/>
+                <a:ea typeface="Playfair Display" pitchFamily="34" charset="-122"/>
+                <a:cs typeface="Playfair Display" pitchFamily="34" charset="-120"/>
               </a:rPr>
               <a:t>Бланки, визитки и идентификация.</a:t>
             </a:r>
@@ -2660,9 +2672,9 @@
                 <a:solidFill>
                   <a:srgbClr val="4A5468"/>
                 </a:solidFill>
-                <a:latin typeface="Carlito" pitchFamily="34" charset="0"/>
-                <a:ea typeface="Carlito" pitchFamily="34" charset="-122"/>
-                <a:cs typeface="Carlito" pitchFamily="34" charset="-120"/>
+                <a:latin typeface="Inter" pitchFamily="34" charset="0"/>
+                <a:ea typeface="Inter" pitchFamily="34" charset="-122"/>
+                <a:cs typeface="Inter" pitchFamily="34" charset="-120"/>
               </a:rPr>
               <a:t>Строгие требования к печатной продукции. Высокая контрастность, чистая типографика, точечное использование фирменного цвета.</a:t>
             </a:r>
@@ -2741,9 +2753,9 @@
                 <a:solidFill>
                   <a:srgbClr val="8B95A7"/>
                 </a:solidFill>
-                <a:latin typeface="Carlito" pitchFamily="34" charset="0"/>
-                <a:ea typeface="Carlito" pitchFamily="34" charset="-122"/>
-                <a:cs typeface="Carlito" pitchFamily="34" charset="-120"/>
+                <a:latin typeface="Inter" pitchFamily="34" charset="0"/>
+                <a:ea typeface="Inter" pitchFamily="34" charset="-122"/>
+                <a:cs typeface="Inter" pitchFamily="34" charset="-120"/>
               </a:rPr>
               <a:t>БЛАНК · А4</a:t>
             </a:r>
@@ -2759,7 +2771,7 @@
         </p:nvSpPr>
         <p:spPr>
           <a:xfrm>
-            <a:off x="614363" y="2031839"/>
+            <a:off x="614363" y="1967545"/>
             <a:ext cx="2675334" cy="1714500"/>
           </a:xfrm>
           <a:prstGeom prst="roundRect">
@@ -2798,7 +2810,7 @@
         </p:nvSpPr>
         <p:spPr>
           <a:xfrm>
-            <a:off x="728663" y="2146139"/>
+            <a:off x="728663" y="2081845"/>
             <a:ext cx="157163" cy="157163"/>
           </a:xfrm>
           <a:prstGeom prst="ellipse">
@@ -2828,7 +2840,7 @@
         </p:nvSpPr>
         <p:spPr>
           <a:xfrm>
-            <a:off x="734735" y="2152211"/>
+            <a:off x="734735" y="2087917"/>
             <a:ext cx="145018" cy="145018"/>
           </a:xfrm>
           <a:prstGeom prst="rect">
@@ -2867,7 +2879,7 @@
         </p:nvSpPr>
         <p:spPr>
           <a:xfrm>
-            <a:off x="942975" y="2158305"/>
+            <a:off x="942975" y="2094012"/>
             <a:ext cx="2232422" cy="170021"/>
           </a:xfrm>
           <a:prstGeom prst="rect">
@@ -2891,9 +2903,9 @@
                 <a:solidFill>
                   <a:srgbClr val="1A1F2E"/>
                 </a:solidFill>
-                <a:latin typeface="Carlito" pitchFamily="34" charset="0"/>
-                <a:ea typeface="Carlito" pitchFamily="34" charset="-122"/>
-                <a:cs typeface="Carlito" pitchFamily="34" charset="-120"/>
+                <a:latin typeface="Inter" pitchFamily="34" charset="0"/>
+                <a:ea typeface="Inter" pitchFamily="34" charset="-122"/>
+                <a:cs typeface="Inter" pitchFamily="34" charset="-120"/>
               </a:rPr>
               <a:t>Альтера</a:t>
             </a:r>
@@ -2909,7 +2921,7 @@
         </p:nvSpPr>
         <p:spPr>
           <a:xfrm>
-            <a:off x="728663" y="2374739"/>
+            <a:off x="728663" y="2310445"/>
             <a:ext cx="2446734" cy="14288"/>
           </a:xfrm>
           <a:prstGeom prst="rect">
@@ -2939,7 +2951,7 @@
         </p:nvSpPr>
         <p:spPr>
           <a:xfrm>
-            <a:off x="728663" y="2489039"/>
+            <a:off x="728663" y="2424745"/>
             <a:ext cx="1957388" cy="42863"/>
           </a:xfrm>
           <a:prstGeom prst="roundRect">
@@ -2971,7 +2983,7 @@
         </p:nvSpPr>
         <p:spPr>
           <a:xfrm>
-            <a:off x="728663" y="2589051"/>
+            <a:off x="728663" y="2524758"/>
             <a:ext cx="2202061" cy="42863"/>
           </a:xfrm>
           <a:prstGeom prst="roundRect">
@@ -3003,7 +3015,7 @@
         </p:nvSpPr>
         <p:spPr>
           <a:xfrm>
-            <a:off x="728663" y="2689064"/>
+            <a:off x="728663" y="2624770"/>
             <a:ext cx="1712714" cy="42863"/>
           </a:xfrm>
           <a:prstGeom prst="roundRect">
@@ -3035,7 +3047,7 @@
         </p:nvSpPr>
         <p:spPr>
           <a:xfrm>
-            <a:off x="728663" y="2789076"/>
+            <a:off x="728663" y="2724783"/>
             <a:ext cx="2079724" cy="42863"/>
           </a:xfrm>
           <a:prstGeom prst="roundRect">
@@ -3067,8 +3079,8 @@
         </p:nvSpPr>
         <p:spPr>
           <a:xfrm>
-            <a:off x="614363" y="3992687"/>
-            <a:ext cx="2675334" cy="257175"/>
+            <a:off x="614363" y="3864099"/>
+            <a:ext cx="2675334" cy="385763"/>
           </a:xfrm>
           <a:prstGeom prst="rect">
             <a:avLst/>
@@ -3091,9 +3103,9 @@
                 <a:solidFill>
                   <a:srgbClr val="4A5468"/>
                 </a:solidFill>
-                <a:latin typeface="Carlito" pitchFamily="34" charset="0"/>
-                <a:ea typeface="Carlito" pitchFamily="34" charset="-122"/>
-                <a:cs typeface="Carlito" pitchFamily="34" charset="-120"/>
+                <a:latin typeface="Inter" pitchFamily="34" charset="0"/>
+                <a:ea typeface="Inter" pitchFamily="34" charset="-122"/>
+                <a:cs typeface="Inter" pitchFamily="34" charset="-120"/>
               </a:rPr>
               <a:t>Белая бумага #FFFFFF. Тонкая линия #5ECEC1 в шапке. Логотип — чёрный/тёмно-серый. Текст — только Sans-serif (Inter).</a:t>
             </a:r>
@@ -3172,9 +3184,9 @@
                 <a:solidFill>
                   <a:srgbClr val="8B95A7"/>
                 </a:solidFill>
-                <a:latin typeface="Carlito" pitchFamily="34" charset="0"/>
-                <a:ea typeface="Carlito" pitchFamily="34" charset="-122"/>
-                <a:cs typeface="Carlito" pitchFamily="34" charset="-120"/>
+                <a:latin typeface="Inter" pitchFamily="34" charset="0"/>
+                <a:ea typeface="Inter" pitchFamily="34" charset="-122"/>
+                <a:cs typeface="Inter" pitchFamily="34" charset="-120"/>
               </a:rPr>
               <a:t>ВИЗИТКА · 85×55 ММ</a:t>
             </a:r>
@@ -3338,9 +3350,9 @@
                 <a:solidFill>
                   <a:srgbClr val="1A1F2E"/>
                 </a:solidFill>
-                <a:latin typeface="Carlito" pitchFamily="34" charset="0"/>
-                <a:ea typeface="Carlito" pitchFamily="34" charset="-122"/>
-                <a:cs typeface="Carlito" pitchFamily="34" charset="-120"/>
+                <a:latin typeface="Inter" pitchFamily="34" charset="0"/>
+                <a:ea typeface="Inter" pitchFamily="34" charset="-122"/>
+                <a:cs typeface="Inter" pitchFamily="34" charset="-120"/>
               </a:rPr>
               <a:t>Иван Петров</a:t>
             </a:r>
@@ -3380,9 +3392,9 @@
                 <a:solidFill>
                   <a:srgbClr val="8B95A7"/>
                 </a:solidFill>
-                <a:latin typeface="Carlito" pitchFamily="34" charset="0"/>
-                <a:ea typeface="Carlito" pitchFamily="34" charset="-122"/>
-                <a:cs typeface="Carlito" pitchFamily="34" charset="-120"/>
+                <a:latin typeface="Inter" pitchFamily="34" charset="0"/>
+                <a:ea typeface="Inter" pitchFamily="34" charset="-122"/>
+                <a:cs typeface="Inter" pitchFamily="34" charset="-120"/>
               </a:rPr>
               <a:t>Главный врач</a:t>
             </a:r>
@@ -3464,9 +3476,9 @@
                 <a:solidFill>
                   <a:srgbClr val="4A5468"/>
                 </a:solidFill>
-                <a:latin typeface="Carlito" pitchFamily="34" charset="0"/>
-                <a:ea typeface="Carlito" pitchFamily="34" charset="-122"/>
-                <a:cs typeface="Carlito" pitchFamily="34" charset="-120"/>
+                <a:latin typeface="Inter" pitchFamily="34" charset="0"/>
+                <a:ea typeface="Inter" pitchFamily="34" charset="-122"/>
+                <a:cs typeface="Inter" pitchFamily="34" charset="-120"/>
               </a:rPr>
               <a:t>С одной стороны — логотип на фирменном фоне. С другой — контактные данные. Имя и должность — Playfair Display, контакты — Inter.</a:t>
             </a:r>
@@ -3545,9 +3557,9 @@
                 <a:solidFill>
                   <a:srgbClr val="8B95A7"/>
                 </a:solidFill>
-                <a:latin typeface="Carlito" pitchFamily="34" charset="0"/>
-                <a:ea typeface="Carlito" pitchFamily="34" charset="-122"/>
-                <a:cs typeface="Carlito" pitchFamily="34" charset="-120"/>
+                <a:latin typeface="Inter" pitchFamily="34" charset="0"/>
+                <a:ea typeface="Inter" pitchFamily="34" charset="-122"/>
+                <a:cs typeface="Inter" pitchFamily="34" charset="-120"/>
               </a:rPr>
               <a:t>БЕЙДЖ · КАРТОЧКА</a:t>
             </a:r>
@@ -3678,8 +3690,8 @@
         </p:nvSpPr>
         <p:spPr>
           <a:xfrm>
-            <a:off x="7121091" y="2625551"/>
-            <a:ext cx="705780" cy="155850"/>
+            <a:off x="7127900" y="2625551"/>
+            <a:ext cx="698971" cy="155850"/>
           </a:xfrm>
           <a:prstGeom prst="rect">
             <a:avLst/>
@@ -3704,9 +3716,9 @@
                 <a:solidFill>
                   <a:srgbClr val="1A1F2E"/>
                 </a:solidFill>
-                <a:latin typeface="Carlito" pitchFamily="34" charset="0"/>
-                <a:ea typeface="Carlito" pitchFamily="34" charset="-122"/>
-                <a:cs typeface="Carlito" pitchFamily="34" charset="-120"/>
+                <a:latin typeface="Inter" pitchFamily="34" charset="0"/>
+                <a:ea typeface="Inter" pitchFamily="34" charset="-122"/>
+                <a:cs typeface="Inter" pitchFamily="34" charset="-120"/>
               </a:rPr>
               <a:t>ИВАН ПЕТРОВ</a:t>
             </a:r>
@@ -3752,7 +3764,7 @@
         </p:nvSpPr>
         <p:spPr>
           <a:xfrm>
-            <a:off x="7167179" y="2808833"/>
+            <a:off x="7168963" y="2808833"/>
             <a:ext cx="662574" cy="91440"/>
           </a:xfrm>
           <a:prstGeom prst="rect">
@@ -3778,9 +3790,9 @@
                 <a:solidFill>
                   <a:srgbClr val="8B95A7"/>
                 </a:solidFill>
-                <a:latin typeface="Carlito" pitchFamily="34" charset="0"/>
-                <a:ea typeface="Carlito" pitchFamily="34" charset="-122"/>
-                <a:cs typeface="Carlito" pitchFamily="34" charset="-120"/>
+                <a:latin typeface="Inter" pitchFamily="34" charset="0"/>
+                <a:ea typeface="Inter" pitchFamily="34" charset="-122"/>
+                <a:cs typeface="Inter" pitchFamily="34" charset="-120"/>
               </a:rPr>
               <a:t>ГЛАВНЫЙ ВРАЧ</a:t>
             </a:r>
@@ -3796,8 +3808,8 @@
         </p:nvSpPr>
         <p:spPr>
           <a:xfrm>
-            <a:off x="7222108" y="2925924"/>
-            <a:ext cx="526272" cy="91440"/>
+            <a:off x="7223001" y="2925924"/>
+            <a:ext cx="523992" cy="91440"/>
           </a:xfrm>
           <a:prstGeom prst="rect">
             <a:avLst/>
@@ -3820,9 +3832,9 @@
                 <a:solidFill>
                   <a:srgbClr val="8B95A7"/>
                 </a:solidFill>
-                <a:latin typeface="Carlito" pitchFamily="34" charset="0"/>
-                <a:ea typeface="Carlito" pitchFamily="34" charset="-122"/>
-                <a:cs typeface="Carlito" pitchFamily="34" charset="-120"/>
+                <a:latin typeface="Inter" pitchFamily="34" charset="0"/>
+                <a:ea typeface="Inter" pitchFamily="34" charset="-122"/>
+                <a:cs typeface="Inter" pitchFamily="34" charset="-120"/>
               </a:rPr>
               <a:t>ОТДЕЛЕНИЕ №3</a:t>
             </a:r>
@@ -3862,9 +3874,9 @@
                 <a:solidFill>
                   <a:srgbClr val="4A5468"/>
                 </a:solidFill>
-                <a:latin typeface="Carlito" pitchFamily="34" charset="0"/>
-                <a:ea typeface="Carlito" pitchFamily="34" charset="-122"/>
-                <a:cs typeface="Carlito" pitchFamily="34" charset="-120"/>
+                <a:latin typeface="Inter" pitchFamily="34" charset="0"/>
+                <a:ea typeface="Inter" pitchFamily="34" charset="-122"/>
+                <a:cs typeface="Inter" pitchFamily="34" charset="-120"/>
               </a:rPr>
               <a:t>Высокая контрастность — белый фон и чёткий чёрный текст. Логотип #5ECEC1 в малом размере строго обязателен. Для ярких операционных — версия с белым фоном.</a:t>
             </a:r>
@@ -3881,7 +3893,7 @@
         <p:spPr>
           <a:xfrm>
             <a:off x="257175" y="200025"/>
-            <a:ext cx="1257779" cy="169999"/>
+            <a:ext cx="1152902" cy="169999"/>
           </a:xfrm>
           <a:prstGeom prst="rect">
             <a:avLst/>
@@ -3904,9 +3916,9 @@
                 <a:solidFill>
                   <a:srgbClr val="8B95A7"/>
                 </a:solidFill>
-                <a:latin typeface="Carlito" pitchFamily="34" charset="0"/>
-                <a:ea typeface="Carlito" pitchFamily="34" charset="-122"/>
-                <a:cs typeface="Carlito" pitchFamily="34" charset="-120"/>
+                <a:latin typeface="Inter" pitchFamily="34" charset="0"/>
+                <a:ea typeface="Inter" pitchFamily="34" charset="-122"/>
+                <a:cs typeface="Inter" pitchFamily="34" charset="-120"/>
               </a:rPr>
               <a:t>МИС АЛЬТЕРА</a:t>
             </a:r>
@@ -3922,8 +3934,8 @@
         </p:nvSpPr>
         <p:spPr>
           <a:xfrm>
-            <a:off x="8508095" y="4799595"/>
-            <a:ext cx="542768" cy="169999"/>
+            <a:off x="8556203" y="4799595"/>
+            <a:ext cx="473822" cy="169999"/>
           </a:xfrm>
           <a:prstGeom prst="rect">
             <a:avLst/>
@@ -4078,9 +4090,9 @@
                 <a:solidFill>
                   <a:srgbClr val="46B0A3"/>
                 </a:solidFill>
-                <a:latin typeface="Carlito" pitchFamily="34" charset="0"/>
-                <a:ea typeface="Carlito" pitchFamily="34" charset="-122"/>
-                <a:cs typeface="Carlito" pitchFamily="34" charset="-120"/>
+                <a:latin typeface="Inter" pitchFamily="34" charset="0"/>
+                <a:ea typeface="Inter" pitchFamily="34" charset="-122"/>
+                <a:cs typeface="Inter" pitchFamily="34" charset="-120"/>
               </a:rPr>
               <a:t>11 — UI KIT · КНОПКИ</a:t>
             </a:r>
@@ -4120,9 +4132,9 @@
                 <a:solidFill>
                   <a:srgbClr val="1A1F2E"/>
                 </a:solidFill>
-                <a:latin typeface="Tinos" pitchFamily="34" charset="0"/>
-                <a:ea typeface="Tinos" pitchFamily="34" charset="-122"/>
-                <a:cs typeface="Tinos" pitchFamily="34" charset="-120"/>
+                <a:latin typeface="Playfair Display" pitchFamily="34" charset="0"/>
+                <a:ea typeface="Playfair Display" pitchFamily="34" charset="-122"/>
+                <a:cs typeface="Playfair Display" pitchFamily="34" charset="-120"/>
               </a:rPr>
               <a:t>Кнопки и состояния.</a:t>
             </a:r>
@@ -4162,9 +4174,9 @@
                 <a:solidFill>
                   <a:srgbClr val="4A5468"/>
                 </a:solidFill>
-                <a:latin typeface="Carlito" pitchFamily="34" charset="0"/>
-                <a:ea typeface="Carlito" pitchFamily="34" charset="-122"/>
-                <a:cs typeface="Carlito" pitchFamily="34" charset="-120"/>
+                <a:latin typeface="Inter" pitchFamily="34" charset="0"/>
+                <a:ea typeface="Inter" pitchFamily="34" charset="-122"/>
+                <a:cs typeface="Inter" pitchFamily="34" charset="-120"/>
               </a:rPr>
               <a:t>Единый стандарт для всех кнопок системы. Скругление углов (border-radius) — 6–8 пикселей. Чётко прописаны Hover, Active, Disabled.</a:t>
             </a:r>
@@ -4212,8 +4224,8 @@
         </p:nvSpPr>
         <p:spPr>
           <a:xfrm>
-            <a:off x="1518717" y="1578992"/>
-            <a:ext cx="778679" cy="170021"/>
+            <a:off x="1536576" y="1578992"/>
+            <a:ext cx="727535" cy="170021"/>
           </a:xfrm>
           <a:prstGeom prst="rect">
             <a:avLst/>
@@ -4236,9 +4248,9 @@
                 <a:solidFill>
                   <a:srgbClr val="8B95A7"/>
                 </a:solidFill>
-                <a:latin typeface="Carlito" pitchFamily="34" charset="0"/>
-                <a:ea typeface="Carlito" pitchFamily="34" charset="-122"/>
-                <a:cs typeface="Carlito" pitchFamily="34" charset="-120"/>
+                <a:latin typeface="Inter" pitchFamily="34" charset="0"/>
+                <a:ea typeface="Inter" pitchFamily="34" charset="-122"/>
+                <a:cs typeface="Inter" pitchFamily="34" charset="-120"/>
               </a:rPr>
               <a:t>PRIMARY</a:t>
             </a:r>
@@ -4286,8 +4298,8 @@
         </p:nvSpPr>
         <p:spPr>
           <a:xfrm>
-            <a:off x="4208115" y="1578992"/>
-            <a:ext cx="1041915" cy="170021"/>
+            <a:off x="4227426" y="1578992"/>
+            <a:ext cx="986615" cy="170021"/>
           </a:xfrm>
           <a:prstGeom prst="rect">
             <a:avLst/>
@@ -4310,9 +4322,9 @@
                 <a:solidFill>
                   <a:srgbClr val="8B95A7"/>
                 </a:solidFill>
-                <a:latin typeface="Carlito" pitchFamily="34" charset="0"/>
-                <a:ea typeface="Carlito" pitchFamily="34" charset="-122"/>
-                <a:cs typeface="Carlito" pitchFamily="34" charset="-120"/>
+                <a:latin typeface="Inter" pitchFamily="34" charset="0"/>
+                <a:ea typeface="Inter" pitchFamily="34" charset="-122"/>
+                <a:cs typeface="Inter" pitchFamily="34" charset="-120"/>
               </a:rPr>
               <a:t>SECONDARY</a:t>
             </a:r>
@@ -4360,8 +4372,8 @@
         </p:nvSpPr>
         <p:spPr>
           <a:xfrm>
-            <a:off x="7104794" y="1578992"/>
-            <a:ext cx="711392" cy="170021"/>
+            <a:off x="7124774" y="1578992"/>
+            <a:ext cx="654334" cy="170021"/>
           </a:xfrm>
           <a:prstGeom prst="rect">
             <a:avLst/>
@@ -4384,9 +4396,9 @@
                 <a:solidFill>
                   <a:srgbClr val="8B95A7"/>
                 </a:solidFill>
-                <a:latin typeface="Carlito" pitchFamily="34" charset="0"/>
-                <a:ea typeface="Carlito" pitchFamily="34" charset="-122"/>
-                <a:cs typeface="Carlito" pitchFamily="34" charset="-120"/>
+                <a:latin typeface="Inter" pitchFamily="34" charset="0"/>
+                <a:ea typeface="Inter" pitchFamily="34" charset="-122"/>
+                <a:cs typeface="Inter" pitchFamily="34" charset="-120"/>
               </a:rPr>
               <a:t>DANGER</a:t>
             </a:r>
@@ -4465,9 +4477,9 @@
                 <a:solidFill>
                   <a:srgbClr val="8B95A7"/>
                 </a:solidFill>
-                <a:latin typeface="Carlito" pitchFamily="34" charset="0"/>
-                <a:ea typeface="Carlito" pitchFamily="34" charset="-122"/>
-                <a:cs typeface="Carlito" pitchFamily="34" charset="-120"/>
+                <a:latin typeface="Inter" pitchFamily="34" charset="0"/>
+                <a:ea typeface="Inter" pitchFamily="34" charset="-122"/>
+                <a:cs typeface="Inter" pitchFamily="34" charset="-120"/>
               </a:rPr>
               <a:t>СОСТОЯНИЯ</a:t>
             </a:r>
@@ -4484,7 +4496,7 @@
         <p:spPr>
           <a:xfrm>
             <a:off x="628650" y="3370676"/>
-            <a:ext cx="427174" cy="224028"/>
+            <a:ext cx="421481" cy="224028"/>
           </a:xfrm>
           <a:prstGeom prst="roundRect">
             <a:avLst>
@@ -4518,7 +4530,7 @@
         <p:spPr>
           <a:xfrm>
             <a:off x="628650" y="3382677"/>
-            <a:ext cx="427174" cy="200025"/>
+            <a:ext cx="421481" cy="200025"/>
           </a:xfrm>
           <a:prstGeom prst="rect">
             <a:avLst/>
@@ -4541,9 +4553,9 @@
                 <a:solidFill>
                   <a:srgbClr val="46B0A3"/>
                 </a:solidFill>
-                <a:latin typeface="Carlito" pitchFamily="34" charset="0"/>
-                <a:ea typeface="Carlito" pitchFamily="34" charset="-122"/>
-                <a:cs typeface="Carlito" pitchFamily="34" charset="-120"/>
+                <a:latin typeface="Inter" pitchFamily="34" charset="0"/>
+                <a:ea typeface="Inter" pitchFamily="34" charset="-122"/>
+                <a:cs typeface="Inter" pitchFamily="34" charset="-120"/>
               </a:rPr>
               <a:t>Hover</a:t>
             </a:r>
@@ -4559,8 +4571,8 @@
         </p:nvSpPr>
         <p:spPr>
           <a:xfrm>
-            <a:off x="1127261" y="3370676"/>
-            <a:ext cx="436662" cy="224028"/>
+            <a:off x="1121569" y="3370676"/>
+            <a:ext cx="435769" cy="224028"/>
           </a:xfrm>
           <a:prstGeom prst="roundRect">
             <a:avLst>
@@ -4591,8 +4603,8 @@
         </p:nvSpPr>
         <p:spPr>
           <a:xfrm>
-            <a:off x="1127261" y="3382677"/>
-            <a:ext cx="436662" cy="200025"/>
+            <a:off x="1121569" y="3382677"/>
+            <a:ext cx="435769" cy="200025"/>
           </a:xfrm>
           <a:prstGeom prst="rect">
             <a:avLst/>
@@ -4615,9 +4627,9 @@
                 <a:solidFill>
                   <a:srgbClr val="FFFFFF"/>
                 </a:solidFill>
-                <a:latin typeface="Carlito" pitchFamily="34" charset="0"/>
-                <a:ea typeface="Carlito" pitchFamily="34" charset="-122"/>
-                <a:cs typeface="Carlito" pitchFamily="34" charset="-120"/>
+                <a:latin typeface="Inter" pitchFamily="34" charset="0"/>
+                <a:ea typeface="Inter" pitchFamily="34" charset="-122"/>
+                <a:cs typeface="Inter" pitchFamily="34" charset="-120"/>
               </a:rPr>
               <a:t>Active</a:t>
             </a:r>
@@ -4633,8 +4645,8 @@
         </p:nvSpPr>
         <p:spPr>
           <a:xfrm>
-            <a:off x="1635361" y="3370676"/>
-            <a:ext cx="543930" cy="224028"/>
+            <a:off x="1628775" y="3370676"/>
+            <a:ext cx="521494" cy="224028"/>
           </a:xfrm>
           <a:prstGeom prst="roundRect">
             <a:avLst>
@@ -4667,8 +4679,8 @@
         </p:nvSpPr>
         <p:spPr>
           <a:xfrm>
-            <a:off x="1635361" y="3382677"/>
-            <a:ext cx="543930" cy="200025"/>
+            <a:off x="1628775" y="3382677"/>
+            <a:ext cx="521494" cy="200025"/>
           </a:xfrm>
           <a:prstGeom prst="rect">
             <a:avLst/>
@@ -4693,9 +4705,9 @@
                     <a:alpha val="60000"/>
                   </a:srgbClr>
                 </a:solidFill>
-                <a:latin typeface="Carlito" pitchFamily="34" charset="0"/>
-                <a:ea typeface="Carlito" pitchFamily="34" charset="-122"/>
-                <a:cs typeface="Carlito" pitchFamily="34" charset="-120"/>
+                <a:latin typeface="Inter" pitchFamily="34" charset="0"/>
+                <a:ea typeface="Inter" pitchFamily="34" charset="-122"/>
+                <a:cs typeface="Inter" pitchFamily="34" charset="-120"/>
               </a:rPr>
               <a:t>Disabled</a:t>
             </a:r>
@@ -4711,8 +4723,8 @@
         </p:nvSpPr>
         <p:spPr>
           <a:xfrm>
-            <a:off x="2250728" y="3370676"/>
-            <a:ext cx="444922" cy="224028"/>
+            <a:off x="2221706" y="3370676"/>
+            <a:ext cx="442913" cy="224028"/>
           </a:xfrm>
           <a:prstGeom prst="roundRect">
             <a:avLst>
@@ -4748,8 +4760,8 @@
         </p:nvSpPr>
         <p:spPr>
           <a:xfrm>
-            <a:off x="2250728" y="3382677"/>
-            <a:ext cx="444922" cy="200025"/>
+            <a:off x="2221706" y="3382677"/>
+            <a:ext cx="442913" cy="200025"/>
           </a:xfrm>
           <a:prstGeom prst="rect">
             <a:avLst/>
@@ -4772,9 +4784,9 @@
                 <a:solidFill>
                   <a:srgbClr val="1A1F2E"/>
                 </a:solidFill>
-                <a:latin typeface="Carlito" pitchFamily="34" charset="0"/>
-                <a:ea typeface="Carlito" pitchFamily="34" charset="-122"/>
-                <a:cs typeface="Carlito" pitchFamily="34" charset="-120"/>
+                <a:latin typeface="Inter" pitchFamily="34" charset="0"/>
+                <a:ea typeface="Inter" pitchFamily="34" charset="-122"/>
+                <a:cs typeface="Inter" pitchFamily="34" charset="-120"/>
               </a:rPr>
               <a:t>Focus</a:t>
             </a:r>
@@ -4814,9 +4826,9 @@
                 <a:solidFill>
                   <a:srgbClr val="4A5468"/>
                 </a:solidFill>
-                <a:latin typeface="Carlito" pitchFamily="34" charset="0"/>
-                <a:ea typeface="Carlito" pitchFamily="34" charset="-122"/>
-                <a:cs typeface="Carlito" pitchFamily="34" charset="-120"/>
+                <a:latin typeface="Inter" pitchFamily="34" charset="0"/>
+                <a:ea typeface="Inter" pitchFamily="34" charset="-122"/>
+                <a:cs typeface="Inter" pitchFamily="34" charset="-120"/>
               </a:rPr>
               <a:t>Disabled — прозрачность 50%, отсутствие реакции на клик. Focus — двойная обводка цвета #5ECEC1 для доступности с клавиатуры.</a:t>
             </a:r>
@@ -4895,9 +4907,9 @@
                 <a:solidFill>
                   <a:srgbClr val="8B95A7"/>
                 </a:solidFill>
-                <a:latin typeface="Carlito" pitchFamily="34" charset="0"/>
-                <a:ea typeface="Carlito" pitchFamily="34" charset="-122"/>
-                <a:cs typeface="Carlito" pitchFamily="34" charset="-120"/>
+                <a:latin typeface="Inter" pitchFamily="34" charset="0"/>
+                <a:ea typeface="Inter" pitchFamily="34" charset="-122"/>
+                <a:cs typeface="Inter" pitchFamily="34" charset="-120"/>
               </a:rPr>
               <a:t>ТЕНИ</a:t>
             </a:r>
@@ -4914,7 +4926,7 @@
         <p:spPr>
           <a:xfrm>
             <a:off x="5476801" y="3356817"/>
-            <a:ext cx="396143" cy="216027"/>
+            <a:ext cx="392906" cy="216027"/>
           </a:xfrm>
           <a:prstGeom prst="roundRect">
             <a:avLst>
@@ -4953,7 +4965,7 @@
         <p:spPr>
           <a:xfrm>
             <a:off x="5476801" y="3368390"/>
-            <a:ext cx="396143" cy="192881"/>
+            <a:ext cx="392906" cy="192881"/>
           </a:xfrm>
           <a:prstGeom prst="rect">
             <a:avLst/>
@@ -4976,9 +4988,9 @@
                 <a:solidFill>
                   <a:srgbClr val="FFFFFF"/>
                 </a:solidFill>
-                <a:latin typeface="Carlito" pitchFamily="34" charset="0"/>
-                <a:ea typeface="Carlito" pitchFamily="34" charset="-122"/>
-                <a:cs typeface="Carlito" pitchFamily="34" charset="-120"/>
+                <a:latin typeface="Inter" pitchFamily="34" charset="0"/>
+                <a:ea typeface="Inter" pitchFamily="34" charset="-122"/>
+                <a:cs typeface="Inter" pitchFamily="34" charset="-120"/>
               </a:rPr>
               <a:t>Light</a:t>
             </a:r>
@@ -4994,8 +5006,8 @@
         </p:nvSpPr>
         <p:spPr>
           <a:xfrm>
-            <a:off x="5958669" y="3356817"/>
-            <a:ext cx="386544" cy="216027"/>
+            <a:off x="5955432" y="3356817"/>
+            <a:ext cx="371475" cy="216027"/>
           </a:xfrm>
           <a:prstGeom prst="roundRect">
             <a:avLst>
@@ -5033,8 +5045,8 @@
         </p:nvSpPr>
         <p:spPr>
           <a:xfrm>
-            <a:off x="5958669" y="3368390"/>
-            <a:ext cx="386544" cy="192881"/>
+            <a:off x="5955432" y="3368390"/>
+            <a:ext cx="371475" cy="192881"/>
           </a:xfrm>
           <a:prstGeom prst="rect">
             <a:avLst/>
@@ -5057,9 +5069,9 @@
                 <a:solidFill>
                   <a:srgbClr val="FFFFFF"/>
                 </a:solidFill>
-                <a:latin typeface="Carlito" pitchFamily="34" charset="0"/>
-                <a:ea typeface="Carlito" pitchFamily="34" charset="-122"/>
-                <a:cs typeface="Carlito" pitchFamily="34" charset="-120"/>
+                <a:latin typeface="Inter" pitchFamily="34" charset="0"/>
+                <a:ea typeface="Inter" pitchFamily="34" charset="-122"/>
+                <a:cs typeface="Inter" pitchFamily="34" charset="-120"/>
               </a:rPr>
               <a:t>Dark</a:t>
             </a:r>
@@ -5099,9 +5111,9 @@
                 <a:solidFill>
                   <a:srgbClr val="4A5468"/>
                 </a:solidFill>
-                <a:latin typeface="Carlito" pitchFamily="34" charset="0"/>
-                <a:ea typeface="Carlito" pitchFamily="34" charset="-122"/>
-                <a:cs typeface="Carlito" pitchFamily="34" charset="-120"/>
+                <a:latin typeface="Inter" pitchFamily="34" charset="0"/>
+                <a:ea typeface="Inter" pitchFamily="34" charset="-122"/>
+                <a:cs typeface="Inter" pitchFamily="34" charset="-120"/>
               </a:rPr>
               <a:t>Светлая — мягкие тени 0px 4px 12px rgba(0,0,0,0.05). Тёмная — плотные чёрные тени или отсутствие теней с усилением эффекта освещения кнопки.</a:t>
             </a:r>
@@ -5118,7 +5130,7 @@
         <p:spPr>
           <a:xfrm>
             <a:off x="257175" y="200025"/>
-            <a:ext cx="2478848" cy="169999"/>
+            <a:ext cx="2232826" cy="169999"/>
           </a:xfrm>
           <a:prstGeom prst="rect">
             <a:avLst/>
@@ -5141,9 +5153,9 @@
                 <a:solidFill>
                   <a:srgbClr val="8B95A7"/>
                 </a:solidFill>
-                <a:latin typeface="Carlito" pitchFamily="34" charset="0"/>
-                <a:ea typeface="Carlito" pitchFamily="34" charset="-122"/>
-                <a:cs typeface="Carlito" pitchFamily="34" charset="-120"/>
+                <a:latin typeface="Inter" pitchFamily="34" charset="0"/>
+                <a:ea typeface="Inter" pitchFamily="34" charset="-122"/>
+                <a:cs typeface="Inter" pitchFamily="34" charset="-120"/>
               </a:rPr>
               <a:t>МИС АЛЬТЕРА · BRAND BOOK</a:t>
             </a:r>
@@ -5159,8 +5171,8 @@
         </p:nvSpPr>
         <p:spPr>
           <a:xfrm>
-            <a:off x="8508095" y="4799595"/>
-            <a:ext cx="542768" cy="169999"/>
+            <a:off x="8572204" y="4799595"/>
+            <a:ext cx="453969" cy="169999"/>
           </a:xfrm>
           <a:prstGeom prst="rect">
             <a:avLst/>
@@ -5285,7 +5297,7 @@
       </p:sp>
       <p:pic>
         <p:nvPicPr>
-          <p:cNvPr id="4" name="Image 1" descr="/tmp/h2p-svg-1786014518137-xrn8kb.png">    </p:cNvPr>
+          <p:cNvPr id="4" name="Image 1" descr="/tmp/h2p-svg-1786015136546-ku8qn5.png">    </p:cNvPr>
           <p:cNvPicPr>
             <a:picLocks noChangeAspect="1"/>
           </p:cNvPicPr>
@@ -5339,9 +5351,9 @@
                 <a:solidFill>
                   <a:srgbClr val="C9A96E"/>
                 </a:solidFill>
-                <a:latin typeface="Carlito" pitchFamily="34" charset="0"/>
-                <a:ea typeface="Carlito" pitchFamily="34" charset="-122"/>
-                <a:cs typeface="Carlito" pitchFamily="34" charset="-120"/>
+                <a:latin typeface="Inter" pitchFamily="34" charset="0"/>
+                <a:ea typeface="Inter" pitchFamily="34" charset="-122"/>
+                <a:cs typeface="Inter" pitchFamily="34" charset="-120"/>
               </a:rPr>
               <a:t>12 — UI KIT · ДАННЫЕ</a:t>
             </a:r>
@@ -5381,9 +5393,9 @@
                 <a:solidFill>
                   <a:srgbClr val="FFFFFF"/>
                 </a:solidFill>
-                <a:latin typeface="Tinos" pitchFamily="34" charset="0"/>
-                <a:ea typeface="Tinos" pitchFamily="34" charset="-122"/>
-                <a:cs typeface="Tinos" pitchFamily="34" charset="-120"/>
+                <a:latin typeface="Playfair Display" pitchFamily="34" charset="0"/>
+                <a:ea typeface="Playfair Display" pitchFamily="34" charset="-122"/>
+                <a:cs typeface="Playfair Display" pitchFamily="34" charset="-120"/>
               </a:rPr>
               <a:t>Визуализация медицинских данных.</a:t>
             </a:r>
@@ -5423,9 +5435,9 @@
                 <a:solidFill>
                   <a:srgbClr val="B5BECB"/>
                 </a:solidFill>
-                <a:latin typeface="Carlito" pitchFamily="34" charset="0"/>
-                <a:ea typeface="Carlito" pitchFamily="34" charset="-122"/>
-                <a:cs typeface="Carlito" pitchFamily="34" charset="-120"/>
+                <a:latin typeface="Inter" pitchFamily="34" charset="0"/>
+                <a:ea typeface="Inter" pitchFamily="34" charset="-122"/>
+                <a:cs typeface="Inter" pitchFamily="34" charset="-120"/>
               </a:rPr>
               <a:t>В МИС очень много цифр. Они должны быть строгими, без кислотных цветов. Графики — с лёгким эффектом фосфоресценции в тёмной теме.</a:t>
             </a:r>
@@ -5504,9 +5516,9 @@
                 <a:solidFill>
                   <a:srgbClr val="B5BECB"/>
                 </a:solidFill>
-                <a:latin typeface="Carlito" pitchFamily="34" charset="0"/>
-                <a:ea typeface="Carlito" pitchFamily="34" charset="-122"/>
-                <a:cs typeface="Carlito" pitchFamily="34" charset="-120"/>
+                <a:latin typeface="Inter" pitchFamily="34" charset="0"/>
+                <a:ea typeface="Inter" pitchFamily="34" charset="-122"/>
+                <a:cs typeface="Inter" pitchFamily="34" charset="-120"/>
               </a:rPr>
               <a:t>ДИНАМИКА ПОСТУПЛЕНИЙ · 30 ДНЕЙ</a:t>
             </a:r>
@@ -5555,7 +5567,7 @@
         <p:spPr>
           <a:xfrm>
             <a:off x="628650" y="1826902"/>
-            <a:ext cx="752869" cy="170047"/>
+            <a:ext cx="703288" cy="170047"/>
           </a:xfrm>
           <a:prstGeom prst="rect">
             <a:avLst/>
@@ -5578,9 +5590,9 @@
                 <a:solidFill>
                   <a:srgbClr val="C9D2DE"/>
                 </a:solidFill>
-                <a:latin typeface="Carlito" pitchFamily="34" charset="0"/>
-                <a:ea typeface="Carlito" pitchFamily="34" charset="-122"/>
-                <a:cs typeface="Carlito" pitchFamily="34" charset="-120"/>
+                <a:latin typeface="Inter" pitchFamily="34" charset="0"/>
+                <a:ea typeface="Inter" pitchFamily="34" charset="-122"/>
+                <a:cs typeface="Inter" pitchFamily="34" charset="-120"/>
               </a:rPr>
               <a:t>Поступления</a:t>
             </a:r>
@@ -5596,7 +5608,7 @@
         </p:nvSpPr>
         <p:spPr>
           <a:xfrm>
-            <a:off x="1399617" y="1855477"/>
+            <a:off x="1357313" y="1855477"/>
             <a:ext cx="57150" cy="57150"/>
           </a:xfrm>
           <a:prstGeom prst="roundRect">
@@ -5628,8 +5640,8 @@
         </p:nvSpPr>
         <p:spPr>
           <a:xfrm>
-            <a:off x="1399617" y="1826902"/>
-            <a:ext cx="589074" cy="170047"/>
+            <a:off x="1357313" y="1826902"/>
+            <a:ext cx="557784" cy="170047"/>
           </a:xfrm>
           <a:prstGeom prst="rect">
             <a:avLst/>
@@ -5652,9 +5664,9 @@
                 <a:solidFill>
                   <a:srgbClr val="C9D2DE"/>
                 </a:solidFill>
-                <a:latin typeface="Carlito" pitchFamily="34" charset="0"/>
-                <a:ea typeface="Carlito" pitchFamily="34" charset="-122"/>
-                <a:cs typeface="Carlito" pitchFamily="34" charset="-120"/>
+                <a:latin typeface="Inter" pitchFamily="34" charset="0"/>
+                <a:ea typeface="Inter" pitchFamily="34" charset="-122"/>
+                <a:cs typeface="Inter" pitchFamily="34" charset="-120"/>
               </a:rPr>
               <a:t>Выписки</a:t>
             </a:r>
@@ -5670,7 +5682,7 @@
         </p:nvSpPr>
         <p:spPr>
           <a:xfrm>
-            <a:off x="1988418" y="1855477"/>
+            <a:off x="1921669" y="1855477"/>
             <a:ext cx="57150" cy="57150"/>
           </a:xfrm>
           <a:prstGeom prst="roundRect">
@@ -5702,8 +5714,8 @@
         </p:nvSpPr>
         <p:spPr>
           <a:xfrm>
-            <a:off x="1988418" y="1826902"/>
-            <a:ext cx="882250" cy="170047"/>
+            <a:off x="1921669" y="1826902"/>
+            <a:ext cx="837248" cy="170047"/>
           </a:xfrm>
           <a:prstGeom prst="rect">
             <a:avLst/>
@@ -5726,9 +5738,9 @@
                 <a:solidFill>
                   <a:srgbClr val="C9D2DE"/>
                 </a:solidFill>
-                <a:latin typeface="Carlito" pitchFamily="34" charset="0"/>
-                <a:ea typeface="Carlito" pitchFamily="34" charset="-122"/>
-                <a:cs typeface="Carlito" pitchFamily="34" charset="-120"/>
+                <a:latin typeface="Inter" pitchFamily="34" charset="0"/>
+                <a:ea typeface="Inter" pitchFamily="34" charset="-122"/>
+                <a:cs typeface="Inter" pitchFamily="34" charset="-120"/>
               </a:rPr>
               <a:t>Выздоровления</a:t>
             </a:r>
@@ -5744,7 +5756,7 @@
         </p:nvSpPr>
         <p:spPr>
           <a:xfrm>
-            <a:off x="2869778" y="1855477"/>
+            <a:off x="2764631" y="1855477"/>
             <a:ext cx="57150" cy="57150"/>
           </a:xfrm>
           <a:prstGeom prst="roundRect">
@@ -5776,8 +5788,8 @@
         </p:nvSpPr>
         <p:spPr>
           <a:xfrm>
-            <a:off x="2869778" y="1826902"/>
-            <a:ext cx="2133191" cy="170047"/>
+            <a:off x="2764631" y="1826902"/>
+            <a:ext cx="2238338" cy="170047"/>
           </a:xfrm>
           <a:prstGeom prst="rect">
             <a:avLst/>
@@ -5800,9 +5812,9 @@
                 <a:solidFill>
                   <a:srgbClr val="C9D2DE"/>
                 </a:solidFill>
-                <a:latin typeface="Carlito" pitchFamily="34" charset="0"/>
-                <a:ea typeface="Carlito" pitchFamily="34" charset="-122"/>
-                <a:cs typeface="Carlito" pitchFamily="34" charset="-120"/>
+                <a:latin typeface="Inter" pitchFamily="34" charset="0"/>
+                <a:ea typeface="Inter" pitchFamily="34" charset="-122"/>
+                <a:cs typeface="Inter" pitchFamily="34" charset="-120"/>
               </a:rPr>
               <a:t>Премиум-показатель</a:t>
             </a:r>
@@ -5843,7 +5855,7 @@
         <p:spPr>
           <a:xfrm>
             <a:off x="628650" y="3890107"/>
-            <a:ext cx="867787" cy="158306"/>
+            <a:ext cx="800100" cy="158306"/>
           </a:xfrm>
           <a:prstGeom prst="rect">
             <a:avLst/>
@@ -5886,8 +5898,8 @@
         </p:nvSpPr>
         <p:spPr>
           <a:xfrm>
-            <a:off x="628650" y="4075844"/>
-            <a:ext cx="635654" cy="121779"/>
+            <a:off x="607184" y="4075844"/>
+            <a:ext cx="629006" cy="121779"/>
           </a:xfrm>
           <a:prstGeom prst="rect">
             <a:avLst/>
@@ -5910,9 +5922,9 @@
                 <a:solidFill>
                   <a:srgbClr val="9CA9BC"/>
                 </a:solidFill>
-                <a:latin typeface="Carlito" pitchFamily="34" charset="0"/>
-                <a:ea typeface="Carlito" pitchFamily="34" charset="-122"/>
-                <a:cs typeface="Carlito" pitchFamily="34" charset="-120"/>
+                <a:latin typeface="Inter" pitchFamily="34" charset="0"/>
+                <a:ea typeface="Inter" pitchFamily="34" charset="-122"/>
+                <a:cs typeface="Inter" pitchFamily="34" charset="-120"/>
               </a:rPr>
               <a:t>Поступления</a:t>
             </a:r>
@@ -5928,8 +5940,8 @@
         </p:nvSpPr>
         <p:spPr>
           <a:xfrm>
-            <a:off x="1342467" y="3890107"/>
-            <a:ext cx="787420" cy="158306"/>
+            <a:off x="1300163" y="3890107"/>
+            <a:ext cx="605790" cy="158306"/>
           </a:xfrm>
           <a:prstGeom prst="rect">
             <a:avLst/>
@@ -5972,8 +5984,8 @@
         </p:nvSpPr>
         <p:spPr>
           <a:xfrm>
-            <a:off x="1342467" y="4075844"/>
-            <a:ext cx="629936" cy="121779"/>
+            <a:off x="1300163" y="4075844"/>
+            <a:ext cx="484632" cy="121779"/>
           </a:xfrm>
           <a:prstGeom prst="rect">
             <a:avLst/>
@@ -5996,9 +6008,9 @@
                 <a:solidFill>
                   <a:srgbClr val="9CA9BC"/>
                 </a:solidFill>
-                <a:latin typeface="Carlito" pitchFamily="34" charset="0"/>
-                <a:ea typeface="Carlito" pitchFamily="34" charset="-122"/>
-                <a:cs typeface="Carlito" pitchFamily="34" charset="-120"/>
+                <a:latin typeface="Inter" pitchFamily="34" charset="0"/>
+                <a:ea typeface="Inter" pitchFamily="34" charset="-122"/>
+                <a:cs typeface="Inter" pitchFamily="34" charset="-120"/>
               </a:rPr>
               <a:t>Выписки</a:t>
             </a:r>
@@ -6014,8 +6026,8 @@
         </p:nvSpPr>
         <p:spPr>
           <a:xfrm>
-            <a:off x="2006054" y="3890107"/>
-            <a:ext cx="1044416" cy="158306"/>
+            <a:off x="1850231" y="3890107"/>
+            <a:ext cx="982980" cy="158306"/>
           </a:xfrm>
           <a:prstGeom prst="rect">
             <a:avLst/>
@@ -6058,8 +6070,8 @@
         </p:nvSpPr>
         <p:spPr>
           <a:xfrm>
-            <a:off x="2006054" y="4075844"/>
-            <a:ext cx="765035" cy="121779"/>
+            <a:off x="1850231" y="4075844"/>
+            <a:ext cx="720033" cy="121779"/>
           </a:xfrm>
           <a:prstGeom prst="rect">
             <a:avLst/>
@@ -6082,9 +6094,9 @@
                 <a:solidFill>
                   <a:srgbClr val="9CA9BC"/>
                 </a:solidFill>
-                <a:latin typeface="Carlito" pitchFamily="34" charset="0"/>
-                <a:ea typeface="Carlito" pitchFamily="34" charset="-122"/>
-                <a:cs typeface="Carlito" pitchFamily="34" charset="-120"/>
+                <a:latin typeface="Inter" pitchFamily="34" charset="0"/>
+                <a:ea typeface="Inter" pitchFamily="34" charset="-122"/>
+                <a:cs typeface="Inter" pitchFamily="34" charset="-120"/>
               </a:rPr>
               <a:t>Выздоровления</a:t>
             </a:r>
@@ -6100,8 +6112,8 @@
         </p:nvSpPr>
         <p:spPr>
           <a:xfrm>
-            <a:off x="2830264" y="3890107"/>
-            <a:ext cx="1060847" cy="158306"/>
+            <a:off x="2636044" y="3890107"/>
+            <a:ext cx="971550" cy="158306"/>
           </a:xfrm>
           <a:prstGeom prst="rect">
             <a:avLst/>
@@ -6144,8 +6156,8 @@
         </p:nvSpPr>
         <p:spPr>
           <a:xfrm>
-            <a:off x="2830264" y="4075844"/>
-            <a:ext cx="777070" cy="121779"/>
+            <a:off x="2636044" y="4075844"/>
+            <a:ext cx="711660" cy="121779"/>
           </a:xfrm>
           <a:prstGeom prst="rect">
             <a:avLst/>
@@ -6168,9 +6180,9 @@
                 <a:solidFill>
                   <a:srgbClr val="9CA9BC"/>
                 </a:solidFill>
-                <a:latin typeface="Carlito" pitchFamily="34" charset="0"/>
-                <a:ea typeface="Carlito" pitchFamily="34" charset="-122"/>
-                <a:cs typeface="Carlito" pitchFamily="34" charset="-120"/>
+                <a:latin typeface="Inter" pitchFamily="34" charset="0"/>
+                <a:ea typeface="Inter" pitchFamily="34" charset="-122"/>
+                <a:cs typeface="Inter" pitchFamily="34" charset="-120"/>
               </a:rPr>
               <a:t>Эффективность</a:t>
             </a:r>
@@ -6249,9 +6261,9 @@
                 <a:solidFill>
                   <a:srgbClr val="FFFFFF"/>
                 </a:solidFill>
-                <a:latin typeface="Carlito" pitchFamily="34" charset="0"/>
-                <a:ea typeface="Carlito" pitchFamily="34" charset="-122"/>
-                <a:cs typeface="Carlito" pitchFamily="34" charset="-120"/>
+                <a:latin typeface="Inter" pitchFamily="34" charset="0"/>
+                <a:ea typeface="Inter" pitchFamily="34" charset="-122"/>
+                <a:cs typeface="Inter" pitchFamily="34" charset="-120"/>
               </a:rPr>
               <a:t>Правила для графиков</a:t>
             </a:r>
@@ -6321,9 +6333,9 @@
                 <a:solidFill>
                   <a:srgbClr val="C9D2DE"/>
                 </a:solidFill>
-                <a:latin typeface="Carlito" pitchFamily="34" charset="0"/>
-                <a:ea typeface="Carlito" pitchFamily="34" charset="-122"/>
-                <a:cs typeface="Carlito" pitchFamily="34" charset="-120"/>
+                <a:latin typeface="Inter" pitchFamily="34" charset="0"/>
+                <a:ea typeface="Inter" pitchFamily="34" charset="-122"/>
+                <a:cs typeface="Inter" pitchFamily="34" charset="-120"/>
               </a:rPr>
               <a:t>Толщина линии — не более 2 пикселей.</a:t>
             </a:r>
@@ -6393,9 +6405,9 @@
                 <a:solidFill>
                   <a:srgbClr val="C9D2DE"/>
                 </a:solidFill>
-                <a:latin typeface="Carlito" pitchFamily="34" charset="0"/>
-                <a:ea typeface="Carlito" pitchFamily="34" charset="-122"/>
-                <a:cs typeface="Carlito" pitchFamily="34" charset="-120"/>
+                <a:latin typeface="Inter" pitchFamily="34" charset="0"/>
+                <a:ea typeface="Inter" pitchFamily="34" charset="-122"/>
+                <a:cs typeface="Inter" pitchFamily="34" charset="-120"/>
               </a:rPr>
               <a:t>Цвета — только из палитры: Tiffany, Info, Success, Gold.</a:t>
             </a:r>
@@ -6442,7 +6454,7 @@
         <p:spPr>
           <a:xfrm>
             <a:off x="5588757" y="2211884"/>
-            <a:ext cx="2940769" cy="372904"/>
+            <a:ext cx="2940769" cy="186452"/>
           </a:xfrm>
           <a:prstGeom prst="rect">
             <a:avLst/>
@@ -6461,17 +6473,17 @@
               <a:buNone/>
             </a:pPr>
             <a:r>
-              <a:rPr lang="en-US" sz="800" dirty="0">
+              <a:rPr lang="en-US" sz="675" dirty="0">
                 <a:solidFill>
                   <a:srgbClr val="C9D2DE"/>
                 </a:solidFill>
-                <a:latin typeface="Carlito" pitchFamily="34" charset="0"/>
-                <a:ea typeface="Carlito" pitchFamily="34" charset="-122"/>
-                <a:cs typeface="Carlito" pitchFamily="34" charset="-120"/>
+                <a:latin typeface="Inter" pitchFamily="34" charset="0"/>
+                <a:ea typeface="Inter" pitchFamily="34" charset="-122"/>
+                <a:cs typeface="Inter" pitchFamily="34" charset="-120"/>
               </a:rPr>
               <a:t>Свечение в тёмной теме — микроподсветка снизу для читаемости.</a:t>
             </a:r>
-            <a:endParaRPr lang="en-US" sz="800" dirty="0"/>
+            <a:endParaRPr lang="en-US" sz="675" dirty="0"/>
           </a:p>
         </p:txBody>
       </p:sp>
@@ -6483,7 +6495,7 @@
         </p:nvSpPr>
         <p:spPr>
           <a:xfrm>
-            <a:off x="5474457" y="2596083"/>
+            <a:off x="5474457" y="2450418"/>
             <a:ext cx="42863" cy="42863"/>
           </a:xfrm>
           <a:prstGeom prst="ellipse">
@@ -6513,8 +6525,8 @@
         </p:nvSpPr>
         <p:spPr>
           <a:xfrm>
-            <a:off x="5588757" y="2546077"/>
-            <a:ext cx="2940769" cy="144214"/>
+            <a:off x="5588757" y="2400412"/>
+            <a:ext cx="2940769" cy="186452"/>
           </a:xfrm>
           <a:prstGeom prst="rect">
             <a:avLst/>
@@ -6537,9 +6549,9 @@
                 <a:solidFill>
                   <a:srgbClr val="C9D2DE"/>
                 </a:solidFill>
-                <a:latin typeface="Carlito" pitchFamily="34" charset="0"/>
-                <a:ea typeface="Carlito" pitchFamily="34" charset="-122"/>
-                <a:cs typeface="Carlito" pitchFamily="34" charset="-120"/>
+                <a:latin typeface="Inter" pitchFamily="34" charset="0"/>
+                <a:ea typeface="Inter" pitchFamily="34" charset="-122"/>
+                <a:cs typeface="Inter" pitchFamily="34" charset="-120"/>
               </a:rPr>
               <a:t>Никаких кислотных и нестандартных оттенков.</a:t>
             </a:r>
@@ -6618,9 +6630,9 @@
                 <a:solidFill>
                   <a:srgbClr val="FFFFFF"/>
                 </a:solidFill>
-                <a:latin typeface="Carlito" pitchFamily="34" charset="0"/>
-                <a:ea typeface="Carlito" pitchFamily="34" charset="-122"/>
-                <a:cs typeface="Carlito" pitchFamily="34" charset="-120"/>
+                <a:latin typeface="Inter" pitchFamily="34" charset="0"/>
+                <a:ea typeface="Inter" pitchFamily="34" charset="-122"/>
+                <a:cs typeface="Inter" pitchFamily="34" charset="-120"/>
               </a:rPr>
               <a:t>Иконки (Line Art)</a:t>
             </a:r>
@@ -7128,9 +7140,9 @@
                 <a:solidFill>
                   <a:srgbClr val="9CA9BC"/>
                 </a:solidFill>
-                <a:latin typeface="Carlito" pitchFamily="34" charset="0"/>
-                <a:ea typeface="Carlito" pitchFamily="34" charset="-122"/>
-                <a:cs typeface="Carlito" pitchFamily="34" charset="-120"/>
+                <a:latin typeface="Inter" pitchFamily="34" charset="0"/>
+                <a:ea typeface="Inter" pitchFamily="34" charset="-122"/>
+                <a:cs typeface="Inter" pitchFamily="34" charset="-120"/>
               </a:rPr>
               <a:t>Толщина штриха 1.5–2px. Скруглённые концы и стыки (Round caps). Полное отсутствие острых углов в микро-графике.</a:t>
             </a:r>
@@ -7147,7 +7159,7 @@
         <p:spPr>
           <a:xfrm>
             <a:off x="257175" y="200025"/>
-            <a:ext cx="2478848" cy="169999"/>
+            <a:ext cx="2232826" cy="169999"/>
           </a:xfrm>
           <a:prstGeom prst="rect">
             <a:avLst/>
@@ -7170,9 +7182,9 @@
                 <a:solidFill>
                   <a:srgbClr val="9CA9BC"/>
                 </a:solidFill>
-                <a:latin typeface="Carlito" pitchFamily="34" charset="0"/>
-                <a:ea typeface="Carlito" pitchFamily="34" charset="-122"/>
-                <a:cs typeface="Carlito" pitchFamily="34" charset="-120"/>
+                <a:latin typeface="Inter" pitchFamily="34" charset="0"/>
+                <a:ea typeface="Inter" pitchFamily="34" charset="-122"/>
+                <a:cs typeface="Inter" pitchFamily="34" charset="-120"/>
               </a:rPr>
               <a:t>МИС АЛЬТЕРА · BRAND BOOK</a:t>
             </a:r>
@@ -7188,8 +7200,8 @@
         </p:nvSpPr>
         <p:spPr>
           <a:xfrm>
-            <a:off x="8508095" y="4799595"/>
-            <a:ext cx="542768" cy="169999"/>
+            <a:off x="8556203" y="4799595"/>
+            <a:ext cx="473822" cy="169999"/>
           </a:xfrm>
           <a:prstGeom prst="rect">
             <a:avLst/>
@@ -7386,9 +7398,9 @@
                 <a:solidFill>
                   <a:srgbClr val="1A1F2E"/>
                 </a:solidFill>
-                <a:latin typeface="Tinos" pitchFamily="34" charset="0"/>
-                <a:ea typeface="Tinos" pitchFamily="34" charset="-122"/>
-                <a:cs typeface="Tinos" pitchFamily="34" charset="-120"/>
+                <a:latin typeface="Playfair Display" pitchFamily="34" charset="0"/>
+                <a:ea typeface="Playfair Display" pitchFamily="34" charset="-122"/>
+                <a:cs typeface="Playfair Display" pitchFamily="34" charset="-120"/>
               </a:rPr>
               <a:t>Голос бренда и Tone of Voice.</a:t>
             </a:r>
@@ -7428,9 +7440,9 @@
                 <a:solidFill>
                   <a:srgbClr val="4A5468"/>
                 </a:solidFill>
-                <a:latin typeface="Carlito" pitchFamily="34" charset="0"/>
-                <a:ea typeface="Carlito" pitchFamily="34" charset="-122"/>
-                <a:cs typeface="Carlito" pitchFamily="34" charset="-120"/>
+                <a:latin typeface="Inter" pitchFamily="34" charset="0"/>
+                <a:ea typeface="Inter" pitchFamily="34" charset="-122"/>
+                <a:cs typeface="Inter" pitchFamily="34" charset="-120"/>
               </a:rPr>
               <a:t>Общение с врачом на равных. Уважение к профессионализму, без излишней формальности и бюрократизма.</a:t>
             </a:r>
@@ -7575,9 +7587,9 @@
                 <a:solidFill>
                   <a:srgbClr val="1A1F2E"/>
                 </a:solidFill>
-                <a:latin typeface="Carlito" pitchFamily="34" charset="0"/>
-                <a:ea typeface="Carlito" pitchFamily="34" charset="-122"/>
-                <a:cs typeface="Carlito" pitchFamily="34" charset="-120"/>
+                <a:latin typeface="Inter" pitchFamily="34" charset="0"/>
+                <a:ea typeface="Inter" pitchFamily="34" charset="-122"/>
+                <a:cs typeface="Inter" pitchFamily="34" charset="-120"/>
               </a:rPr>
               <a:t>На Вы</a:t>
             </a:r>
@@ -7617,9 +7629,9 @@
                 <a:solidFill>
                   <a:srgbClr val="4A5468"/>
                 </a:solidFill>
-                <a:latin typeface="Carlito" pitchFamily="34" charset="0"/>
-                <a:ea typeface="Carlito" pitchFamily="34" charset="-122"/>
-                <a:cs typeface="Carlito" pitchFamily="34" charset="-120"/>
+                <a:latin typeface="Inter" pitchFamily="34" charset="0"/>
+                <a:ea typeface="Inter" pitchFamily="34" charset="-122"/>
+                <a:cs typeface="Inter" pitchFamily="34" charset="-120"/>
               </a:rPr>
               <a:t>Только уважительное обращение. Без панибратства.</a:t>
             </a:r>
@@ -7764,9 +7776,9 @@
                 <a:solidFill>
                   <a:srgbClr val="1A1F2E"/>
                 </a:solidFill>
-                <a:latin typeface="Carlito" pitchFamily="34" charset="0"/>
-                <a:ea typeface="Carlito" pitchFamily="34" charset="-122"/>
-                <a:cs typeface="Carlito" pitchFamily="34" charset="-120"/>
+                <a:latin typeface="Inter" pitchFamily="34" charset="0"/>
+                <a:ea typeface="Inter" pitchFamily="34" charset="-122"/>
+                <a:cs typeface="Inter" pitchFamily="34" charset="-120"/>
               </a:rPr>
               <a:t>На равных</a:t>
             </a:r>
@@ -7806,9 +7818,9 @@
                 <a:solidFill>
                   <a:srgbClr val="4A5468"/>
                 </a:solidFill>
-                <a:latin typeface="Carlito" pitchFamily="34" charset="0"/>
-                <a:ea typeface="Carlito" pitchFamily="34" charset="-122"/>
-                <a:cs typeface="Carlito" pitchFamily="34" charset="-120"/>
+                <a:latin typeface="Inter" pitchFamily="34" charset="0"/>
+                <a:ea typeface="Inter" pitchFamily="34" charset="-122"/>
+                <a:cs typeface="Inter" pitchFamily="34" charset="-120"/>
               </a:rPr>
               <a:t>Не даём инструкции — просим помощи. Коллеги, а не пользователи.</a:t>
             </a:r>
@@ -7953,9 +7965,9 @@
                 <a:solidFill>
                   <a:srgbClr val="1A1F2E"/>
                 </a:solidFill>
-                <a:latin typeface="Carlito" pitchFamily="34" charset="0"/>
-                <a:ea typeface="Carlito" pitchFamily="34" charset="-122"/>
-                <a:cs typeface="Carlito" pitchFamily="34" charset="-120"/>
+                <a:latin typeface="Inter" pitchFamily="34" charset="0"/>
+                <a:ea typeface="Inter" pitchFamily="34" charset="-122"/>
+                <a:cs typeface="Inter" pitchFamily="34" charset="-120"/>
               </a:rPr>
               <a:t>Простота</a:t>
             </a:r>
@@ -7995,9 +8007,9 @@
                 <a:solidFill>
                   <a:srgbClr val="4A5468"/>
                 </a:solidFill>
-                <a:latin typeface="Carlito" pitchFamily="34" charset="0"/>
-                <a:ea typeface="Carlito" pitchFamily="34" charset="-122"/>
-                <a:cs typeface="Carlito" pitchFamily="34" charset="-120"/>
+                <a:latin typeface="Inter" pitchFamily="34" charset="0"/>
+                <a:ea typeface="Inter" pitchFamily="34" charset="-122"/>
+                <a:cs typeface="Inter" pitchFamily="34" charset="-120"/>
               </a:rPr>
               <a:t>Без сложных аббревиатур. Одно предложение — одна мысль.</a:t>
             </a:r>
@@ -8142,9 +8154,9 @@
                 <a:solidFill>
                   <a:srgbClr val="1A1F2E"/>
                 </a:solidFill>
-                <a:latin typeface="Carlito" pitchFamily="34" charset="0"/>
-                <a:ea typeface="Carlito" pitchFamily="34" charset="-122"/>
-                <a:cs typeface="Carlito" pitchFamily="34" charset="-120"/>
+                <a:latin typeface="Inter" pitchFamily="34" charset="0"/>
+                <a:ea typeface="Inter" pitchFamily="34" charset="-122"/>
+                <a:cs typeface="Inter" pitchFamily="34" charset="-120"/>
               </a:rPr>
               <a:t>Без паники</a:t>
             </a:r>
@@ -8184,9 +8196,9 @@
                 <a:solidFill>
                   <a:srgbClr val="4A5468"/>
                 </a:solidFill>
-                <a:latin typeface="Carlito" pitchFamily="34" charset="0"/>
-                <a:ea typeface="Carlito" pitchFamily="34" charset="-122"/>
-                <a:cs typeface="Carlito" pitchFamily="34" charset="-120"/>
+                <a:latin typeface="Inter" pitchFamily="34" charset="0"/>
+                <a:ea typeface="Inter" pitchFamily="34" charset="-122"/>
+                <a:cs typeface="Inter" pitchFamily="34" charset="-120"/>
               </a:rPr>
               <a:t>Не пишем «Ошибка!». Пишем «Что-то пошло не так. Проверьте соединение.»</a:t>
             </a:r>
@@ -8242,7 +8254,7 @@
         <p:spPr>
           <a:xfrm>
             <a:off x="714375" y="2515605"/>
-            <a:ext cx="394335" cy="432054"/>
+            <a:ext cx="462058" cy="432054"/>
           </a:xfrm>
           <a:prstGeom prst="rect">
             <a:avLst/>
@@ -8267,9 +8279,9 @@
                     <a:alpha val="40000"/>
                   </a:srgbClr>
                 </a:solidFill>
-                <a:latin typeface="Tinos" pitchFamily="34" charset="0"/>
-                <a:ea typeface="Tinos" pitchFamily="34" charset="-122"/>
-                <a:cs typeface="Tinos" pitchFamily="34" charset="-120"/>
+                <a:latin typeface="Playfair Display" pitchFamily="34" charset="0"/>
+                <a:ea typeface="Playfair Display" pitchFamily="34" charset="-122"/>
+                <a:cs typeface="Playfair Display" pitchFamily="34" charset="-120"/>
               </a:rPr>
               <a:t>«</a:t>
             </a:r>
@@ -8286,7 +8298,7 @@
         <p:spPr>
           <a:xfrm>
             <a:off x="714375" y="2629905"/>
-            <a:ext cx="6286500" cy="646393"/>
+            <a:ext cx="6286500" cy="892437"/>
           </a:xfrm>
           <a:prstGeom prst="rect">
             <a:avLst/>
@@ -8309,9 +8321,9 @@
                 <a:solidFill>
                   <a:srgbClr val="1A1F2E"/>
                 </a:solidFill>
-                <a:latin typeface="Tinos" pitchFamily="34" charset="0"/>
-                <a:ea typeface="Tinos" pitchFamily="34" charset="-122"/>
-                <a:cs typeface="Tinos" pitchFamily="34" charset="-120"/>
+                <a:latin typeface="Playfair Display" pitchFamily="34" charset="0"/>
+                <a:ea typeface="Playfair Display" pitchFamily="34" charset="-122"/>
+                <a:cs typeface="Playfair Display" pitchFamily="34" charset="-120"/>
               </a:rPr>
               <a:t>Коллеги, нам очень нужна ваша помощь. Мы создаём новую систему взамен устаревшей — понятную, логичную и действительно помогающую в работе.</a:t>
             </a:r>
@@ -8327,8 +8339,8 @@
         </p:nvSpPr>
         <p:spPr>
           <a:xfrm>
-            <a:off x="6566557" y="3657600"/>
-            <a:ext cx="1972796" cy="91440"/>
+            <a:off x="6672263" y="3657600"/>
+            <a:ext cx="1862804" cy="91440"/>
           </a:xfrm>
           <a:prstGeom prst="rect">
             <a:avLst/>
@@ -8351,9 +8363,9 @@
                 <a:solidFill>
                   <a:srgbClr val="8B95A7"/>
                 </a:solidFill>
-                <a:latin typeface="Carlito" pitchFamily="34" charset="0"/>
-                <a:ea typeface="Carlito" pitchFamily="34" charset="-122"/>
-                <a:cs typeface="Carlito" pitchFamily="34" charset="-120"/>
+                <a:latin typeface="Inter" pitchFamily="34" charset="0"/>
+                <a:ea typeface="Inter" pitchFamily="34" charset="-122"/>
+                <a:cs typeface="Inter" pitchFamily="34" charset="-120"/>
               </a:rPr>
               <a:t>— Пример тональности в интерфейсе</a:t>
             </a:r>
@@ -8370,7 +8382,7 @@
         <p:spPr>
           <a:xfrm>
             <a:off x="257175" y="200025"/>
-            <a:ext cx="2478848" cy="169999"/>
+            <a:ext cx="2232826" cy="169999"/>
           </a:xfrm>
           <a:prstGeom prst="rect">
             <a:avLst/>
@@ -8393,9 +8405,9 @@
                 <a:solidFill>
                   <a:srgbClr val="8B95A7"/>
                 </a:solidFill>
-                <a:latin typeface="Carlito" pitchFamily="34" charset="0"/>
-                <a:ea typeface="Carlito" pitchFamily="34" charset="-122"/>
-                <a:cs typeface="Carlito" pitchFamily="34" charset="-120"/>
+                <a:latin typeface="Inter" pitchFamily="34" charset="0"/>
+                <a:ea typeface="Inter" pitchFamily="34" charset="-122"/>
+                <a:cs typeface="Inter" pitchFamily="34" charset="-120"/>
               </a:rPr>
               <a:t>МИС АЛЬТЕРА · BRAND BOOK</a:t>
             </a:r>
@@ -8411,8 +8423,8 @@
         </p:nvSpPr>
         <p:spPr>
           <a:xfrm>
-            <a:off x="8508095" y="4799595"/>
-            <a:ext cx="542768" cy="169999"/>
+            <a:off x="8556203" y="4799595"/>
+            <a:ext cx="473822" cy="169999"/>
           </a:xfrm>
           <a:prstGeom prst="rect">
             <a:avLst/>
@@ -8479,7 +8491,7 @@
       </p:grpSpPr>
       <p:pic>
         <p:nvPicPr>
-          <p:cNvPr id="2" name="Image 0" descr="/tmp/h2p-fit-1786014517824-4yjs8y.png">    </p:cNvPr>
+          <p:cNvPr id="2" name="Image 0" descr="/tmp/h2p-fit-1786015136310-8mb4rb.png">    </p:cNvPr>
           <p:cNvPicPr>
             <a:picLocks noChangeAspect="1"/>
           </p:cNvPicPr>
@@ -8533,8 +8545,8 @@
         </p:nvSpPr>
         <p:spPr>
           <a:xfrm>
-            <a:off x="3897250" y="571500"/>
-            <a:ext cx="1878503" cy="170021"/>
+            <a:off x="3961209" y="571500"/>
+            <a:ext cx="1700441" cy="170021"/>
           </a:xfrm>
           <a:prstGeom prst="rect">
             <a:avLst/>
@@ -8559,9 +8571,9 @@
                     <a:alpha val="85000"/>
                   </a:srgbClr>
                 </a:solidFill>
-                <a:latin typeface="Carlito" pitchFamily="34" charset="0"/>
-                <a:ea typeface="Carlito" pitchFamily="34" charset="-122"/>
-                <a:cs typeface="Carlito" pitchFamily="34" charset="-120"/>
+                <a:latin typeface="Inter" pitchFamily="34" charset="0"/>
+                <a:ea typeface="Inter" pitchFamily="34" charset="-122"/>
+                <a:cs typeface="Inter" pitchFamily="34" charset="-120"/>
               </a:rPr>
               <a:t>14 — ЗАКЛЮЧЕНИЕ</a:t>
             </a:r>
@@ -8677,9 +8689,9 @@
                 <a:solidFill>
                   <a:srgbClr val="FFFFFF"/>
                 </a:solidFill>
-                <a:latin typeface="Tinos" pitchFamily="34" charset="0"/>
-                <a:ea typeface="Tinos" pitchFamily="34" charset="-122"/>
-                <a:cs typeface="Tinos" pitchFamily="34" charset="-120"/>
+                <a:latin typeface="Playfair Display" pitchFamily="34" charset="0"/>
+                <a:ea typeface="Playfair Display" pitchFamily="34" charset="-122"/>
+                <a:cs typeface="Playfair Display" pitchFamily="34" charset="-120"/>
               </a:rPr>
               <a:t>Спасибо за внимание!</a:t>
             </a:r>
@@ -8751,9 +8763,9 @@
                     <a:alpha val="90000"/>
                   </a:srgbClr>
                 </a:solidFill>
-                <a:latin typeface="Carlito" pitchFamily="34" charset="0"/>
-                <a:ea typeface="Carlito" pitchFamily="34" charset="-122"/>
-                <a:cs typeface="Carlito" pitchFamily="34" charset="-120"/>
+                <a:latin typeface="Inter" pitchFamily="34" charset="0"/>
+                <a:ea typeface="Inter" pitchFamily="34" charset="-122"/>
+                <a:cs typeface="Inter" pitchFamily="34" charset="-120"/>
               </a:rPr>
               <a:t>По всем вопросам о брендинге и соблюдению правил обращайтесь в отдел маркетинга и дизайна.</a:t>
             </a:r>
@@ -8769,8 +8781,8 @@
         </p:nvSpPr>
         <p:spPr>
           <a:xfrm>
-            <a:off x="3660391" y="3657488"/>
-            <a:ext cx="510064" cy="126159"/>
+            <a:off x="3714750" y="3657488"/>
+            <a:ext cx="468630" cy="126159"/>
           </a:xfrm>
           <a:prstGeom prst="rect">
             <a:avLst/>
@@ -8795,9 +8807,9 @@
                 <a:solidFill>
                   <a:srgbClr val="5ECEC1"/>
                 </a:solidFill>
-                <a:latin typeface="Carlito" pitchFamily="34" charset="0"/>
-                <a:ea typeface="Carlito" pitchFamily="34" charset="-122"/>
-                <a:cs typeface="Carlito" pitchFamily="34" charset="-120"/>
+                <a:latin typeface="Inter" pitchFamily="34" charset="0"/>
+                <a:ea typeface="Inter" pitchFamily="34" charset="-122"/>
+                <a:cs typeface="Inter" pitchFamily="34" charset="-120"/>
               </a:rPr>
               <a:t>EMAIL</a:t>
             </a:r>
@@ -8813,8 +8825,8 @@
         </p:nvSpPr>
         <p:spPr>
           <a:xfrm>
-            <a:off x="3302422" y="3811079"/>
-            <a:ext cx="1212701" cy="169980"/>
+            <a:off x="3378994" y="3811079"/>
+            <a:ext cx="1130284" cy="169980"/>
           </a:xfrm>
           <a:prstGeom prst="rect">
             <a:avLst/>
@@ -8837,9 +8849,9 @@
                 <a:solidFill>
                   <a:srgbClr val="FFFFFF"/>
                 </a:solidFill>
-                <a:latin typeface="Carlito" pitchFamily="34" charset="0"/>
-                <a:ea typeface="Carlito" pitchFamily="34" charset="-122"/>
-                <a:cs typeface="Carlito" pitchFamily="34" charset="-120"/>
+                <a:latin typeface="Inter" pitchFamily="34" charset="0"/>
+                <a:ea typeface="Inter" pitchFamily="34" charset="-122"/>
+                <a:cs typeface="Inter" pitchFamily="34" charset="-120"/>
               </a:rPr>
               <a:t>brand@altera-mis.ru</a:t>
             </a:r>
@@ -8855,8 +8867,8 @@
         </p:nvSpPr>
         <p:spPr>
           <a:xfrm>
-            <a:off x="5045050" y="3657488"/>
-            <a:ext cx="734504" cy="126159"/>
+            <a:off x="5022056" y="3657488"/>
+            <a:ext cx="700253" cy="126159"/>
           </a:xfrm>
           <a:prstGeom prst="rect">
             <a:avLst/>
@@ -8881,9 +8893,9 @@
                 <a:solidFill>
                   <a:srgbClr val="5ECEC1"/>
                 </a:solidFill>
-                <a:latin typeface="Carlito" pitchFamily="34" charset="0"/>
-                <a:ea typeface="Carlito" pitchFamily="34" charset="-122"/>
-                <a:cs typeface="Carlito" pitchFamily="34" charset="-120"/>
+                <a:latin typeface="Inter" pitchFamily="34" charset="0"/>
+                <a:ea typeface="Inter" pitchFamily="34" charset="-122"/>
+                <a:cs typeface="Inter" pitchFamily="34" charset="-120"/>
               </a:rPr>
               <a:t>INTRANET</a:t>
             </a:r>
@@ -8899,8 +8911,8 @@
         </p:nvSpPr>
         <p:spPr>
           <a:xfrm>
-            <a:off x="4765774" y="3811079"/>
-            <a:ext cx="1183262" cy="169980"/>
+            <a:off x="4772025" y="3811079"/>
+            <a:ext cx="1092279" cy="169980"/>
           </a:xfrm>
           <a:prstGeom prst="rect">
             <a:avLst/>
@@ -8923,9 +8935,9 @@
                 <a:solidFill>
                   <a:srgbClr val="FFFFFF"/>
                 </a:solidFill>
-                <a:latin typeface="Carlito" pitchFamily="34" charset="0"/>
-                <a:ea typeface="Carlito" pitchFamily="34" charset="-122"/>
-                <a:cs typeface="Carlito" pitchFamily="34" charset="-120"/>
+                <a:latin typeface="Inter" pitchFamily="34" charset="0"/>
+                <a:ea typeface="Inter" pitchFamily="34" charset="-122"/>
+                <a:cs typeface="Inter" pitchFamily="34" charset="-120"/>
               </a:rPr>
               <a:t>design.altera-internal</a:t>
             </a:r>
@@ -8967,9 +8979,9 @@
                     <a:alpha val="50000"/>
                   </a:srgbClr>
                 </a:solidFill>
-                <a:latin typeface="Carlito" pitchFamily="34" charset="0"/>
-                <a:ea typeface="Carlito" pitchFamily="34" charset="-122"/>
-                <a:cs typeface="Carlito" pitchFamily="34" charset="-120"/>
+                <a:latin typeface="Inter" pitchFamily="34" charset="0"/>
+                <a:ea typeface="Inter" pitchFamily="34" charset="-122"/>
+                <a:cs typeface="Inter" pitchFamily="34" charset="-120"/>
               </a:rPr>
               <a:t>МИС АЛЬТЕРА · БРЕНД-БУК · 2026</a:t>
             </a:r>
@@ -9099,9 +9111,9 @@
                 <a:solidFill>
                   <a:srgbClr val="46B0A3"/>
                 </a:solidFill>
-                <a:latin typeface="Carlito" pitchFamily="34" charset="0"/>
-                <a:ea typeface="Carlito" pitchFamily="34" charset="-122"/>
-                <a:cs typeface="Carlito" pitchFamily="34" charset="-120"/>
+                <a:latin typeface="Inter" pitchFamily="34" charset="0"/>
+                <a:ea typeface="Inter" pitchFamily="34" charset="-122"/>
+                <a:cs typeface="Inter" pitchFamily="34" charset="-120"/>
               </a:rPr>
               <a:t>02 — ФИЛОСОФИЯ</a:t>
             </a:r>
@@ -9141,9 +9153,9 @@
                 <a:solidFill>
                   <a:srgbClr val="1A1F2E"/>
                 </a:solidFill>
-                <a:latin typeface="Tinos" pitchFamily="34" charset="0"/>
-                <a:ea typeface="Tinos" pitchFamily="34" charset="-122"/>
-                <a:cs typeface="Tinos" pitchFamily="34" charset="-120"/>
+                <a:latin typeface="Playfair Display" pitchFamily="34" charset="0"/>
+                <a:ea typeface="Playfair Display" pitchFamily="34" charset="-122"/>
+                <a:cs typeface="Playfair Display" pitchFamily="34" charset="-120"/>
               </a:rPr>
               <a:t>Идеология бренда.</a:t>
             </a:r>
@@ -9213,9 +9225,9 @@
                 <a:solidFill>
                   <a:srgbClr val="4A5468"/>
                 </a:solidFill>
-                <a:latin typeface="Carlito" pitchFamily="34" charset="0"/>
-                <a:ea typeface="Carlito" pitchFamily="34" charset="-122"/>
-                <a:cs typeface="Carlito" pitchFamily="34" charset="-120"/>
+                <a:latin typeface="Inter" pitchFamily="34" charset="0"/>
+                <a:ea typeface="Inter" pitchFamily="34" charset="-122"/>
+                <a:cs typeface="Inter" pitchFamily="34" charset="-120"/>
               </a:rPr>
               <a:t>Медицинская Информационная Система должна быть не просто инструментом, а надёжным и спокойным помощником. Доверие к системе строится через прозрачность и интуитивность.</a:t>
             </a:r>
@@ -9255,9 +9267,9 @@
                 <a:solidFill>
                   <a:srgbClr val="8B95A7"/>
                 </a:solidFill>
-                <a:latin typeface="Carlito" pitchFamily="34" charset="0"/>
-                <a:ea typeface="Carlito" pitchFamily="34" charset="-122"/>
-                <a:cs typeface="Carlito" pitchFamily="34" charset="-120"/>
+                <a:latin typeface="Inter" pitchFamily="34" charset="0"/>
+                <a:ea typeface="Inter" pitchFamily="34" charset="-122"/>
+                <a:cs typeface="Inter" pitchFamily="34" charset="-120"/>
               </a:rPr>
               <a:t>КЛЮЧЕВЫЕ СЛОВА:</a:t>
             </a:r>
@@ -9274,7 +9286,7 @@
         <p:spPr>
           <a:xfrm>
             <a:off x="457200" y="3551595"/>
-            <a:ext cx="642156" cy="255208"/>
+            <a:ext cx="678656" cy="255208"/>
           </a:xfrm>
           <a:prstGeom prst="roundRect">
             <a:avLst>
@@ -9308,7 +9320,7 @@
         <p:spPr>
           <a:xfrm>
             <a:off x="457200" y="3564396"/>
-            <a:ext cx="642156" cy="229605"/>
+            <a:ext cx="678656" cy="229605"/>
           </a:xfrm>
           <a:prstGeom prst="rect">
             <a:avLst/>
@@ -9331,9 +9343,9 @@
                 <a:solidFill>
                   <a:srgbClr val="46B0A3"/>
                 </a:solidFill>
-                <a:latin typeface="Carlito" pitchFamily="34" charset="0"/>
-                <a:ea typeface="Carlito" pitchFamily="34" charset="-122"/>
-                <a:cs typeface="Carlito" pitchFamily="34" charset="-120"/>
+                <a:latin typeface="Inter" pitchFamily="34" charset="0"/>
+                <a:ea typeface="Inter" pitchFamily="34" charset="-122"/>
+                <a:cs typeface="Inter" pitchFamily="34" charset="-120"/>
               </a:rPr>
               <a:t>Медицина</a:t>
             </a:r>
@@ -9349,8 +9361,8 @@
         </p:nvSpPr>
         <p:spPr>
           <a:xfrm>
-            <a:off x="1156506" y="3551595"/>
-            <a:ext cx="503746" cy="255208"/>
+            <a:off x="1193006" y="3551595"/>
+            <a:ext cx="514350" cy="255208"/>
           </a:xfrm>
           <a:prstGeom prst="roundRect">
             <a:avLst>
@@ -9383,8 +9395,8 @@
         </p:nvSpPr>
         <p:spPr>
           <a:xfrm>
-            <a:off x="1156506" y="3564396"/>
-            <a:ext cx="503746" cy="229605"/>
+            <a:off x="1193006" y="3564396"/>
+            <a:ext cx="514350" cy="229605"/>
           </a:xfrm>
           <a:prstGeom prst="rect">
             <a:avLst/>
@@ -9407,9 +9419,9 @@
                 <a:solidFill>
                   <a:srgbClr val="46B0A3"/>
                 </a:solidFill>
-                <a:latin typeface="Carlito" pitchFamily="34" charset="0"/>
-                <a:ea typeface="Carlito" pitchFamily="34" charset="-122"/>
-                <a:cs typeface="Carlito" pitchFamily="34" charset="-120"/>
+                <a:latin typeface="Inter" pitchFamily="34" charset="0"/>
+                <a:ea typeface="Inter" pitchFamily="34" charset="-122"/>
+                <a:cs typeface="Inter" pitchFamily="34" charset="-120"/>
               </a:rPr>
               <a:t>Забота</a:t>
             </a:r>
@@ -9425,8 +9437,8 @@
         </p:nvSpPr>
         <p:spPr>
           <a:xfrm>
-            <a:off x="1717402" y="3551595"/>
-            <a:ext cx="691493" cy="255208"/>
+            <a:off x="1764506" y="3551595"/>
+            <a:ext cx="735806" cy="255208"/>
           </a:xfrm>
           <a:prstGeom prst="roundRect">
             <a:avLst>
@@ -9459,8 +9471,8 @@
         </p:nvSpPr>
         <p:spPr>
           <a:xfrm>
-            <a:off x="1717402" y="3564396"/>
-            <a:ext cx="691493" cy="229605"/>
+            <a:off x="1764506" y="3564396"/>
+            <a:ext cx="735806" cy="229605"/>
           </a:xfrm>
           <a:prstGeom prst="rect">
             <a:avLst/>
@@ -9483,9 +9495,9 @@
                 <a:solidFill>
                   <a:srgbClr val="46B0A3"/>
                 </a:solidFill>
-                <a:latin typeface="Carlito" pitchFamily="34" charset="0"/>
-                <a:ea typeface="Carlito" pitchFamily="34" charset="-122"/>
-                <a:cs typeface="Carlito" pitchFamily="34" charset="-120"/>
+                <a:latin typeface="Inter" pitchFamily="34" charset="0"/>
+                <a:ea typeface="Inter" pitchFamily="34" charset="-122"/>
+                <a:cs typeface="Inter" pitchFamily="34" charset="-120"/>
               </a:rPr>
               <a:t>Технология</a:t>
             </a:r>
@@ -9501,8 +9513,8 @@
         </p:nvSpPr>
         <p:spPr>
           <a:xfrm>
-            <a:off x="2466045" y="3551595"/>
-            <a:ext cx="553864" cy="255208"/>
+            <a:off x="2557463" y="3551595"/>
+            <a:ext cx="578644" cy="255208"/>
           </a:xfrm>
           <a:prstGeom prst="roundRect">
             <a:avLst>
@@ -9535,8 +9547,8 @@
         </p:nvSpPr>
         <p:spPr>
           <a:xfrm>
-            <a:off x="2466045" y="3564396"/>
-            <a:ext cx="553864" cy="229605"/>
+            <a:off x="2557463" y="3564396"/>
+            <a:ext cx="578644" cy="229605"/>
           </a:xfrm>
           <a:prstGeom prst="rect">
             <a:avLst/>
@@ -9559,9 +9571,9 @@
                 <a:solidFill>
                   <a:srgbClr val="46B0A3"/>
                 </a:solidFill>
-                <a:latin typeface="Carlito" pitchFamily="34" charset="0"/>
-                <a:ea typeface="Carlito" pitchFamily="34" charset="-122"/>
-                <a:cs typeface="Carlito" pitchFamily="34" charset="-120"/>
+                <a:latin typeface="Inter" pitchFamily="34" charset="0"/>
+                <a:ea typeface="Inter" pitchFamily="34" charset="-122"/>
+                <a:cs typeface="Inter" pitchFamily="34" charset="-120"/>
               </a:rPr>
               <a:t>Ясность</a:t>
             </a:r>
@@ -9577,8 +9589,8 @@
         </p:nvSpPr>
         <p:spPr>
           <a:xfrm>
-            <a:off x="3077059" y="3551595"/>
-            <a:ext cx="570830" cy="255208"/>
+            <a:off x="3193256" y="3551595"/>
+            <a:ext cx="614363" cy="255208"/>
           </a:xfrm>
           <a:prstGeom prst="roundRect">
             <a:avLst>
@@ -9611,8 +9623,8 @@
         </p:nvSpPr>
         <p:spPr>
           <a:xfrm>
-            <a:off x="3077059" y="3564396"/>
-            <a:ext cx="570830" cy="229605"/>
+            <a:off x="3193256" y="3564396"/>
+            <a:ext cx="614363" cy="229605"/>
           </a:xfrm>
           <a:prstGeom prst="rect">
             <a:avLst/>
@@ -9635,9 +9647,9 @@
                 <a:solidFill>
                   <a:srgbClr val="46B0A3"/>
                 </a:solidFill>
-                <a:latin typeface="Carlito" pitchFamily="34" charset="0"/>
-                <a:ea typeface="Carlito" pitchFamily="34" charset="-122"/>
-                <a:cs typeface="Carlito" pitchFamily="34" charset="-120"/>
+                <a:latin typeface="Inter" pitchFamily="34" charset="0"/>
+                <a:ea typeface="Inter" pitchFamily="34" charset="-122"/>
+                <a:cs typeface="Inter" pitchFamily="34" charset="-120"/>
               </a:rPr>
               <a:t>Доверие</a:t>
             </a:r>
@@ -9653,7 +9665,7 @@
         </p:nvSpPr>
         <p:spPr>
           <a:xfrm>
-            <a:off x="4343400" y="1387004"/>
+            <a:off x="4343400" y="1319696"/>
             <a:ext cx="4560570" cy="189988"/>
           </a:xfrm>
           <a:prstGeom prst="rect">
@@ -9677,9 +9689,9 @@
                 <a:solidFill>
                   <a:srgbClr val="1A1F2E"/>
                 </a:solidFill>
-                <a:latin typeface="Tinos" pitchFamily="34" charset="0"/>
-                <a:ea typeface="Tinos" pitchFamily="34" charset="-122"/>
-                <a:cs typeface="Tinos" pitchFamily="34" charset="-120"/>
+                <a:latin typeface="Playfair Display" pitchFamily="34" charset="0"/>
+                <a:ea typeface="Playfair Display" pitchFamily="34" charset="-122"/>
+                <a:cs typeface="Playfair Display" pitchFamily="34" charset="-120"/>
               </a:rPr>
               <a:t>Характер бренда</a:t>
             </a:r>
@@ -9695,12 +9707,12 @@
         </p:nvSpPr>
         <p:spPr>
           <a:xfrm>
-            <a:off x="4343400" y="1705794"/>
-            <a:ext cx="2114550" cy="1025351"/>
+            <a:off x="4343400" y="1638486"/>
+            <a:ext cx="2114550" cy="1159966"/>
           </a:xfrm>
           <a:prstGeom prst="roundRect">
             <a:avLst>
-              <a:gd name="adj" fmla="val 22295"/>
+              <a:gd name="adj" fmla="val 19707"/>
             </a:avLst>
           </a:prstGeom>
           <a:solidFill>
@@ -9734,7 +9746,7 @@
         </p:nvSpPr>
         <p:spPr>
           <a:xfrm>
-            <a:off x="4514850" y="1862956"/>
+            <a:off x="4514850" y="1795649"/>
             <a:ext cx="285750" cy="285750"/>
           </a:xfrm>
           <a:prstGeom prst="ellipse">
@@ -9766,7 +9778,7 @@
         </p:nvSpPr>
         <p:spPr>
           <a:xfrm>
-            <a:off x="4543782" y="1891888"/>
+            <a:off x="4543782" y="1824581"/>
             <a:ext cx="227886" cy="227886"/>
           </a:xfrm>
           <a:prstGeom prst="rect">
@@ -9805,7 +9817,7 @@
         </p:nvSpPr>
         <p:spPr>
           <a:xfrm>
-            <a:off x="4900613" y="1862956"/>
+            <a:off x="4900613" y="1795649"/>
             <a:ext cx="1385888" cy="279749"/>
           </a:xfrm>
           <a:prstGeom prst="rect">
@@ -9831,9 +9843,9 @@
                 <a:solidFill>
                   <a:srgbClr val="1A1F2E"/>
                 </a:solidFill>
-                <a:latin typeface="Carlito" pitchFamily="34" charset="0"/>
-                <a:ea typeface="Carlito" pitchFamily="34" charset="-122"/>
-                <a:cs typeface="Carlito" pitchFamily="34" charset="-120"/>
+                <a:latin typeface="Inter" pitchFamily="34" charset="0"/>
+                <a:ea typeface="Inter" pitchFamily="34" charset="-122"/>
+                <a:cs typeface="Inter" pitchFamily="34" charset="-120"/>
               </a:rPr>
               <a:t>Дружелюбный, но без панибратства</a:t>
             </a:r>
@@ -9849,8 +9861,8 @@
         </p:nvSpPr>
         <p:spPr>
           <a:xfrm>
-            <a:off x="4900613" y="2170137"/>
-            <a:ext cx="1469041" cy="403845"/>
+            <a:off x="4900613" y="2102830"/>
+            <a:ext cx="1469041" cy="538460"/>
           </a:xfrm>
           <a:prstGeom prst="rect">
             <a:avLst/>
@@ -9873,9 +9885,9 @@
                 <a:solidFill>
                   <a:srgbClr val="4A5468"/>
                 </a:solidFill>
-                <a:latin typeface="Carlito" pitchFamily="34" charset="0"/>
-                <a:ea typeface="Carlito" pitchFamily="34" charset="-122"/>
-                <a:cs typeface="Carlito" pitchFamily="34" charset="-120"/>
+                <a:latin typeface="Inter" pitchFamily="34" charset="0"/>
+                <a:ea typeface="Inter" pitchFamily="34" charset="-122"/>
+                <a:cs typeface="Inter" pitchFamily="34" charset="-120"/>
               </a:rPr>
               <a:t>Тёплый тон общения, сохраняющий профессиональную дистанцию.</a:t>
             </a:r>
@@ -9891,12 +9903,12 @@
         </p:nvSpPr>
         <p:spPr>
           <a:xfrm>
-            <a:off x="6572250" y="1705794"/>
-            <a:ext cx="2114550" cy="1025351"/>
+            <a:off x="6572250" y="1638486"/>
+            <a:ext cx="2114550" cy="1159966"/>
           </a:xfrm>
           <a:prstGeom prst="roundRect">
             <a:avLst>
-              <a:gd name="adj" fmla="val 22295"/>
+              <a:gd name="adj" fmla="val 19707"/>
             </a:avLst>
           </a:prstGeom>
           <a:solidFill>
@@ -9930,7 +9942,7 @@
         </p:nvSpPr>
         <p:spPr>
           <a:xfrm>
-            <a:off x="6743700" y="1862956"/>
+            <a:off x="6743700" y="1795649"/>
             <a:ext cx="285750" cy="285750"/>
           </a:xfrm>
           <a:prstGeom prst="ellipse">
@@ -9962,7 +9974,7 @@
         </p:nvSpPr>
         <p:spPr>
           <a:xfrm>
-            <a:off x="6772632" y="1891888"/>
+            <a:off x="6772632" y="1824581"/>
             <a:ext cx="227886" cy="227886"/>
           </a:xfrm>
           <a:prstGeom prst="rect">
@@ -10001,7 +10013,7 @@
         </p:nvSpPr>
         <p:spPr>
           <a:xfrm>
-            <a:off x="7129463" y="1862956"/>
+            <a:off x="7129463" y="1795649"/>
             <a:ext cx="1385888" cy="140446"/>
           </a:xfrm>
           <a:prstGeom prst="rect">
@@ -10027,9 +10039,9 @@
                 <a:solidFill>
                   <a:srgbClr val="1A1F2E"/>
                 </a:solidFill>
-                <a:latin typeface="Carlito" pitchFamily="34" charset="0"/>
-                <a:ea typeface="Carlito" pitchFamily="34" charset="-122"/>
-                <a:cs typeface="Carlito" pitchFamily="34" charset="-120"/>
+                <a:latin typeface="Inter" pitchFamily="34" charset="0"/>
+                <a:ea typeface="Inter" pitchFamily="34" charset="-122"/>
+                <a:cs typeface="Inter" pitchFamily="34" charset="-120"/>
               </a:rPr>
               <a:t>Экспертный</a:t>
             </a:r>
@@ -10045,7 +10057,7 @@
         </p:nvSpPr>
         <p:spPr>
           <a:xfrm>
-            <a:off x="7129463" y="2030834"/>
+            <a:off x="7129463" y="1963527"/>
             <a:ext cx="1469041" cy="477159"/>
           </a:xfrm>
           <a:prstGeom prst="rect">
@@ -10069,9 +10081,9 @@
                 <a:solidFill>
                   <a:srgbClr val="4A5468"/>
                 </a:solidFill>
-                <a:latin typeface="Carlito" pitchFamily="34" charset="0"/>
-                <a:ea typeface="Carlito" pitchFamily="34" charset="-122"/>
-                <a:cs typeface="Carlito" pitchFamily="34" charset="-120"/>
+                <a:latin typeface="Inter" pitchFamily="34" charset="0"/>
+                <a:ea typeface="Inter" pitchFamily="34" charset="-122"/>
+                <a:cs typeface="Inter" pitchFamily="34" charset="-120"/>
               </a:rPr>
               <a:t>Уважение к профессионализму врача в каждой детали интерфейса.</a:t>
             </a:r>
@@ -10087,7 +10099,7 @@
         </p:nvSpPr>
         <p:spPr>
           <a:xfrm>
-            <a:off x="4343400" y="2845445"/>
+            <a:off x="4343400" y="2912752"/>
             <a:ext cx="2114550" cy="1025351"/>
           </a:xfrm>
           <a:prstGeom prst="roundRect">
@@ -10126,7 +10138,7 @@
         </p:nvSpPr>
         <p:spPr>
           <a:xfrm>
-            <a:off x="4514850" y="3002607"/>
+            <a:off x="4514850" y="3069915"/>
             <a:ext cx="285750" cy="285750"/>
           </a:xfrm>
           <a:prstGeom prst="ellipse">
@@ -10158,7 +10170,7 @@
         </p:nvSpPr>
         <p:spPr>
           <a:xfrm>
-            <a:off x="4543782" y="3031540"/>
+            <a:off x="4543782" y="3098847"/>
             <a:ext cx="227886" cy="227886"/>
           </a:xfrm>
           <a:prstGeom prst="rect">
@@ -10197,7 +10209,7 @@
         </p:nvSpPr>
         <p:spPr>
           <a:xfrm>
-            <a:off x="4900613" y="3002607"/>
+            <a:off x="4900613" y="3069915"/>
             <a:ext cx="1385888" cy="279749"/>
           </a:xfrm>
           <a:prstGeom prst="rect">
@@ -10223,9 +10235,9 @@
                 <a:solidFill>
                   <a:srgbClr val="1A1F2E"/>
                 </a:solidFill>
-                <a:latin typeface="Carlito" pitchFamily="34" charset="0"/>
-                <a:ea typeface="Carlito" pitchFamily="34" charset="-122"/>
-                <a:cs typeface="Carlito" pitchFamily="34" charset="-120"/>
+                <a:latin typeface="Inter" pitchFamily="34" charset="0"/>
+                <a:ea typeface="Inter" pitchFamily="34" charset="-122"/>
+                <a:cs typeface="Inter" pitchFamily="34" charset="-120"/>
               </a:rPr>
               <a:t>Современный и технологичный</a:t>
             </a:r>
@@ -10241,7 +10253,7 @@
         </p:nvSpPr>
         <p:spPr>
           <a:xfrm>
-            <a:off x="4900613" y="3309789"/>
+            <a:off x="4900613" y="3377096"/>
             <a:ext cx="1469041" cy="403845"/>
           </a:xfrm>
           <a:prstGeom prst="rect">
@@ -10265,9 +10277,9 @@
                 <a:solidFill>
                   <a:srgbClr val="4A5468"/>
                 </a:solidFill>
-                <a:latin typeface="Carlito" pitchFamily="34" charset="0"/>
-                <a:ea typeface="Carlito" pitchFamily="34" charset="-122"/>
-                <a:cs typeface="Carlito" pitchFamily="34" charset="-120"/>
+                <a:latin typeface="Inter" pitchFamily="34" charset="0"/>
+                <a:ea typeface="Inter" pitchFamily="34" charset="-122"/>
+                <a:cs typeface="Inter" pitchFamily="34" charset="-120"/>
               </a:rPr>
               <a:t>Скрывает сложность за простым и предсказуемым интерфейсом.</a:t>
             </a:r>
@@ -10283,7 +10295,7 @@
         </p:nvSpPr>
         <p:spPr>
           <a:xfrm>
-            <a:off x="6572250" y="2845445"/>
+            <a:off x="6572250" y="2912752"/>
             <a:ext cx="2114550" cy="1025351"/>
           </a:xfrm>
           <a:prstGeom prst="roundRect">
@@ -10322,7 +10334,7 @@
         </p:nvSpPr>
         <p:spPr>
           <a:xfrm>
-            <a:off x="6743700" y="3002607"/>
+            <a:off x="6743700" y="3069915"/>
             <a:ext cx="285750" cy="285750"/>
           </a:xfrm>
           <a:prstGeom prst="ellipse">
@@ -10354,7 +10366,7 @@
         </p:nvSpPr>
         <p:spPr>
           <a:xfrm>
-            <a:off x="6772632" y="3031540"/>
+            <a:off x="6772632" y="3098847"/>
             <a:ext cx="227886" cy="227886"/>
           </a:xfrm>
           <a:prstGeom prst="rect">
@@ -10393,7 +10405,7 @@
         </p:nvSpPr>
         <p:spPr>
           <a:xfrm>
-            <a:off x="7129463" y="3002607"/>
+            <a:off x="7129463" y="3069915"/>
             <a:ext cx="1385888" cy="140446"/>
           </a:xfrm>
           <a:prstGeom prst="rect">
@@ -10419,9 +10431,9 @@
                 <a:solidFill>
                   <a:srgbClr val="1A1F2E"/>
                 </a:solidFill>
-                <a:latin typeface="Carlito" pitchFamily="34" charset="0"/>
-                <a:ea typeface="Carlito" pitchFamily="34" charset="-122"/>
-                <a:cs typeface="Carlito" pitchFamily="34" charset="-120"/>
+                <a:latin typeface="Inter" pitchFamily="34" charset="0"/>
+                <a:ea typeface="Inter" pitchFamily="34" charset="-122"/>
+                <a:cs typeface="Inter" pitchFamily="34" charset="-120"/>
               </a:rPr>
               <a:t>Спокойный</a:t>
             </a:r>
@@ -10437,8 +10449,8 @@
         </p:nvSpPr>
         <p:spPr>
           <a:xfrm>
-            <a:off x="7129463" y="3170486"/>
-            <a:ext cx="1469041" cy="318106"/>
+            <a:off x="7129463" y="3237793"/>
+            <a:ext cx="1469041" cy="477159"/>
           </a:xfrm>
           <a:prstGeom prst="rect">
             <a:avLst/>
@@ -10461,9 +10473,9 @@
                 <a:solidFill>
                   <a:srgbClr val="4A5468"/>
                 </a:solidFill>
-                <a:latin typeface="Carlito" pitchFamily="34" charset="0"/>
-                <a:ea typeface="Carlito" pitchFamily="34" charset="-122"/>
-                <a:cs typeface="Carlito" pitchFamily="34" charset="-120"/>
+                <a:latin typeface="Inter" pitchFamily="34" charset="0"/>
+                <a:ea typeface="Inter" pitchFamily="34" charset="-122"/>
+                <a:cs typeface="Inter" pitchFamily="34" charset="-120"/>
               </a:rPr>
               <a:t>Снижает уровень стресса при длительной работе в системе.</a:t>
             </a:r>
@@ -10480,7 +10492,7 @@
         <p:spPr>
           <a:xfrm>
             <a:off x="257175" y="200025"/>
-            <a:ext cx="1257779" cy="169999"/>
+            <a:ext cx="1152902" cy="169999"/>
           </a:xfrm>
           <a:prstGeom prst="rect">
             <a:avLst/>
@@ -10503,9 +10515,9 @@
                 <a:solidFill>
                   <a:srgbClr val="8B95A7"/>
                 </a:solidFill>
-                <a:latin typeface="Carlito" pitchFamily="34" charset="0"/>
-                <a:ea typeface="Carlito" pitchFamily="34" charset="-122"/>
-                <a:cs typeface="Carlito" pitchFamily="34" charset="-120"/>
+                <a:latin typeface="Inter" pitchFamily="34" charset="0"/>
+                <a:ea typeface="Inter" pitchFamily="34" charset="-122"/>
+                <a:cs typeface="Inter" pitchFamily="34" charset="-120"/>
               </a:rPr>
               <a:t>МИС АЛЬТЕРА</a:t>
             </a:r>
@@ -10521,8 +10533,8 @@
         </p:nvSpPr>
         <p:spPr>
           <a:xfrm>
-            <a:off x="8508095" y="4799595"/>
-            <a:ext cx="542768" cy="169999"/>
+            <a:off x="8534772" y="4799595"/>
+            <a:ext cx="504536" cy="169999"/>
           </a:xfrm>
           <a:prstGeom prst="rect">
             <a:avLst/>
@@ -10677,9 +10689,9 @@
                 <a:solidFill>
                   <a:srgbClr val="46B0A3"/>
                 </a:solidFill>
-                <a:latin typeface="Carlito" pitchFamily="34" charset="0"/>
-                <a:ea typeface="Carlito" pitchFamily="34" charset="-122"/>
-                <a:cs typeface="Carlito" pitchFamily="34" charset="-120"/>
+                <a:latin typeface="Inter" pitchFamily="34" charset="0"/>
+                <a:ea typeface="Inter" pitchFamily="34" charset="-122"/>
+                <a:cs typeface="Inter" pitchFamily="34" charset="-120"/>
               </a:rPr>
               <a:t>03 — ФИРМЕННЫЙ ЗНАК</a:t>
             </a:r>
@@ -10719,9 +10731,9 @@
                 <a:solidFill>
                   <a:srgbClr val="1A1F2E"/>
                 </a:solidFill>
-                <a:latin typeface="Tinos" pitchFamily="34" charset="0"/>
-                <a:ea typeface="Tinos" pitchFamily="34" charset="-122"/>
-                <a:cs typeface="Tinos" pitchFamily="34" charset="-120"/>
+                <a:latin typeface="Playfair Display" pitchFamily="34" charset="0"/>
+                <a:ea typeface="Playfair Display" pitchFamily="34" charset="-122"/>
+                <a:cs typeface="Playfair Display" pitchFamily="34" charset="-120"/>
               </a:rPr>
               <a:t>Логотип: Символ целостности.</a:t>
             </a:r>
@@ -10761,9 +10773,9 @@
                 <a:solidFill>
                   <a:srgbClr val="4A5468"/>
                 </a:solidFill>
-                <a:latin typeface="Carlito" pitchFamily="34" charset="0"/>
-                <a:ea typeface="Carlito" pitchFamily="34" charset="-122"/>
-                <a:cs typeface="Carlito" pitchFamily="34" charset="-120"/>
+                <a:latin typeface="Inter" pitchFamily="34" charset="0"/>
+                <a:ea typeface="Inter" pitchFamily="34" charset="-122"/>
+                <a:cs typeface="Inter" pitchFamily="34" charset="-120"/>
               </a:rPr>
               <a:t>Логотип представляет собой сферический знак с тремя диагональными изогнутыми линиями. Метафора: земной шар, круговорот данных, непрерывное взаимодействие между пациентом, врачом и системой. Линии динамичны, но сбалансированы — спокойствие и уверенность.</a:t>
             </a:r>
@@ -10894,8 +10906,8 @@
         </p:nvSpPr>
         <p:spPr>
           <a:xfrm>
-            <a:off x="1561271" y="3779379"/>
-            <a:ext cx="1392307" cy="170047"/>
+            <a:off x="1584521" y="3779379"/>
+            <a:ext cx="1345808" cy="170047"/>
           </a:xfrm>
           <a:prstGeom prst="rect">
             <a:avLst/>
@@ -10918,9 +10930,9 @@
                 <a:solidFill>
                   <a:srgbClr val="8B95A7"/>
                 </a:solidFill>
-                <a:latin typeface="Carlito" pitchFamily="34" charset="0"/>
-                <a:ea typeface="Carlito" pitchFamily="34" charset="-122"/>
-                <a:cs typeface="Carlito" pitchFamily="34" charset="-120"/>
+                <a:latin typeface="Inter" pitchFamily="34" charset="0"/>
+                <a:ea typeface="Inter" pitchFamily="34" charset="-122"/>
+                <a:cs typeface="Inter" pitchFamily="34" charset="-120"/>
               </a:rPr>
               <a:t>ОСНОВНАЯ ВЕРСИЯ</a:t>
             </a:r>
@@ -10960,9 +10972,9 @@
                 <a:solidFill>
                   <a:srgbClr val="1A1F2E"/>
                 </a:solidFill>
-                <a:latin typeface="Tinos" pitchFamily="34" charset="0"/>
-                <a:ea typeface="Tinos" pitchFamily="34" charset="-122"/>
-                <a:cs typeface="Tinos" pitchFamily="34" charset="-120"/>
+                <a:latin typeface="Playfair Display" pitchFamily="34" charset="0"/>
+                <a:ea typeface="Playfair Display" pitchFamily="34" charset="-122"/>
+                <a:cs typeface="Playfair Display" pitchFamily="34" charset="-120"/>
               </a:rPr>
               <a:t>Основные правила</a:t>
             </a:r>
@@ -11082,7 +11094,7 @@
         <p:spPr>
           <a:xfrm>
             <a:off x="4757738" y="2187439"/>
-            <a:ext cx="3067180" cy="148929"/>
+            <a:ext cx="3217902" cy="148929"/>
           </a:xfrm>
           <a:prstGeom prst="rect">
             <a:avLst/>
@@ -11107,9 +11119,9 @@
                 <a:solidFill>
                   <a:srgbClr val="1A1F2E"/>
                 </a:solidFill>
-                <a:latin typeface="Carlito" pitchFamily="34" charset="0"/>
-                <a:ea typeface="Carlito" pitchFamily="34" charset="-122"/>
-                <a:cs typeface="Carlito" pitchFamily="34" charset="-120"/>
+                <a:latin typeface="Inter" pitchFamily="34" charset="0"/>
+                <a:ea typeface="Inter" pitchFamily="34" charset="-122"/>
+                <a:cs typeface="Inter" pitchFamily="34" charset="-120"/>
               </a:rPr>
               <a:t>Цветная версия</a:t>
             </a:r>
@@ -11126,7 +11138,7 @@
         <p:spPr>
           <a:xfrm>
             <a:off x="4757738" y="2363800"/>
-            <a:ext cx="2921124" cy="134615"/>
+            <a:ext cx="3064669" cy="134615"/>
           </a:xfrm>
           <a:prstGeom prst="rect">
             <a:avLst/>
@@ -11149,9 +11161,9 @@
                 <a:solidFill>
                   <a:srgbClr val="4A5468"/>
                 </a:solidFill>
-                <a:latin typeface="Carlito" pitchFamily="34" charset="0"/>
-                <a:ea typeface="Carlito" pitchFamily="34" charset="-122"/>
-                <a:cs typeface="Carlito" pitchFamily="34" charset="-120"/>
+                <a:latin typeface="Inter" pitchFamily="34" charset="0"/>
+                <a:ea typeface="Inter" pitchFamily="34" charset="-122"/>
+                <a:cs typeface="Inter" pitchFamily="34" charset="-120"/>
               </a:rPr>
               <a:t>Tiffany #5ECEC1 на светлом фоне. Основная для цифровой среды.</a:t>
             </a:r>
@@ -11296,9 +11308,9 @@
                 <a:solidFill>
                   <a:srgbClr val="1A1F2E"/>
                 </a:solidFill>
-                <a:latin typeface="Carlito" pitchFamily="34" charset="0"/>
-                <a:ea typeface="Carlito" pitchFamily="34" charset="-122"/>
-                <a:cs typeface="Carlito" pitchFamily="34" charset="-120"/>
+                <a:latin typeface="Inter" pitchFamily="34" charset="0"/>
+                <a:ea typeface="Inter" pitchFamily="34" charset="-122"/>
+                <a:cs typeface="Inter" pitchFamily="34" charset="-120"/>
               </a:rPr>
               <a:t>Монохром</a:t>
             </a:r>
@@ -11315,7 +11327,7 @@
         <p:spPr>
           <a:xfrm>
             <a:off x="4757738" y="2989101"/>
-            <a:ext cx="2961308" cy="134615"/>
+            <a:ext cx="3214688" cy="134615"/>
           </a:xfrm>
           <a:prstGeom prst="rect">
             <a:avLst/>
@@ -11334,17 +11346,17 @@
               <a:buNone/>
             </a:pPr>
             <a:r>
-              <a:rPr lang="en-US" sz="731" dirty="0">
+              <a:rPr lang="en-US" sz="800" dirty="0">
                 <a:solidFill>
                   <a:srgbClr val="4A5468"/>
                 </a:solidFill>
-                <a:latin typeface="Carlito" pitchFamily="34" charset="0"/>
-                <a:ea typeface="Carlito" pitchFamily="34" charset="-122"/>
-                <a:cs typeface="Carlito" pitchFamily="34" charset="-120"/>
+                <a:latin typeface="Inter" pitchFamily="34" charset="0"/>
+                <a:ea typeface="Inter" pitchFamily="34" charset="-122"/>
+                <a:cs typeface="Inter" pitchFamily="34" charset="-120"/>
               </a:rPr>
               <a:t>Чёрный/тёмно-серый на белой бумаге. Белый на тёмных носителях.</a:t>
             </a:r>
-            <a:endParaRPr lang="en-US" sz="731" dirty="0"/>
+            <a:endParaRPr lang="en-US" sz="800" dirty="0"/>
           </a:p>
         </p:txBody>
       </p:sp>
@@ -11485,9 +11497,9 @@
                 <a:solidFill>
                   <a:srgbClr val="1A1F2E"/>
                 </a:solidFill>
-                <a:latin typeface="Carlito" pitchFamily="34" charset="0"/>
-                <a:ea typeface="Carlito" pitchFamily="34" charset="-122"/>
-                <a:cs typeface="Carlito" pitchFamily="34" charset="-120"/>
+                <a:latin typeface="Inter" pitchFamily="34" charset="0"/>
+                <a:ea typeface="Inter" pitchFamily="34" charset="-122"/>
+                <a:cs typeface="Inter" pitchFamily="34" charset="-120"/>
               </a:rPr>
               <a:t>Минимальные размеры</a:t>
             </a:r>
@@ -11527,9 +11539,9 @@
                 <a:solidFill>
                   <a:srgbClr val="4A5468"/>
                 </a:solidFill>
-                <a:latin typeface="Carlito" pitchFamily="34" charset="0"/>
-                <a:ea typeface="Carlito" pitchFamily="34" charset="-122"/>
-                <a:cs typeface="Carlito" pitchFamily="34" charset="-120"/>
+                <a:latin typeface="Inter" pitchFamily="34" charset="0"/>
+                <a:ea typeface="Inter" pitchFamily="34" charset="-122"/>
+                <a:cs typeface="Inter" pitchFamily="34" charset="-120"/>
               </a:rPr>
               <a:t>Печать — 16 мм. Интерфейс — 48 пикселей. Меньше — нельзя: теряется читаемость линий.</a:t>
             </a:r>
@@ -11546,7 +11558,7 @@
         <p:spPr>
           <a:xfrm>
             <a:off x="257175" y="200025"/>
-            <a:ext cx="1257779" cy="169999"/>
+            <a:ext cx="1152902" cy="169999"/>
           </a:xfrm>
           <a:prstGeom prst="rect">
             <a:avLst/>
@@ -11569,9 +11581,9 @@
                 <a:solidFill>
                   <a:srgbClr val="8B95A7"/>
                 </a:solidFill>
-                <a:latin typeface="Carlito" pitchFamily="34" charset="0"/>
-                <a:ea typeface="Carlito" pitchFamily="34" charset="-122"/>
-                <a:cs typeface="Carlito" pitchFamily="34" charset="-120"/>
+                <a:latin typeface="Inter" pitchFamily="34" charset="0"/>
+                <a:ea typeface="Inter" pitchFamily="34" charset="-122"/>
+                <a:cs typeface="Inter" pitchFamily="34" charset="-120"/>
               </a:rPr>
               <a:t>МИС АЛЬТЕРА</a:t>
             </a:r>
@@ -11587,8 +11599,8 @@
         </p:nvSpPr>
         <p:spPr>
           <a:xfrm>
-            <a:off x="8508095" y="4799595"/>
-            <a:ext cx="542768" cy="169999"/>
+            <a:off x="8534772" y="4799595"/>
+            <a:ext cx="504536" cy="169999"/>
           </a:xfrm>
           <a:prstGeom prst="rect">
             <a:avLst/>
@@ -11766,9 +11778,9 @@
                 <a:solidFill>
                   <a:srgbClr val="46B0A3"/>
                 </a:solidFill>
-                <a:latin typeface="Carlito" pitchFamily="34" charset="0"/>
-                <a:ea typeface="Carlito" pitchFamily="34" charset="-122"/>
-                <a:cs typeface="Carlito" pitchFamily="34" charset="-120"/>
+                <a:latin typeface="Inter" pitchFamily="34" charset="0"/>
+                <a:ea typeface="Inter" pitchFamily="34" charset="-122"/>
+                <a:cs typeface="Inter" pitchFamily="34" charset="-120"/>
               </a:rPr>
               <a:t>04 — ОХРАННОЕ ПОЛЕ</a:t>
             </a:r>
@@ -11808,9 +11820,9 @@
                 <a:solidFill>
                   <a:srgbClr val="1A1F2E"/>
                 </a:solidFill>
-                <a:latin typeface="Tinos" pitchFamily="34" charset="0"/>
-                <a:ea typeface="Tinos" pitchFamily="34" charset="-122"/>
-                <a:cs typeface="Tinos" pitchFamily="34" charset="-120"/>
+                <a:latin typeface="Playfair Display" pitchFamily="34" charset="0"/>
+                <a:ea typeface="Playfair Display" pitchFamily="34" charset="-122"/>
+                <a:cs typeface="Playfair Display" pitchFamily="34" charset="-120"/>
               </a:rPr>
               <a:t>Правила размещения и защитная зона.</a:t>
             </a:r>
@@ -11850,9 +11862,9 @@
                 <a:solidFill>
                   <a:srgbClr val="4A5468"/>
                 </a:solidFill>
-                <a:latin typeface="Carlito" pitchFamily="34" charset="0"/>
-                <a:ea typeface="Carlito" pitchFamily="34" charset="-122"/>
-                <a:cs typeface="Carlito" pitchFamily="34" charset="-120"/>
+                <a:latin typeface="Inter" pitchFamily="34" charset="0"/>
+                <a:ea typeface="Inter" pitchFamily="34" charset="-122"/>
+                <a:cs typeface="Inter" pitchFamily="34" charset="-120"/>
               </a:rPr>
               <a:t>Логотип должен легко идентифицироваться. Запрещено загромождать пространство вокруг него.</a:t>
             </a:r>
@@ -11933,9 +11945,9 @@
                 <a:solidFill>
                   <a:srgbClr val="8B95A7"/>
                 </a:solidFill>
-                <a:latin typeface="Carlito" pitchFamily="34" charset="0"/>
-                <a:ea typeface="Carlito" pitchFamily="34" charset="-122"/>
-                <a:cs typeface="Carlito" pitchFamily="34" charset="-120"/>
+                <a:latin typeface="Inter" pitchFamily="34" charset="0"/>
+                <a:ea typeface="Inter" pitchFamily="34" charset="-122"/>
+                <a:cs typeface="Inter" pitchFamily="34" charset="-120"/>
               </a:rPr>
               <a:t>ОХРАННОЕ ПОЛЕ = РАДИУС ЛОГОТИПА</a:t>
             </a:r>
@@ -12116,9 +12128,9 @@
                 <a:solidFill>
                   <a:srgbClr val="4A5468"/>
                 </a:solidFill>
-                <a:latin typeface="Carlito" pitchFamily="34" charset="0"/>
-                <a:ea typeface="Carlito" pitchFamily="34" charset="-122"/>
-                <a:cs typeface="Carlito" pitchFamily="34" charset="-120"/>
+                <a:latin typeface="Inter" pitchFamily="34" charset="0"/>
+                <a:ea typeface="Inter" pitchFamily="34" charset="-122"/>
+                <a:cs typeface="Inter" pitchFamily="34" charset="-120"/>
               </a:rPr>
               <a:t>Логотип</a:t>
             </a:r>
@@ -12134,7 +12146,7 @@
         </p:nvSpPr>
         <p:spPr>
           <a:xfrm>
-            <a:off x="3374752" y="1895661"/>
+            <a:off x="3367385" y="1895661"/>
             <a:ext cx="114300" cy="114300"/>
           </a:xfrm>
           <a:prstGeom prst="rect">
@@ -12173,7 +12185,7 @@
         </p:nvSpPr>
         <p:spPr>
           <a:xfrm>
-            <a:off x="3298111" y="1886396"/>
+            <a:off x="3290744" y="1886396"/>
             <a:ext cx="559047" cy="170021"/>
           </a:xfrm>
           <a:prstGeom prst="rect">
@@ -12197,9 +12209,9 @@
                 <a:solidFill>
                   <a:srgbClr val="4A5468"/>
                 </a:solidFill>
-                <a:latin typeface="Carlito" pitchFamily="34" charset="0"/>
-                <a:ea typeface="Carlito" pitchFamily="34" charset="-122"/>
-                <a:cs typeface="Carlito" pitchFamily="34" charset="-120"/>
+                <a:latin typeface="Inter" pitchFamily="34" charset="0"/>
+                <a:ea typeface="Inter" pitchFamily="34" charset="-122"/>
+                <a:cs typeface="Inter" pitchFamily="34" charset="-120"/>
               </a:rPr>
               <a:t>≥ R (радиус)</a:t>
             </a:r>
@@ -12239,9 +12251,9 @@
                 <a:solidFill>
                   <a:srgbClr val="8B95A7"/>
                 </a:solidFill>
-                <a:latin typeface="Carlito" pitchFamily="34" charset="0"/>
-                <a:ea typeface="Carlito" pitchFamily="34" charset="-122"/>
-                <a:cs typeface="Carlito" pitchFamily="34" charset="-120"/>
+                <a:latin typeface="Inter" pitchFamily="34" charset="0"/>
+                <a:ea typeface="Inter" pitchFamily="34" charset="-122"/>
+                <a:cs typeface="Inter" pitchFamily="34" charset="-120"/>
               </a:rPr>
               <a:t>СВЕТЛАЯ / ТЁМНАЯ ТЕМА</a:t>
             </a:r>
@@ -12389,9 +12401,9 @@
                 <a:solidFill>
                   <a:srgbClr val="1A1F2E"/>
                 </a:solidFill>
-                <a:latin typeface="Carlito" pitchFamily="34" charset="0"/>
-                <a:ea typeface="Carlito" pitchFamily="34" charset="-122"/>
-                <a:cs typeface="Carlito" pitchFamily="34" charset="-120"/>
+                <a:latin typeface="Inter" pitchFamily="34" charset="0"/>
+                <a:ea typeface="Inter" pitchFamily="34" charset="-122"/>
+                <a:cs typeface="Inter" pitchFamily="34" charset="-120"/>
               </a:rPr>
               <a:t>Светлая: #5ECEC1 на #F9FAFB</a:t>
             </a:r>
@@ -12534,9 +12546,9 @@
                 <a:solidFill>
                   <a:srgbClr val="1A1F2E"/>
                 </a:solidFill>
-                <a:latin typeface="Carlito" pitchFamily="34" charset="0"/>
-                <a:ea typeface="Carlito" pitchFamily="34" charset="-122"/>
-                <a:cs typeface="Carlito" pitchFamily="34" charset="-120"/>
+                <a:latin typeface="Inter" pitchFamily="34" charset="0"/>
+                <a:ea typeface="Inter" pitchFamily="34" charset="-122"/>
+                <a:cs typeface="Inter" pitchFamily="34" charset="-120"/>
               </a:rPr>
               <a:t>Тёмная: белый #FFFFFF или золотой #C9A96E на #161B22</a:t>
             </a:r>
@@ -12576,9 +12588,9 @@
                 <a:solidFill>
                   <a:srgbClr val="F35E62"/>
                 </a:solidFill>
-                <a:latin typeface="Carlito" pitchFamily="34" charset="0"/>
-                <a:ea typeface="Carlito" pitchFamily="34" charset="-122"/>
-                <a:cs typeface="Carlito" pitchFamily="34" charset="-120"/>
+                <a:latin typeface="Inter" pitchFamily="34" charset="0"/>
+                <a:ea typeface="Inter" pitchFamily="34" charset="-122"/>
+                <a:cs typeface="Inter" pitchFamily="34" charset="-120"/>
               </a:rPr>
               <a:t>ЗАПРЕЩЕНО</a:t>
             </a:r>
@@ -12626,8 +12638,8 @@
         </p:nvSpPr>
         <p:spPr>
           <a:xfrm>
-            <a:off x="5158349" y="3090342"/>
-            <a:ext cx="629006" cy="128016"/>
+            <a:off x="5170289" y="3090342"/>
+            <a:ext cx="660797" cy="137160"/>
           </a:xfrm>
           <a:prstGeom prst="rect">
             <a:avLst/>
@@ -12650,9 +12662,9 @@
                 <a:solidFill>
                   <a:srgbClr val="1A1F2E"/>
                 </a:solidFill>
-                <a:latin typeface="Carlito" pitchFamily="34" charset="0"/>
-                <a:ea typeface="Carlito" pitchFamily="34" charset="-122"/>
-                <a:cs typeface="Carlito" pitchFamily="34" charset="-120"/>
+                <a:latin typeface="Inter" pitchFamily="34" charset="0"/>
+                <a:ea typeface="Inter" pitchFamily="34" charset="-122"/>
+                <a:cs typeface="Inter" pitchFamily="34" charset="-120"/>
               </a:rPr>
               <a:t>Растягивать</a:t>
             </a:r>
@@ -12708,7 +12720,7 @@
         <p:spPr>
           <a:xfrm>
             <a:off x="7007126" y="3090342"/>
-            <a:ext cx="937478" cy="128016"/>
+            <a:ext cx="991195" cy="137160"/>
           </a:xfrm>
           <a:prstGeom prst="rect">
             <a:avLst/>
@@ -12731,9 +12743,9 @@
                 <a:solidFill>
                   <a:srgbClr val="1A1F2E"/>
                 </a:solidFill>
-                <a:latin typeface="Carlito" pitchFamily="34" charset="0"/>
-                <a:ea typeface="Carlito" pitchFamily="34" charset="-122"/>
-                <a:cs typeface="Carlito" pitchFamily="34" charset="-120"/>
+                <a:latin typeface="Inter" pitchFamily="34" charset="0"/>
+                <a:ea typeface="Inter" pitchFamily="34" charset="-122"/>
+                <a:cs typeface="Inter" pitchFamily="34" charset="-120"/>
               </a:rPr>
               <a:t>Менять пропорции</a:t>
             </a:r>
@@ -12789,7 +12801,7 @@
         <p:spPr>
           <a:xfrm>
             <a:off x="5170289" y="3353098"/>
-            <a:ext cx="1488802" cy="128016"/>
+            <a:ext cx="1604772" cy="137160"/>
           </a:xfrm>
           <a:prstGeom prst="rect">
             <a:avLst/>
@@ -12808,17 +12820,17 @@
               <a:buNone/>
             </a:pPr>
             <a:r>
-              <a:rPr lang="en-US" sz="675" dirty="0">
+              <a:rPr lang="en-US" sz="800" dirty="0">
                 <a:solidFill>
                   <a:srgbClr val="1A1F2E"/>
                 </a:solidFill>
-                <a:latin typeface="Carlito" pitchFamily="34" charset="0"/>
-                <a:ea typeface="Carlito" pitchFamily="34" charset="-122"/>
-                <a:cs typeface="Carlito" pitchFamily="34" charset="-120"/>
+                <a:latin typeface="Inter" pitchFamily="34" charset="0"/>
+                <a:ea typeface="Inter" pitchFamily="34" charset="-122"/>
+                <a:cs typeface="Inter" pitchFamily="34" charset="-120"/>
               </a:rPr>
               <a:t>Перекрашивать в статусные цвета</a:t>
             </a:r>
-            <a:endParaRPr lang="en-US" sz="675" dirty="0"/>
+            <a:endParaRPr lang="en-US" sz="800" dirty="0"/>
           </a:p>
         </p:txBody>
       </p:sp>
@@ -12870,7 +12882,7 @@
         <p:spPr>
           <a:xfrm>
             <a:off x="7007126" y="3284562"/>
-            <a:ext cx="1437568" cy="259854"/>
+            <a:ext cx="1552337" cy="259854"/>
           </a:xfrm>
           <a:prstGeom prst="rect">
             <a:avLst/>
@@ -12893,9 +12905,9 @@
                 <a:solidFill>
                   <a:srgbClr val="1A1F2E"/>
                 </a:solidFill>
-                <a:latin typeface="Carlito" pitchFamily="34" charset="0"/>
-                <a:ea typeface="Carlito" pitchFamily="34" charset="-122"/>
-                <a:cs typeface="Carlito" pitchFamily="34" charset="-120"/>
+                <a:latin typeface="Inter" pitchFamily="34" charset="0"/>
+                <a:ea typeface="Inter" pitchFamily="34" charset="-122"/>
+                <a:cs typeface="Inter" pitchFamily="34" charset="-120"/>
               </a:rPr>
               <a:t>Делать полупрозрачным водяным знаком</a:t>
             </a:r>
@@ -12951,7 +12963,7 @@
         <p:spPr>
           <a:xfrm>
             <a:off x="257175" y="200025"/>
-            <a:ext cx="1257779" cy="169999"/>
+            <a:ext cx="1152902" cy="169999"/>
           </a:xfrm>
           <a:prstGeom prst="rect">
             <a:avLst/>
@@ -12974,9 +12986,9 @@
                 <a:solidFill>
                   <a:srgbClr val="8B95A7"/>
                 </a:solidFill>
-                <a:latin typeface="Carlito" pitchFamily="34" charset="0"/>
-                <a:ea typeface="Carlito" pitchFamily="34" charset="-122"/>
-                <a:cs typeface="Carlito" pitchFamily="34" charset="-120"/>
+                <a:latin typeface="Inter" pitchFamily="34" charset="0"/>
+                <a:ea typeface="Inter" pitchFamily="34" charset="-122"/>
+                <a:cs typeface="Inter" pitchFamily="34" charset="-120"/>
               </a:rPr>
               <a:t>МИС АЛЬТЕРА</a:t>
             </a:r>
@@ -12992,8 +13004,8 @@
         </p:nvSpPr>
         <p:spPr>
           <a:xfrm>
-            <a:off x="8508095" y="4799595"/>
-            <a:ext cx="542768" cy="169999"/>
+            <a:off x="8534772" y="4799595"/>
+            <a:ext cx="504536" cy="169999"/>
           </a:xfrm>
           <a:prstGeom prst="rect">
             <a:avLst/>
@@ -13136,9 +13148,9 @@
                 <a:solidFill>
                   <a:srgbClr val="46B0A3"/>
                 </a:solidFill>
-                <a:latin typeface="Carlito" pitchFamily="34" charset="0"/>
-                <a:ea typeface="Carlito" pitchFamily="34" charset="-122"/>
-                <a:cs typeface="Carlito" pitchFamily="34" charset="-120"/>
+                <a:latin typeface="Inter" pitchFamily="34" charset="0"/>
+                <a:ea typeface="Inter" pitchFamily="34" charset="-122"/>
+                <a:cs typeface="Inter" pitchFamily="34" charset="-120"/>
               </a:rPr>
               <a:t>05 — ПАЛИТРА UX</a:t>
             </a:r>
@@ -13178,9 +13190,9 @@
                 <a:solidFill>
                   <a:srgbClr val="1A1F2E"/>
                 </a:solidFill>
-                <a:latin typeface="Tinos" pitchFamily="34" charset="0"/>
-                <a:ea typeface="Tinos" pitchFamily="34" charset="-122"/>
-                <a:cs typeface="Tinos" pitchFamily="34" charset="-120"/>
+                <a:latin typeface="Playfair Display" pitchFamily="34" charset="0"/>
+                <a:ea typeface="Playfair Display" pitchFamily="34" charset="-122"/>
+                <a:cs typeface="Playfair Display" pitchFamily="34" charset="-120"/>
               </a:rPr>
               <a:t>Цветовые пропорции: Интерфейс.</a:t>
             </a:r>
@@ -13220,9 +13232,9 @@
                 <a:solidFill>
                   <a:srgbClr val="4A5468"/>
                 </a:solidFill>
-                <a:latin typeface="Carlito" pitchFamily="34" charset="0"/>
-                <a:ea typeface="Carlito" pitchFamily="34" charset="-122"/>
-                <a:cs typeface="Carlito" pitchFamily="34" charset="-120"/>
+                <a:latin typeface="Inter" pitchFamily="34" charset="0"/>
+                <a:ea typeface="Inter" pitchFamily="34" charset="-122"/>
+                <a:cs typeface="Inter" pitchFamily="34" charset="-120"/>
               </a:rPr>
               <a:t>Цвет в интерфейсе не должен отвлекать врача от данных. Яркий цвет используется только как призыв к действию.</a:t>
             </a:r>
@@ -13292,9 +13304,9 @@
                 <a:solidFill>
                   <a:srgbClr val="4A5468"/>
                 </a:solidFill>
-                <a:latin typeface="Carlito" pitchFamily="34" charset="0"/>
-                <a:ea typeface="Carlito" pitchFamily="34" charset="-122"/>
-                <a:cs typeface="Carlito" pitchFamily="34" charset="-120"/>
+                <a:latin typeface="Inter" pitchFamily="34" charset="0"/>
+                <a:ea typeface="Inter" pitchFamily="34" charset="-122"/>
+                <a:cs typeface="Inter" pitchFamily="34" charset="-120"/>
               </a:rPr>
               <a:t>60% · Фон</a:t>
             </a:r>
@@ -13364,9 +13376,9 @@
                 <a:solidFill>
                   <a:srgbClr val="1A1F2E"/>
                 </a:solidFill>
-                <a:latin typeface="Carlito" pitchFamily="34" charset="0"/>
-                <a:ea typeface="Carlito" pitchFamily="34" charset="-122"/>
-                <a:cs typeface="Carlito" pitchFamily="34" charset="-120"/>
+                <a:latin typeface="Inter" pitchFamily="34" charset="0"/>
+                <a:ea typeface="Inter" pitchFamily="34" charset="-122"/>
+                <a:cs typeface="Inter" pitchFamily="34" charset="-120"/>
               </a:rPr>
               <a:t>30% · Контейнеры</a:t>
             </a:r>
@@ -13436,9 +13448,9 @@
                 <a:solidFill>
                   <a:srgbClr val="FFFFFF"/>
                 </a:solidFill>
-                <a:latin typeface="Carlito" pitchFamily="34" charset="0"/>
-                <a:ea typeface="Carlito" pitchFamily="34" charset="-122"/>
-                <a:cs typeface="Carlito" pitchFamily="34" charset="-120"/>
+                <a:latin typeface="Inter" pitchFamily="34" charset="0"/>
+                <a:ea typeface="Inter" pitchFamily="34" charset="-122"/>
+                <a:cs typeface="Inter" pitchFamily="34" charset="-120"/>
               </a:rPr>
               <a:t>10% · Акценты</a:t>
             </a:r>
@@ -13517,9 +13529,9 @@
                 <a:solidFill>
                   <a:srgbClr val="46B0A3"/>
                 </a:solidFill>
-                <a:latin typeface="Carlito" pitchFamily="34" charset="0"/>
-                <a:ea typeface="Carlito" pitchFamily="34" charset="-122"/>
-                <a:cs typeface="Carlito" pitchFamily="34" charset="-120"/>
+                <a:latin typeface="Inter" pitchFamily="34" charset="0"/>
+                <a:ea typeface="Inter" pitchFamily="34" charset="-122"/>
+                <a:cs typeface="Inter" pitchFamily="34" charset="-120"/>
               </a:rPr>
               <a:t>60% — ФОН (БАЗА)</a:t>
             </a:r>
@@ -13596,7 +13608,7 @@
         <p:spPr>
           <a:xfrm>
             <a:off x="1443038" y="2609031"/>
-            <a:ext cx="698055" cy="133972"/>
+            <a:ext cx="753523" cy="133972"/>
           </a:xfrm>
           <a:prstGeom prst="rect">
             <a:avLst/>
@@ -13639,8 +13651,8 @@
         </p:nvSpPr>
         <p:spPr>
           <a:xfrm>
-            <a:off x="1418973" y="2770436"/>
-            <a:ext cx="746185" cy="170021"/>
+            <a:off x="1443038" y="2770436"/>
+            <a:ext cx="753523" cy="170021"/>
           </a:xfrm>
           <a:prstGeom prst="rect">
             <a:avLst/>
@@ -13705,9 +13717,9 @@
                 <a:solidFill>
                   <a:srgbClr val="1A1F2E"/>
                 </a:solidFill>
-                <a:latin typeface="Carlito" pitchFamily="34" charset="0"/>
-                <a:ea typeface="Carlito" pitchFamily="34" charset="-122"/>
-                <a:cs typeface="Carlito" pitchFamily="34" charset="-120"/>
+                <a:latin typeface="Inter" pitchFamily="34" charset="0"/>
+                <a:ea typeface="Inter" pitchFamily="34" charset="-122"/>
+                <a:cs typeface="Inter" pitchFamily="34" charset="-120"/>
               </a:rPr>
               <a:t>Фоновое пространство</a:t>
             </a:r>
@@ -13747,9 +13759,9 @@
                 <a:solidFill>
                   <a:srgbClr val="4A5468"/>
                 </a:solidFill>
-                <a:latin typeface="Carlito" pitchFamily="34" charset="0"/>
-                <a:ea typeface="Carlito" pitchFamily="34" charset="-122"/>
-                <a:cs typeface="Carlito" pitchFamily="34" charset="-120"/>
+                <a:latin typeface="Inter" pitchFamily="34" charset="0"/>
+                <a:ea typeface="Inter" pitchFamily="34" charset="-122"/>
+                <a:cs typeface="Inter" pitchFamily="34" charset="-120"/>
               </a:rPr>
               <a:t>Умеренный матовый серый. Не бликует и не утомляет глаза при длительной работе.</a:t>
             </a:r>
@@ -13828,9 +13840,9 @@
                 <a:solidFill>
                   <a:srgbClr val="46B0A3"/>
                 </a:solidFill>
-                <a:latin typeface="Carlito" pitchFamily="34" charset="0"/>
-                <a:ea typeface="Carlito" pitchFamily="34" charset="-122"/>
-                <a:cs typeface="Carlito" pitchFamily="34" charset="-120"/>
+                <a:latin typeface="Inter" pitchFamily="34" charset="0"/>
+                <a:ea typeface="Inter" pitchFamily="34" charset="-122"/>
+                <a:cs typeface="Inter" pitchFamily="34" charset="-120"/>
               </a:rPr>
               <a:t>30% — КОНТЕЙНЕРЫ</a:t>
             </a:r>
@@ -13907,7 +13919,7 @@
         <p:spPr>
           <a:xfrm>
             <a:off x="4229100" y="2609031"/>
-            <a:ext cx="697793" cy="133972"/>
+            <a:ext cx="761895" cy="133972"/>
           </a:xfrm>
           <a:prstGeom prst="rect">
             <a:avLst/>
@@ -13932,9 +13944,9 @@
                 <a:solidFill>
                   <a:srgbClr val="8B95A7"/>
                 </a:solidFill>
-                <a:latin typeface="Carlito" pitchFamily="34" charset="0"/>
-                <a:ea typeface="Carlito" pitchFamily="34" charset="-122"/>
-                <a:cs typeface="Carlito" pitchFamily="34" charset="-120"/>
+                <a:latin typeface="Inter" pitchFamily="34" charset="0"/>
+                <a:ea typeface="Inter" pitchFamily="34" charset="-122"/>
+                <a:cs typeface="Inter" pitchFamily="34" charset="-120"/>
               </a:rPr>
               <a:t>Light: #FFFFFF</a:t>
             </a:r>
@@ -13950,8 +13962,8 @@
         </p:nvSpPr>
         <p:spPr>
           <a:xfrm>
-            <a:off x="4204904" y="2770436"/>
-            <a:ext cx="746185" cy="170021"/>
+            <a:off x="4229100" y="2770436"/>
+            <a:ext cx="761895" cy="170021"/>
           </a:xfrm>
           <a:prstGeom prst="rect">
             <a:avLst/>
@@ -14016,9 +14028,9 @@
                 <a:solidFill>
                   <a:srgbClr val="1A1F2E"/>
                 </a:solidFill>
-                <a:latin typeface="Carlito" pitchFamily="34" charset="0"/>
-                <a:ea typeface="Carlito" pitchFamily="34" charset="-122"/>
-                <a:cs typeface="Carlito" pitchFamily="34" charset="-120"/>
+                <a:latin typeface="Inter" pitchFamily="34" charset="0"/>
+                <a:ea typeface="Inter" pitchFamily="34" charset="-122"/>
+                <a:cs typeface="Inter" pitchFamily="34" charset="-120"/>
               </a:rPr>
               <a:t>Карточки и панели</a:t>
             </a:r>
@@ -14058,9 +14070,9 @@
                 <a:solidFill>
                   <a:srgbClr val="4A5468"/>
                 </a:solidFill>
-                <a:latin typeface="Carlito" pitchFamily="34" charset="0"/>
-                <a:ea typeface="Carlito" pitchFamily="34" charset="-122"/>
-                <a:cs typeface="Carlito" pitchFamily="34" charset="-120"/>
+                <a:latin typeface="Inter" pitchFamily="34" charset="0"/>
+                <a:ea typeface="Inter" pitchFamily="34" charset="-122"/>
+                <a:cs typeface="Inter" pitchFamily="34" charset="-120"/>
               </a:rPr>
               <a:t>Чистый белый / глубокий тёмно-серый. Формируют структуру интерфейса.</a:t>
             </a:r>
@@ -14139,9 +14151,9 @@
                 <a:solidFill>
                   <a:srgbClr val="46B0A3"/>
                 </a:solidFill>
-                <a:latin typeface="Carlito" pitchFamily="34" charset="0"/>
-                <a:ea typeface="Carlito" pitchFamily="34" charset="-122"/>
-                <a:cs typeface="Carlito" pitchFamily="34" charset="-120"/>
+                <a:latin typeface="Inter" pitchFamily="34" charset="0"/>
+                <a:ea typeface="Inter" pitchFamily="34" charset="-122"/>
+                <a:cs typeface="Inter" pitchFamily="34" charset="-120"/>
               </a:rPr>
               <a:t>10% — АКЦЕНТЫ И ДЕЙСТВИЯ</a:t>
             </a:r>
@@ -14229,7 +14241,7 @@
         <p:spPr>
           <a:xfrm>
             <a:off x="7015163" y="2609031"/>
-            <a:ext cx="798656" cy="133972"/>
+            <a:ext cx="853992" cy="133972"/>
           </a:xfrm>
           <a:prstGeom prst="rect">
             <a:avLst/>
@@ -14273,7 +14285,7 @@
         <p:spPr>
           <a:xfrm>
             <a:off x="7015163" y="2770436"/>
-            <a:ext cx="872252" cy="170021"/>
+            <a:ext cx="932688" cy="170021"/>
           </a:xfrm>
           <a:prstGeom prst="rect">
             <a:avLst/>
@@ -14296,9 +14308,9 @@
                 <a:solidFill>
                   <a:srgbClr val="8B95A7"/>
                 </a:solidFill>
-                <a:latin typeface="Carlito" pitchFamily="34" charset="0"/>
-                <a:ea typeface="Carlito" pitchFamily="34" charset="-122"/>
-                <a:cs typeface="Carlito" pitchFamily="34" charset="-120"/>
+                <a:latin typeface="Inter" pitchFamily="34" charset="0"/>
+                <a:ea typeface="Inter" pitchFamily="34" charset="-122"/>
+                <a:cs typeface="Inter" pitchFamily="34" charset="-120"/>
               </a:rPr>
               <a:t>+ статусы</a:t>
             </a:r>
@@ -14338,9 +14350,9 @@
                 <a:solidFill>
                   <a:srgbClr val="1A1F2E"/>
                 </a:solidFill>
-                <a:latin typeface="Carlito" pitchFamily="34" charset="0"/>
-                <a:ea typeface="Carlito" pitchFamily="34" charset="-122"/>
-                <a:cs typeface="Carlito" pitchFamily="34" charset="-120"/>
+                <a:latin typeface="Inter" pitchFamily="34" charset="0"/>
+                <a:ea typeface="Inter" pitchFamily="34" charset="-122"/>
+                <a:cs typeface="Inter" pitchFamily="34" charset="-120"/>
               </a:rPr>
               <a:t>Точечные действия</a:t>
             </a:r>
@@ -14357,7 +14369,7 @@
         <p:spPr>
           <a:xfrm>
             <a:off x="6200775" y="3479453"/>
-            <a:ext cx="2314575" cy="329184"/>
+            <a:ext cx="2314575" cy="344016"/>
           </a:xfrm>
           <a:prstGeom prst="rect">
             <a:avLst/>
@@ -14380,9 +14392,9 @@
                 <a:solidFill>
                   <a:srgbClr val="4A5468"/>
                 </a:solidFill>
-                <a:latin typeface="Carlito" pitchFamily="34" charset="0"/>
-                <a:ea typeface="Carlito" pitchFamily="34" charset="-122"/>
-                <a:cs typeface="Carlito" pitchFamily="34" charset="-120"/>
+                <a:latin typeface="Inter" pitchFamily="34" charset="0"/>
+                <a:ea typeface="Inter" pitchFamily="34" charset="-122"/>
+                <a:cs typeface="Inter" pitchFamily="34" charset="-120"/>
               </a:rPr>
               <a:t>Фирменный Тиффани #5ECEC1 и статусы. Строго: кнопки, активные ссылки, иконки с прозрачностью.</a:t>
             </a:r>
@@ -14399,7 +14411,7 @@
         <p:spPr>
           <a:xfrm>
             <a:off x="257175" y="200025"/>
-            <a:ext cx="1257779" cy="169999"/>
+            <a:ext cx="1152902" cy="169999"/>
           </a:xfrm>
           <a:prstGeom prst="rect">
             <a:avLst/>
@@ -14422,9 +14434,9 @@
                 <a:solidFill>
                   <a:srgbClr val="8B95A7"/>
                 </a:solidFill>
-                <a:latin typeface="Carlito" pitchFamily="34" charset="0"/>
-                <a:ea typeface="Carlito" pitchFamily="34" charset="-122"/>
-                <a:cs typeface="Carlito" pitchFamily="34" charset="-120"/>
+                <a:latin typeface="Inter" pitchFamily="34" charset="0"/>
+                <a:ea typeface="Inter" pitchFamily="34" charset="-122"/>
+                <a:cs typeface="Inter" pitchFamily="34" charset="-120"/>
               </a:rPr>
               <a:t>МИС АЛЬТЕРА</a:t>
             </a:r>
@@ -14440,8 +14452,8 @@
         </p:nvSpPr>
         <p:spPr>
           <a:xfrm>
-            <a:off x="8508095" y="4799595"/>
-            <a:ext cx="542768" cy="169999"/>
+            <a:off x="8534772" y="4799595"/>
+            <a:ext cx="504536" cy="169999"/>
           </a:xfrm>
           <a:prstGeom prst="rect">
             <a:avLst/>
@@ -14596,9 +14608,9 @@
                 <a:solidFill>
                   <a:srgbClr val="46B0A3"/>
                 </a:solidFill>
-                <a:latin typeface="Carlito" pitchFamily="34" charset="0"/>
-                <a:ea typeface="Carlito" pitchFamily="34" charset="-122"/>
-                <a:cs typeface="Carlito" pitchFamily="34" charset="-120"/>
+                <a:latin typeface="Inter" pitchFamily="34" charset="0"/>
+                <a:ea typeface="Inter" pitchFamily="34" charset="-122"/>
+                <a:cs typeface="Inter" pitchFamily="34" charset="-120"/>
               </a:rPr>
               <a:t>06 — СТАТУСЫ И ПОЛИГРАФИЯ</a:t>
             </a:r>
@@ -14638,9 +14650,9 @@
                 <a:solidFill>
                   <a:srgbClr val="1A1F2E"/>
                 </a:solidFill>
-                <a:latin typeface="Tinos" pitchFamily="34" charset="0"/>
-                <a:ea typeface="Tinos" pitchFamily="34" charset="-122"/>
-                <a:cs typeface="Tinos" pitchFamily="34" charset="-120"/>
+                <a:latin typeface="Playfair Display" pitchFamily="34" charset="0"/>
+                <a:ea typeface="Playfair Display" pitchFamily="34" charset="-122"/>
+                <a:cs typeface="Playfair Display" pitchFamily="34" charset="-120"/>
               </a:rPr>
               <a:t>Семантика цвета и полиграфия.</a:t>
             </a:r>
@@ -14680,9 +14692,9 @@
                 <a:solidFill>
                   <a:srgbClr val="4A5468"/>
                 </a:solidFill>
-                <a:latin typeface="Carlito" pitchFamily="34" charset="0"/>
-                <a:ea typeface="Carlito" pitchFamily="34" charset="-122"/>
-                <a:cs typeface="Carlito" pitchFamily="34" charset="-120"/>
+                <a:latin typeface="Inter" pitchFamily="34" charset="0"/>
+                <a:ea typeface="Inter" pitchFamily="34" charset="-122"/>
+                <a:cs typeface="Inter" pitchFamily="34" charset="-120"/>
               </a:rPr>
               <a:t>Статусные цвета несут операционный смысл. В полиграфии пропорции инвертируются для премиального ощущения.</a:t>
             </a:r>
@@ -14722,9 +14734,9 @@
                 <a:solidFill>
                   <a:srgbClr val="8B95A7"/>
                 </a:solidFill>
-                <a:latin typeface="Carlito" pitchFamily="34" charset="0"/>
-                <a:ea typeface="Carlito" pitchFamily="34" charset="-122"/>
-                <a:cs typeface="Carlito" pitchFamily="34" charset="-120"/>
+                <a:latin typeface="Inter" pitchFamily="34" charset="0"/>
+                <a:ea typeface="Inter" pitchFamily="34" charset="-122"/>
+                <a:cs typeface="Inter" pitchFamily="34" charset="-120"/>
               </a:rPr>
               <a:t>СТАТУСНЫЕ ЦВЕТА (ИНТЕРФЕЙС)</a:t>
             </a:r>
@@ -14842,9 +14854,9 @@
                 <a:solidFill>
                   <a:srgbClr val="FFFFFF"/>
                 </a:solidFill>
-                <a:latin typeface="Carlito" pitchFamily="34" charset="0"/>
-                <a:ea typeface="Carlito" pitchFamily="34" charset="-122"/>
-                <a:cs typeface="Carlito" pitchFamily="34" charset="-120"/>
+                <a:latin typeface="Inter" pitchFamily="34" charset="0"/>
+                <a:ea typeface="Inter" pitchFamily="34" charset="-122"/>
+                <a:cs typeface="Inter" pitchFamily="34" charset="-120"/>
               </a:rPr>
               <a:t>Успех</a:t>
             </a:r>
@@ -15006,9 +15018,9 @@
                 <a:solidFill>
                   <a:srgbClr val="FFFFFF"/>
                 </a:solidFill>
-                <a:latin typeface="Carlito" pitchFamily="34" charset="0"/>
-                <a:ea typeface="Carlito" pitchFamily="34" charset="-122"/>
-                <a:cs typeface="Carlito" pitchFamily="34" charset="-120"/>
+                <a:latin typeface="Inter" pitchFamily="34" charset="0"/>
+                <a:ea typeface="Inter" pitchFamily="34" charset="-122"/>
+                <a:cs typeface="Inter" pitchFamily="34" charset="-120"/>
               </a:rPr>
               <a:t>Предупреждение</a:t>
             </a:r>
@@ -15170,9 +15182,9 @@
                 <a:solidFill>
                   <a:srgbClr val="FFFFFF"/>
                 </a:solidFill>
-                <a:latin typeface="Carlito" pitchFamily="34" charset="0"/>
-                <a:ea typeface="Carlito" pitchFamily="34" charset="-122"/>
-                <a:cs typeface="Carlito" pitchFamily="34" charset="-120"/>
+                <a:latin typeface="Inter" pitchFamily="34" charset="0"/>
+                <a:ea typeface="Inter" pitchFamily="34" charset="-122"/>
+                <a:cs typeface="Inter" pitchFamily="34" charset="-120"/>
               </a:rPr>
               <a:t>Ошибка</a:t>
             </a:r>
@@ -15334,9 +15346,9 @@
                 <a:solidFill>
                   <a:srgbClr val="FFFFFF"/>
                 </a:solidFill>
-                <a:latin typeface="Carlito" pitchFamily="34" charset="0"/>
-                <a:ea typeface="Carlito" pitchFamily="34" charset="-122"/>
-                <a:cs typeface="Carlito" pitchFamily="34" charset="-120"/>
+                <a:latin typeface="Inter" pitchFamily="34" charset="0"/>
+                <a:ea typeface="Inter" pitchFamily="34" charset="-122"/>
+                <a:cs typeface="Inter" pitchFamily="34" charset="-120"/>
               </a:rPr>
               <a:t>Информация</a:t>
             </a:r>
@@ -15498,9 +15510,9 @@
                 <a:solidFill>
                   <a:srgbClr val="FFFFFF"/>
                 </a:solidFill>
-                <a:latin typeface="Carlito" pitchFamily="34" charset="0"/>
-                <a:ea typeface="Carlito" pitchFamily="34" charset="-122"/>
-                <a:cs typeface="Carlito" pitchFamily="34" charset="-120"/>
+                <a:latin typeface="Inter" pitchFamily="34" charset="0"/>
+                <a:ea typeface="Inter" pitchFamily="34" charset="-122"/>
+                <a:cs typeface="Inter" pitchFamily="34" charset="-120"/>
               </a:rPr>
               <a:t>Выделение</a:t>
             </a:r>
@@ -15664,9 +15676,9 @@
                 <a:solidFill>
                   <a:srgbClr val="FFFFFF"/>
                 </a:solidFill>
-                <a:latin typeface="Carlito" pitchFamily="34" charset="0"/>
-                <a:ea typeface="Carlito" pitchFamily="34" charset="-122"/>
-                <a:cs typeface="Carlito" pitchFamily="34" charset="-120"/>
+                <a:latin typeface="Inter" pitchFamily="34" charset="0"/>
+                <a:ea typeface="Inter" pitchFamily="34" charset="-122"/>
+                <a:cs typeface="Inter" pitchFamily="34" charset="-120"/>
               </a:rPr>
               <a:t>Премиум</a:t>
             </a:r>
@@ -15708,9 +15720,9 @@
                     <a:alpha val="90000"/>
                   </a:srgbClr>
                 </a:solidFill>
-                <a:latin typeface="Carlito" pitchFamily="34" charset="0"/>
-                <a:ea typeface="Carlito" pitchFamily="34" charset="-122"/>
-                <a:cs typeface="Carlito" pitchFamily="34" charset="-120"/>
+                <a:latin typeface="Inter" pitchFamily="34" charset="0"/>
+                <a:ea typeface="Inter" pitchFamily="34" charset="-122"/>
+                <a:cs typeface="Inter" pitchFamily="34" charset="-120"/>
               </a:rPr>
               <a:t>тёмная тема</a:t>
             </a:r>
@@ -15833,9 +15845,9 @@
                 <a:solidFill>
                   <a:srgbClr val="1A1F2E"/>
                 </a:solidFill>
-                <a:latin typeface="Carlito" pitchFamily="34" charset="0"/>
-                <a:ea typeface="Carlito" pitchFamily="34" charset="-122"/>
-                <a:cs typeface="Carlito" pitchFamily="34" charset="-120"/>
+                <a:latin typeface="Inter" pitchFamily="34" charset="0"/>
+                <a:ea typeface="Inter" pitchFamily="34" charset="-122"/>
+                <a:cs typeface="Inter" pitchFamily="34" charset="-120"/>
               </a:rPr>
               <a:t>Правило для полиграфии (Offline)</a:t>
             </a:r>
@@ -15852,7 +15864,7 @@
         <p:spPr>
           <a:xfrm>
             <a:off x="628650" y="3015779"/>
-            <a:ext cx="3707606" cy="339999"/>
+            <a:ext cx="3707606" cy="509998"/>
           </a:xfrm>
           <a:prstGeom prst="rect">
             <a:avLst/>
@@ -15875,9 +15887,9 @@
                 <a:solidFill>
                   <a:srgbClr val="4A5468"/>
                 </a:solidFill>
-                <a:latin typeface="Carlito" pitchFamily="34" charset="0"/>
-                <a:ea typeface="Carlito" pitchFamily="34" charset="-122"/>
-                <a:cs typeface="Carlito" pitchFamily="34" charset="-120"/>
+                <a:latin typeface="Inter" pitchFamily="34" charset="0"/>
+                <a:ea typeface="Inter" pitchFamily="34" charset="-122"/>
+                <a:cs typeface="Inter" pitchFamily="34" charset="-120"/>
               </a:rPr>
               <a:t>В печати пропорции инвертируются для премиального ощущения. В визитках, буклетах и упаковке #5ECEC1 может становиться доминирующим (60%) фоном.</a:t>
             </a:r>
@@ -15893,8 +15905,8 @@
         </p:nvSpPr>
         <p:spPr>
           <a:xfrm>
-            <a:off x="628650" y="3389263"/>
-            <a:ext cx="2224497" cy="200025"/>
+            <a:off x="628650" y="3533142"/>
+            <a:ext cx="2224497" cy="123453"/>
           </a:xfrm>
           <a:prstGeom prst="rect">
             <a:avLst/>
@@ -15923,8 +15935,8 @@
         </p:nvSpPr>
         <p:spPr>
           <a:xfrm>
-            <a:off x="2853147" y="3389263"/>
-            <a:ext cx="1112193" cy="200025"/>
+            <a:off x="2853147" y="3533142"/>
+            <a:ext cx="1112193" cy="123453"/>
           </a:xfrm>
           <a:prstGeom prst="rect">
             <a:avLst/>
@@ -15953,8 +15965,8 @@
         </p:nvSpPr>
         <p:spPr>
           <a:xfrm>
-            <a:off x="3965339" y="3389263"/>
-            <a:ext cx="370694" cy="200025"/>
+            <a:off x="3965339" y="3533142"/>
+            <a:ext cx="370694" cy="123453"/>
           </a:xfrm>
           <a:prstGeom prst="rect">
             <a:avLst/>
@@ -15983,17 +15995,17 @@
         </p:nvSpPr>
         <p:spPr>
           <a:xfrm>
-            <a:off x="628650" y="3632150"/>
-            <a:ext cx="1516707" cy="170078"/>
-          </a:xfrm>
-          <a:prstGeom prst="rect">
-            <a:avLst/>
-          </a:prstGeom>
-          <a:noFill/>
-          <a:ln/>
-        </p:spPr>
-        <p:txBody>
-          <a:bodyPr wrap="square" lIns="0" tIns="0" rIns="0" bIns="0" rtlCol="0" anchor="t"/>
+            <a:off x="628650" y="3699458"/>
+            <a:ext cx="1526642" cy="110728"/>
+          </a:xfrm>
+          <a:prstGeom prst="rect">
+            <a:avLst/>
+          </a:prstGeom>
+          <a:noFill/>
+          <a:ln/>
+        </p:spPr>
+        <p:txBody>
+          <a:bodyPr wrap="none" lIns="0" tIns="0" rIns="0" bIns="0" rtlCol="0" anchor="t"/>
           <a:lstStyle/>
           <a:p>
             <a:pPr algn="l" indent="0" marL="0">
@@ -16025,8 +16037,8 @@
         </p:nvSpPr>
         <p:spPr>
           <a:xfrm>
-            <a:off x="2159645" y="3632150"/>
-            <a:ext cx="1431206" cy="170078"/>
+            <a:off x="2169579" y="3699458"/>
+            <a:ext cx="1422276" cy="110728"/>
           </a:xfrm>
           <a:prstGeom prst="rect">
             <a:avLst/>
@@ -16067,8 +16079,8 @@
         </p:nvSpPr>
         <p:spPr>
           <a:xfrm>
-            <a:off x="3605138" y="3632150"/>
-            <a:ext cx="731118" cy="170078"/>
+            <a:off x="3606143" y="3699458"/>
+            <a:ext cx="730114" cy="110728"/>
           </a:xfrm>
           <a:prstGeom prst="rect">
             <a:avLst/>
@@ -16172,9 +16184,9 @@
                 <a:solidFill>
                   <a:srgbClr val="1A1F2E"/>
                 </a:solidFill>
-                <a:latin typeface="Carlito" pitchFamily="34" charset="0"/>
-                <a:ea typeface="Carlito" pitchFamily="34" charset="-122"/>
-                <a:cs typeface="Carlito" pitchFamily="34" charset="-120"/>
+                <a:latin typeface="Inter" pitchFamily="34" charset="0"/>
+                <a:ea typeface="Inter" pitchFamily="34" charset="-122"/>
+                <a:cs typeface="Inter" pitchFamily="34" charset="-120"/>
               </a:rPr>
               <a:t>Технические коды для типографий</a:t>
             </a:r>
@@ -16216,9 +16228,9 @@
                 <a:solidFill>
                   <a:srgbClr val="8B95A7"/>
                 </a:solidFill>
-                <a:latin typeface="Carlito" pitchFamily="34" charset="0"/>
-                <a:ea typeface="Carlito" pitchFamily="34" charset="-122"/>
-                <a:cs typeface="Carlito" pitchFamily="34" charset="-120"/>
+                <a:latin typeface="Inter" pitchFamily="34" charset="0"/>
+                <a:ea typeface="Inter" pitchFamily="34" charset="-122"/>
+                <a:cs typeface="Inter" pitchFamily="34" charset="-120"/>
               </a:rPr>
               <a:t>CMYK</a:t>
             </a:r>
@@ -16434,9 +16446,9 @@
                 <a:solidFill>
                   <a:srgbClr val="8B95A7"/>
                 </a:solidFill>
-                <a:latin typeface="Carlito" pitchFamily="34" charset="0"/>
-                <a:ea typeface="Carlito" pitchFamily="34" charset="-122"/>
-                <a:cs typeface="Carlito" pitchFamily="34" charset="-120"/>
+                <a:latin typeface="Inter" pitchFamily="34" charset="0"/>
+                <a:ea typeface="Inter" pitchFamily="34" charset="-122"/>
+                <a:cs typeface="Inter" pitchFamily="34" charset="-120"/>
               </a:rPr>
               <a:t>PANTONE</a:t>
             </a:r>
@@ -16520,9 +16532,9 @@
                 <a:solidFill>
                   <a:srgbClr val="8B95A7"/>
                 </a:solidFill>
-                <a:latin typeface="Carlito" pitchFamily="34" charset="0"/>
-                <a:ea typeface="Carlito" pitchFamily="34" charset="-122"/>
-                <a:cs typeface="Carlito" pitchFamily="34" charset="-120"/>
+                <a:latin typeface="Inter" pitchFamily="34" charset="0"/>
+                <a:ea typeface="Inter" pitchFamily="34" charset="-122"/>
+                <a:cs typeface="Inter" pitchFamily="34" charset="-120"/>
               </a:rPr>
               <a:t>ближайший аналог</a:t>
             </a:r>
@@ -16618,7 +16630,7 @@
         <p:spPr>
           <a:xfrm>
             <a:off x="257175" y="200025"/>
-            <a:ext cx="1257779" cy="169999"/>
+            <a:ext cx="1152902" cy="169999"/>
           </a:xfrm>
           <a:prstGeom prst="rect">
             <a:avLst/>
@@ -16641,9 +16653,9 @@
                 <a:solidFill>
                   <a:srgbClr val="8B95A7"/>
                 </a:solidFill>
-                <a:latin typeface="Carlito" pitchFamily="34" charset="0"/>
-                <a:ea typeface="Carlito" pitchFamily="34" charset="-122"/>
-                <a:cs typeface="Carlito" pitchFamily="34" charset="-120"/>
+                <a:latin typeface="Inter" pitchFamily="34" charset="0"/>
+                <a:ea typeface="Inter" pitchFamily="34" charset="-122"/>
+                <a:cs typeface="Inter" pitchFamily="34" charset="-120"/>
               </a:rPr>
               <a:t>МИС АЛЬТЕРА</a:t>
             </a:r>
@@ -16659,8 +16671,8 @@
         </p:nvSpPr>
         <p:spPr>
           <a:xfrm>
-            <a:off x="8508095" y="4799595"/>
-            <a:ext cx="542768" cy="169999"/>
+            <a:off x="8534772" y="4799595"/>
+            <a:ext cx="504536" cy="169999"/>
           </a:xfrm>
           <a:prstGeom prst="rect">
             <a:avLst/>
@@ -16815,9 +16827,9 @@
                 <a:solidFill>
                   <a:srgbClr val="46B0A3"/>
                 </a:solidFill>
-                <a:latin typeface="Carlito" pitchFamily="34" charset="0"/>
-                <a:ea typeface="Carlito" pitchFamily="34" charset="-122"/>
-                <a:cs typeface="Carlito" pitchFamily="34" charset="-120"/>
+                <a:latin typeface="Inter" pitchFamily="34" charset="0"/>
+                <a:ea typeface="Inter" pitchFamily="34" charset="-122"/>
+                <a:cs typeface="Inter" pitchFamily="34" charset="-120"/>
               </a:rPr>
               <a:t>07 — ТИПОГРАФИКА</a:t>
             </a:r>
@@ -16857,9 +16869,9 @@
                 <a:solidFill>
                   <a:srgbClr val="1A1F2E"/>
                 </a:solidFill>
-                <a:latin typeface="Tinos" pitchFamily="34" charset="0"/>
-                <a:ea typeface="Tinos" pitchFamily="34" charset="-122"/>
-                <a:cs typeface="Tinos" pitchFamily="34" charset="-120"/>
+                <a:latin typeface="Playfair Display" pitchFamily="34" charset="0"/>
+                <a:ea typeface="Playfair Display" pitchFamily="34" charset="-122"/>
+                <a:cs typeface="Playfair Display" pitchFamily="34" charset="-120"/>
               </a:rPr>
               <a:t>Фирменный шрифт.</a:t>
             </a:r>
@@ -16899,9 +16911,9 @@
                 <a:solidFill>
                   <a:srgbClr val="4A5468"/>
                 </a:solidFill>
-                <a:latin typeface="Carlito" pitchFamily="34" charset="0"/>
-                <a:ea typeface="Carlito" pitchFamily="34" charset="-122"/>
-                <a:cs typeface="Carlito" pitchFamily="34" charset="-120"/>
+                <a:latin typeface="Inter" pitchFamily="34" charset="0"/>
+                <a:ea typeface="Inter" pitchFamily="34" charset="-122"/>
+                <a:cs typeface="Inter" pitchFamily="34" charset="-120"/>
               </a:rPr>
               <a:t>Сочетание антиквы для заголовков и современного гротеска для интерфейса. Книжное, классическое доверие медицины — при технологичной эстетике.</a:t>
             </a:r>
@@ -16956,7 +16968,7 @@
         </p:nvSpPr>
         <p:spPr>
           <a:xfrm>
-            <a:off x="2594679" y="2708932"/>
+            <a:off x="2560634" y="2708932"/>
             <a:ext cx="2472538" cy="1500188"/>
           </a:xfrm>
           <a:prstGeom prst="rect">
@@ -16982,9 +16994,9 @@
                     <a:alpha val="5000"/>
                   </a:srgbClr>
                 </a:solidFill>
-                <a:latin typeface="Tinos" pitchFamily="34" charset="0"/>
-                <a:ea typeface="Tinos" pitchFamily="34" charset="-122"/>
-                <a:cs typeface="Tinos" pitchFamily="34" charset="-120"/>
+                <a:latin typeface="Playfair Display" pitchFamily="34" charset="0"/>
+                <a:ea typeface="Playfair Display" pitchFamily="34" charset="-122"/>
+                <a:cs typeface="Playfair Display" pitchFamily="34" charset="-120"/>
               </a:rPr>
               <a:t>P</a:t>
             </a:r>
@@ -17026,9 +17038,9 @@
                 <a:solidFill>
                   <a:srgbClr val="8B95A7"/>
                 </a:solidFill>
-                <a:latin typeface="Carlito" pitchFamily="34" charset="0"/>
-                <a:ea typeface="Carlito" pitchFamily="34" charset="-122"/>
-                <a:cs typeface="Carlito" pitchFamily="34" charset="-120"/>
+                <a:latin typeface="Inter" pitchFamily="34" charset="0"/>
+                <a:ea typeface="Inter" pitchFamily="34" charset="-122"/>
+                <a:cs typeface="Inter" pitchFamily="34" charset="-120"/>
               </a:rPr>
               <a:t>H1 · H2 · H3 — ЗАГОЛОВКИ</a:t>
             </a:r>
@@ -17070,9 +17082,9 @@
                 <a:solidFill>
                   <a:srgbClr val="1A1F2E"/>
                 </a:solidFill>
-                <a:latin typeface="Tinos" pitchFamily="34" charset="0"/>
-                <a:ea typeface="Tinos" pitchFamily="34" charset="-122"/>
-                <a:cs typeface="Tinos" pitchFamily="34" charset="-120"/>
+                <a:latin typeface="Playfair Display" pitchFamily="34" charset="0"/>
+                <a:ea typeface="Playfair Display" pitchFamily="34" charset="-122"/>
+                <a:cs typeface="Playfair Display" pitchFamily="34" charset="-120"/>
               </a:rPr>
               <a:t>Aa</a:t>
             </a:r>
@@ -17114,9 +17126,9 @@
                 <a:solidFill>
                   <a:srgbClr val="1A1F2E"/>
                 </a:solidFill>
-                <a:latin typeface="Tinos" pitchFamily="34" charset="0"/>
-                <a:ea typeface="Tinos" pitchFamily="34" charset="-122"/>
-                <a:cs typeface="Tinos" pitchFamily="34" charset="-120"/>
+                <a:latin typeface="Playfair Display" pitchFamily="34" charset="0"/>
+                <a:ea typeface="Playfair Display" pitchFamily="34" charset="-122"/>
+                <a:cs typeface="Playfair Display" pitchFamily="34" charset="-120"/>
               </a:rPr>
               <a:t>Playfair Display</a:t>
             </a:r>
@@ -17156,9 +17168,9 @@
                 <a:solidFill>
                   <a:srgbClr val="4A5468"/>
                 </a:solidFill>
-                <a:latin typeface="Carlito" pitchFamily="34" charset="0"/>
-                <a:ea typeface="Carlito" pitchFamily="34" charset="-122"/>
-                <a:cs typeface="Carlito" pitchFamily="34" charset="-120"/>
+                <a:latin typeface="Inter" pitchFamily="34" charset="0"/>
+                <a:ea typeface="Inter" pitchFamily="34" charset="-122"/>
+                <a:cs typeface="Inter" pitchFamily="34" charset="-120"/>
               </a:rPr>
               <a:t>Bold · SemiBold</a:t>
             </a:r>
@@ -17230,9 +17242,9 @@
                 <a:solidFill>
                   <a:srgbClr val="1A1F2E"/>
                 </a:solidFill>
-                <a:latin typeface="Tinos" pitchFamily="34" charset="0"/>
-                <a:ea typeface="Tinos" pitchFamily="34" charset="-122"/>
-                <a:cs typeface="Tinos" pitchFamily="34" charset="-120"/>
+                <a:latin typeface="Playfair Display" pitchFamily="34" charset="0"/>
+                <a:ea typeface="Playfair Display" pitchFamily="34" charset="-122"/>
+                <a:cs typeface="Playfair Display" pitchFamily="34" charset="-120"/>
               </a:rPr>
               <a:t>Технологии, которые заботятся</a:t>
             </a:r>
@@ -17272,9 +17284,9 @@
                 <a:solidFill>
                   <a:srgbClr val="4A5468"/>
                 </a:solidFill>
-                <a:latin typeface="Carlito" pitchFamily="34" charset="0"/>
-                <a:ea typeface="Carlito" pitchFamily="34" charset="-122"/>
-                <a:cs typeface="Carlito" pitchFamily="34" charset="-120"/>
+                <a:latin typeface="Inter" pitchFamily="34" charset="0"/>
+                <a:ea typeface="Inter" pitchFamily="34" charset="-122"/>
+                <a:cs typeface="Inter" pitchFamily="34" charset="-120"/>
               </a:rPr>
               <a:t>Только для крупных заголовков в интерфейсе, презентациях и бланках. Межстрочный интервал — 110%–120% от кегля.</a:t>
             </a:r>
@@ -17355,9 +17367,9 @@
                     <a:alpha val="5000"/>
                   </a:srgbClr>
                 </a:solidFill>
-                <a:latin typeface="Carlito" pitchFamily="34" charset="0"/>
-                <a:ea typeface="Carlito" pitchFamily="34" charset="-122"/>
-                <a:cs typeface="Carlito" pitchFamily="34" charset="-120"/>
+                <a:latin typeface="Inter" pitchFamily="34" charset="0"/>
+                <a:ea typeface="Inter" pitchFamily="34" charset="-122"/>
+                <a:cs typeface="Inter" pitchFamily="34" charset="-120"/>
               </a:rPr>
               <a:t>I</a:t>
             </a:r>
@@ -17399,9 +17411,9 @@
                 <a:solidFill>
                   <a:srgbClr val="8B95A7"/>
                 </a:solidFill>
-                <a:latin typeface="Carlito" pitchFamily="34" charset="0"/>
-                <a:ea typeface="Carlito" pitchFamily="34" charset="-122"/>
-                <a:cs typeface="Carlito" pitchFamily="34" charset="-120"/>
+                <a:latin typeface="Inter" pitchFamily="34" charset="0"/>
+                <a:ea typeface="Inter" pitchFamily="34" charset="-122"/>
+                <a:cs typeface="Inter" pitchFamily="34" charset="-120"/>
               </a:rPr>
               <a:t>ОСНОВНОЙ ТЕКСТ · ИНТЕРФЕЙС</a:t>
             </a:r>
@@ -17443,9 +17455,9 @@
                 <a:solidFill>
                   <a:srgbClr val="1A1F2E"/>
                 </a:solidFill>
-                <a:latin typeface="Carlito" pitchFamily="34" charset="0"/>
-                <a:ea typeface="Carlito" pitchFamily="34" charset="-122"/>
-                <a:cs typeface="Carlito" pitchFamily="34" charset="-120"/>
+                <a:latin typeface="Inter" pitchFamily="34" charset="0"/>
+                <a:ea typeface="Inter" pitchFamily="34" charset="-122"/>
+                <a:cs typeface="Inter" pitchFamily="34" charset="-120"/>
               </a:rPr>
               <a:t>Aa</a:t>
             </a:r>
@@ -17487,9 +17499,9 @@
                 <a:solidFill>
                   <a:srgbClr val="1A1F2E"/>
                 </a:solidFill>
-                <a:latin typeface="Carlito" pitchFamily="34" charset="0"/>
-                <a:ea typeface="Carlito" pitchFamily="34" charset="-122"/>
-                <a:cs typeface="Carlito" pitchFamily="34" charset="-120"/>
+                <a:latin typeface="Inter" pitchFamily="34" charset="0"/>
+                <a:ea typeface="Inter" pitchFamily="34" charset="-122"/>
+                <a:cs typeface="Inter" pitchFamily="34" charset="-120"/>
               </a:rPr>
               <a:t>Inter / Roboto / SF Pro</a:t>
             </a:r>
@@ -17529,9 +17541,9 @@
                 <a:solidFill>
                   <a:srgbClr val="4A5468"/>
                 </a:solidFill>
-                <a:latin typeface="Carlito" pitchFamily="34" charset="0"/>
-                <a:ea typeface="Carlito" pitchFamily="34" charset="-122"/>
-                <a:cs typeface="Carlito" pitchFamily="34" charset="-120"/>
+                <a:latin typeface="Inter" pitchFamily="34" charset="0"/>
+                <a:ea typeface="Inter" pitchFamily="34" charset="-122"/>
+                <a:cs typeface="Inter" pitchFamily="34" charset="-120"/>
               </a:rPr>
               <a:t>Regular · Medium</a:t>
             </a:r>
@@ -17603,9 +17615,9 @@
                 <a:solidFill>
                   <a:srgbClr val="4A5468"/>
                 </a:solidFill>
-                <a:latin typeface="Carlito" pitchFamily="34" charset="0"/>
-                <a:ea typeface="Carlito" pitchFamily="34" charset="-122"/>
-                <a:cs typeface="Carlito" pitchFamily="34" charset="-120"/>
+                <a:latin typeface="Inter" pitchFamily="34" charset="0"/>
+                <a:ea typeface="Inter" pitchFamily="34" charset="-122"/>
+                <a:cs typeface="Inter" pitchFamily="34" charset="-120"/>
               </a:rPr>
               <a:t>Применяется для всех текстов, таблиц, кнопок и меток. Межстрочный интервал — 140%–150% от кегля — необходим для комфортного чтения большого объёма данных.</a:t>
             </a:r>
@@ -17622,7 +17634,7 @@
         <p:spPr>
           <a:xfrm>
             <a:off x="4864894" y="3934902"/>
-            <a:ext cx="538237" cy="287020"/>
+            <a:ext cx="571500" cy="287020"/>
           </a:xfrm>
           <a:prstGeom prst="roundRect">
             <a:avLst>
@@ -17659,7 +17671,7 @@
         <p:spPr>
           <a:xfrm>
             <a:off x="4864894" y="3947703"/>
-            <a:ext cx="538237" cy="261417"/>
+            <a:ext cx="571500" cy="261417"/>
           </a:xfrm>
           <a:prstGeom prst="rect">
             <a:avLst/>
@@ -17682,9 +17694,9 @@
                 <a:solidFill>
                   <a:srgbClr val="FFFFFF"/>
                 </a:solidFill>
-                <a:latin typeface="Carlito" pitchFamily="34" charset="0"/>
-                <a:ea typeface="Carlito" pitchFamily="34" charset="-122"/>
-                <a:cs typeface="Carlito" pitchFamily="34" charset="-120"/>
+                <a:latin typeface="Inter" pitchFamily="34" charset="0"/>
+                <a:ea typeface="Inter" pitchFamily="34" charset="-122"/>
+                <a:cs typeface="Inter" pitchFamily="34" charset="-120"/>
               </a:rPr>
               <a:t>Primary</a:t>
             </a:r>
@@ -17700,8 +17712,8 @@
         </p:nvSpPr>
         <p:spPr>
           <a:xfrm>
-            <a:off x="5460281" y="3934902"/>
-            <a:ext cx="652760" cy="287020"/>
+            <a:off x="5493544" y="3934902"/>
+            <a:ext cx="685800" cy="287020"/>
           </a:xfrm>
           <a:prstGeom prst="roundRect">
             <a:avLst>
@@ -17735,8 +17747,8 @@
         </p:nvSpPr>
         <p:spPr>
           <a:xfrm>
-            <a:off x="5460281" y="3947703"/>
-            <a:ext cx="652760" cy="261417"/>
+            <a:off x="5493544" y="3947703"/>
+            <a:ext cx="685800" cy="261417"/>
           </a:xfrm>
           <a:prstGeom prst="rect">
             <a:avLst/>
@@ -17759,9 +17771,9 @@
                 <a:solidFill>
                   <a:srgbClr val="46B0A3"/>
                 </a:solidFill>
-                <a:latin typeface="Carlito" pitchFamily="34" charset="0"/>
-                <a:ea typeface="Carlito" pitchFamily="34" charset="-122"/>
-                <a:cs typeface="Carlito" pitchFamily="34" charset="-120"/>
+                <a:latin typeface="Inter" pitchFamily="34" charset="0"/>
+                <a:ea typeface="Inter" pitchFamily="34" charset="-122"/>
+                <a:cs typeface="Inter" pitchFamily="34" charset="-120"/>
               </a:rPr>
               <a:t>Secondary</a:t>
             </a:r>
@@ -17777,8 +17789,8 @@
         </p:nvSpPr>
         <p:spPr>
           <a:xfrm>
-            <a:off x="6170191" y="3934902"/>
-            <a:ext cx="523949" cy="287020"/>
+            <a:off x="6236494" y="3934902"/>
+            <a:ext cx="564356" cy="287020"/>
           </a:xfrm>
           <a:prstGeom prst="roundRect">
             <a:avLst>
@@ -17814,8 +17826,8 @@
         </p:nvSpPr>
         <p:spPr>
           <a:xfrm>
-            <a:off x="6170191" y="3947703"/>
-            <a:ext cx="523949" cy="261417"/>
+            <a:off x="6236494" y="3947703"/>
+            <a:ext cx="564356" cy="261417"/>
           </a:xfrm>
           <a:prstGeom prst="rect">
             <a:avLst/>
@@ -17838,9 +17850,9 @@
                 <a:solidFill>
                   <a:srgbClr val="4A5468"/>
                 </a:solidFill>
-                <a:latin typeface="Carlito" pitchFamily="34" charset="0"/>
-                <a:ea typeface="Carlito" pitchFamily="34" charset="-122"/>
-                <a:cs typeface="Carlito" pitchFamily="34" charset="-120"/>
+                <a:latin typeface="Inter" pitchFamily="34" charset="0"/>
+                <a:ea typeface="Inter" pitchFamily="34" charset="-122"/>
+                <a:cs typeface="Inter" pitchFamily="34" charset="-120"/>
               </a:rPr>
               <a:t>Tertiary</a:t>
             </a:r>
@@ -17857,7 +17869,7 @@
         <p:spPr>
           <a:xfrm>
             <a:off x="257175" y="200025"/>
-            <a:ext cx="1257779" cy="169999"/>
+            <a:ext cx="1152902" cy="169999"/>
           </a:xfrm>
           <a:prstGeom prst="rect">
             <a:avLst/>
@@ -17880,9 +17892,9 @@
                 <a:solidFill>
                   <a:srgbClr val="8B95A7"/>
                 </a:solidFill>
-                <a:latin typeface="Carlito" pitchFamily="34" charset="0"/>
-                <a:ea typeface="Carlito" pitchFamily="34" charset="-122"/>
-                <a:cs typeface="Carlito" pitchFamily="34" charset="-120"/>
+                <a:latin typeface="Inter" pitchFamily="34" charset="0"/>
+                <a:ea typeface="Inter" pitchFamily="34" charset="-122"/>
+                <a:cs typeface="Inter" pitchFamily="34" charset="-120"/>
               </a:rPr>
               <a:t>МИС АЛЬТЕРА</a:t>
             </a:r>
@@ -17898,8 +17910,8 @@
         </p:nvSpPr>
         <p:spPr>
           <a:xfrm>
-            <a:off x="8508095" y="4799595"/>
-            <a:ext cx="542768" cy="169999"/>
+            <a:off x="8541916" y="4799595"/>
+            <a:ext cx="494298" cy="169999"/>
           </a:xfrm>
           <a:prstGeom prst="rect">
             <a:avLst/>
@@ -18112,9 +18124,9 @@
                 <a:solidFill>
                   <a:srgbClr val="46B0A3"/>
                 </a:solidFill>
-                <a:latin typeface="Carlito" pitchFamily="34" charset="0"/>
-                <a:ea typeface="Carlito" pitchFamily="34" charset="-122"/>
-                <a:cs typeface="Carlito" pitchFamily="34" charset="-120"/>
+                <a:latin typeface="Inter" pitchFamily="34" charset="0"/>
+                <a:ea typeface="Inter" pitchFamily="34" charset="-122"/>
+                <a:cs typeface="Inter" pitchFamily="34" charset="-120"/>
               </a:rPr>
               <a:t>08 — ВИЗУАЛЬНЫЙ ЯЗЫК</a:t>
             </a:r>
@@ -18154,9 +18166,9 @@
                 <a:solidFill>
                   <a:srgbClr val="1A1F2E"/>
                 </a:solidFill>
-                <a:latin typeface="Tinos" pitchFamily="34" charset="0"/>
-                <a:ea typeface="Tinos" pitchFamily="34" charset="-122"/>
-                <a:cs typeface="Tinos" pitchFamily="34" charset="-120"/>
+                <a:latin typeface="Playfair Display" pitchFamily="34" charset="0"/>
+                <a:ea typeface="Playfair Display" pitchFamily="34" charset="-122"/>
+                <a:cs typeface="Playfair Display" pitchFamily="34" charset="-120"/>
               </a:rPr>
               <a:t>Биофилия и тактильность.</a:t>
             </a:r>
@@ -18196,9 +18208,9 @@
                 <a:solidFill>
                   <a:srgbClr val="4A5468"/>
                 </a:solidFill>
-                <a:latin typeface="Carlito" pitchFamily="34" charset="0"/>
-                <a:ea typeface="Carlito" pitchFamily="34" charset="-122"/>
-                <a:cs typeface="Carlito" pitchFamily="34" charset="-120"/>
+                <a:latin typeface="Inter" pitchFamily="34" charset="0"/>
+                <a:ea typeface="Inter" pitchFamily="34" charset="-122"/>
+                <a:cs typeface="Inter" pitchFamily="34" charset="-120"/>
               </a:rPr>
               <a:t>Мы отказываемся от стерильной клинической эстетики в пользу живой, природной. Дизайн должен ощущаться физически, даже в цифре.</a:t>
             </a:r>
@@ -18314,9 +18326,9 @@
                 <a:solidFill>
                   <a:srgbClr val="1A1F2E"/>
                 </a:solidFill>
-                <a:latin typeface="Carlito" pitchFamily="34" charset="0"/>
-                <a:ea typeface="Carlito" pitchFamily="34" charset="-122"/>
-                <a:cs typeface="Carlito" pitchFamily="34" charset="-120"/>
+                <a:latin typeface="Inter" pitchFamily="34" charset="0"/>
+                <a:ea typeface="Inter" pitchFamily="34" charset="-122"/>
+                <a:cs typeface="Inter" pitchFamily="34" charset="-120"/>
               </a:rPr>
               <a:t>Мягкие 3D-абстракции</a:t>
             </a:r>
@@ -18356,9 +18368,9 @@
                 <a:solidFill>
                   <a:srgbClr val="4A5468"/>
                 </a:solidFill>
-                <a:latin typeface="Carlito" pitchFamily="34" charset="0"/>
-                <a:ea typeface="Carlito" pitchFamily="34" charset="-122"/>
-                <a:cs typeface="Carlito" pitchFamily="34" charset="-120"/>
+                <a:latin typeface="Inter" pitchFamily="34" charset="0"/>
+                <a:ea typeface="Inter" pitchFamily="34" charset="-122"/>
+                <a:cs typeface="Inter" pitchFamily="34" charset="-120"/>
               </a:rPr>
               <a:t>Плавные, объёмные формы — сферы, перетекающие ленты, капли. Никаких жёстких квадратов и острых углов. Только скругления.</a:t>
             </a:r>
@@ -18474,9 +18486,9 @@
                 <a:solidFill>
                   <a:srgbClr val="1A1F2E"/>
                 </a:solidFill>
-                <a:latin typeface="Carlito" pitchFamily="34" charset="0"/>
-                <a:ea typeface="Carlito" pitchFamily="34" charset="-122"/>
-                <a:cs typeface="Carlito" pitchFamily="34" charset="-120"/>
+                <a:latin typeface="Inter" pitchFamily="34" charset="0"/>
+                <a:ea typeface="Inter" pitchFamily="34" charset="-122"/>
+                <a:cs typeface="Inter" pitchFamily="34" charset="-120"/>
               </a:rPr>
               <a:t>Эффект преломления света (Стекло)</a:t>
             </a:r>
@@ -18516,9 +18528,9 @@
                 <a:solidFill>
                   <a:srgbClr val="4A5468"/>
                 </a:solidFill>
-                <a:latin typeface="Carlito" pitchFamily="34" charset="0"/>
-                <a:ea typeface="Carlito" pitchFamily="34" charset="-122"/>
-                <a:cs typeface="Carlito" pitchFamily="34" charset="-120"/>
+                <a:latin typeface="Inter" pitchFamily="34" charset="0"/>
+                <a:ea typeface="Inter" pitchFamily="34" charset="-122"/>
+                <a:cs typeface="Inter" pitchFamily="34" charset="-120"/>
               </a:rPr>
               <a:t>Полупрозрачные слои, эффект матового стекла — Glassmorphism. Только цвета из палитры, с мягкими градиентными переходами.</a:t>
             </a:r>
@@ -18634,9 +18646,9 @@
                 <a:solidFill>
                   <a:srgbClr val="1A1F2E"/>
                 </a:solidFill>
-                <a:latin typeface="Carlito" pitchFamily="34" charset="0"/>
-                <a:ea typeface="Carlito" pitchFamily="34" charset="-122"/>
-                <a:cs typeface="Carlito" pitchFamily="34" charset="-120"/>
+                <a:latin typeface="Inter" pitchFamily="34" charset="0"/>
+                <a:ea typeface="Inter" pitchFamily="34" charset="-122"/>
+                <a:cs typeface="Inter" pitchFamily="34" charset="-120"/>
               </a:rPr>
               <a:t>Обобщение людей</a:t>
             </a:r>
@@ -18676,9 +18688,9 @@
                 <a:solidFill>
                   <a:srgbClr val="4A5468"/>
                 </a:solidFill>
-                <a:latin typeface="Carlito" pitchFamily="34" charset="0"/>
-                <a:ea typeface="Carlito" pitchFamily="34" charset="-122"/>
-                <a:cs typeface="Carlito" pitchFamily="34" charset="-120"/>
+                <a:latin typeface="Inter" pitchFamily="34" charset="0"/>
+                <a:ea typeface="Inter" pitchFamily="34" charset="-122"/>
+                <a:cs typeface="Inter" pitchFamily="34" charset="-120"/>
               </a:rPr>
               <a:t>Только стилизованные белые или цветовые силуэты. Без портретов. Лицо врача или пациента — табу, чтобы не создавать отчуждения.</a:t>
             </a:r>
@@ -18848,9 +18860,9 @@
                 <a:solidFill>
                   <a:srgbClr val="8B95A7"/>
                 </a:solidFill>
-                <a:latin typeface="Carlito" pitchFamily="34" charset="0"/>
-                <a:ea typeface="Carlito" pitchFamily="34" charset="-122"/>
-                <a:cs typeface="Carlito" pitchFamily="34" charset="-120"/>
+                <a:latin typeface="Inter" pitchFamily="34" charset="0"/>
+                <a:ea typeface="Inter" pitchFamily="34" charset="-122"/>
+                <a:cs typeface="Inter" pitchFamily="34" charset="-120"/>
               </a:rPr>
               <a:t>ИЛЛЮСТРАЦИЯ: БИОФИЛЬНАЯ 3D-АБСТРАКЦИЯ</a:t>
             </a:r>
@@ -18890,9 +18902,9 @@
                 <a:solidFill>
                   <a:srgbClr val="8B95A7"/>
                 </a:solidFill>
-                <a:latin typeface="Carlito" pitchFamily="34" charset="0"/>
-                <a:ea typeface="Carlito" pitchFamily="34" charset="-122"/>
-                <a:cs typeface="Carlito" pitchFamily="34" charset="-120"/>
+                <a:latin typeface="Inter" pitchFamily="34" charset="0"/>
+                <a:ea typeface="Inter" pitchFamily="34" charset="-122"/>
+                <a:cs typeface="Inter" pitchFamily="34" charset="-120"/>
               </a:rPr>
               <a:t>Сферы и перетекающие ленты в цветах палитры, эффект матового стекла.</a:t>
             </a:r>
@@ -18975,7 +18987,7 @@
         <p:spPr>
           <a:xfrm>
             <a:off x="257175" y="200025"/>
-            <a:ext cx="1257779" cy="169999"/>
+            <a:ext cx="1152902" cy="169999"/>
           </a:xfrm>
           <a:prstGeom prst="rect">
             <a:avLst/>
@@ -18998,9 +19010,9 @@
                 <a:solidFill>
                   <a:srgbClr val="8B95A7"/>
                 </a:solidFill>
-                <a:latin typeface="Carlito" pitchFamily="34" charset="0"/>
-                <a:ea typeface="Carlito" pitchFamily="34" charset="-122"/>
-                <a:cs typeface="Carlito" pitchFamily="34" charset="-120"/>
+                <a:latin typeface="Inter" pitchFamily="34" charset="0"/>
+                <a:ea typeface="Inter" pitchFamily="34" charset="-122"/>
+                <a:cs typeface="Inter" pitchFamily="34" charset="-120"/>
               </a:rPr>
               <a:t>МИС АЛЬТЕРА</a:t>
             </a:r>
@@ -19016,8 +19028,8 @@
         </p:nvSpPr>
         <p:spPr>
           <a:xfrm>
-            <a:off x="8508095" y="4799595"/>
-            <a:ext cx="542768" cy="169999"/>
+            <a:off x="8534772" y="4799595"/>
+            <a:ext cx="504536" cy="169999"/>
           </a:xfrm>
           <a:prstGeom prst="rect">
             <a:avLst/>
@@ -19230,9 +19242,9 @@
                 <a:solidFill>
                   <a:srgbClr val="46B0A3"/>
                 </a:solidFill>
-                <a:latin typeface="Carlito" pitchFamily="34" charset="0"/>
-                <a:ea typeface="Carlito" pitchFamily="34" charset="-122"/>
-                <a:cs typeface="Carlito" pitchFamily="34" charset="-120"/>
+                <a:latin typeface="Inter" pitchFamily="34" charset="0"/>
+                <a:ea typeface="Inter" pitchFamily="34" charset="-122"/>
+                <a:cs typeface="Inter" pitchFamily="34" charset="-120"/>
               </a:rPr>
               <a:t>09 — ПОЛИГРАФИЯ И МАТЕРИАЛЫ</a:t>
             </a:r>
@@ -19272,9 +19284,9 @@
                 <a:solidFill>
                   <a:srgbClr val="1A1F2E"/>
                 </a:solidFill>
-                <a:latin typeface="Tinos" pitchFamily="34" charset="0"/>
-                <a:ea typeface="Tinos" pitchFamily="34" charset="-122"/>
-                <a:cs typeface="Tinos" pitchFamily="34" charset="-120"/>
+                <a:latin typeface="Playfair Display" pitchFamily="34" charset="0"/>
+                <a:ea typeface="Playfair Display" pitchFamily="34" charset="-122"/>
+                <a:cs typeface="Playfair Display" pitchFamily="34" charset="-120"/>
               </a:rPr>
               <a:t>Физические носители и фактуры.</a:t>
             </a:r>
@@ -19314,9 +19326,9 @@
                 <a:solidFill>
                   <a:srgbClr val="4A5468"/>
                 </a:solidFill>
-                <a:latin typeface="Carlito" pitchFamily="34" charset="0"/>
-                <a:ea typeface="Carlito" pitchFamily="34" charset="-122"/>
-                <a:cs typeface="Carlito" pitchFamily="34" charset="-120"/>
+                <a:latin typeface="Inter" pitchFamily="34" charset="0"/>
+                <a:ea typeface="Inter" pitchFamily="34" charset="-122"/>
+                <a:cs typeface="Inter" pitchFamily="34" charset="-120"/>
               </a:rPr>
               <a:t>Бумага и печать передают ощущение дорогого природного камня или матового стекла через тактильные ощущения.</a:t>
             </a:r>
@@ -19382,9 +19394,9 @@
                 <a:solidFill>
                   <a:srgbClr val="8B7355"/>
                 </a:solidFill>
-                <a:latin typeface="Carlito" pitchFamily="34" charset="0"/>
-                <a:ea typeface="Carlito" pitchFamily="34" charset="-122"/>
-                <a:cs typeface="Carlito" pitchFamily="34" charset="-120"/>
+                <a:latin typeface="Inter" pitchFamily="34" charset="0"/>
+                <a:ea typeface="Inter" pitchFamily="34" charset="-122"/>
+                <a:cs typeface="Inter" pitchFamily="34" charset="-120"/>
               </a:rPr>
               <a:t>МАТЕРИАЛ · ОБРАЗЕЦ</a:t>
             </a:r>
@@ -19537,8 +19549,8 @@
         </p:nvSpPr>
         <p:spPr>
           <a:xfrm>
-            <a:off x="2145452" y="2764185"/>
-            <a:ext cx="571409" cy="123444"/>
+            <a:off x="2150715" y="2764185"/>
+            <a:ext cx="576072" cy="123444"/>
           </a:xfrm>
           <a:prstGeom prst="rect">
             <a:avLst/>
@@ -19561,9 +19573,9 @@
                 <a:solidFill>
                   <a:srgbClr val="5C4A33"/>
                 </a:solidFill>
-                <a:latin typeface="Tinos" pitchFamily="34" charset="0"/>
-                <a:ea typeface="Tinos" pitchFamily="34" charset="-122"/>
-                <a:cs typeface="Tinos" pitchFamily="34" charset="-120"/>
+                <a:latin typeface="Playfair Display" pitchFamily="34" charset="0"/>
+                <a:ea typeface="Playfair Display" pitchFamily="34" charset="-122"/>
+                <a:cs typeface="Playfair Display" pitchFamily="34" charset="-120"/>
               </a:rPr>
               <a:t>300 г/м²</a:t>
             </a:r>
@@ -19579,8 +19591,8 @@
         </p:nvSpPr>
         <p:spPr>
           <a:xfrm>
-            <a:off x="1892089" y="2964210"/>
-            <a:ext cx="1064039" cy="170021"/>
+            <a:off x="1864965" y="2964210"/>
+            <a:ext cx="1123712" cy="170021"/>
           </a:xfrm>
           <a:prstGeom prst="rect">
             <a:avLst/>
@@ -19603,9 +19615,9 @@
                 <a:solidFill>
                   <a:srgbClr val="8B7355"/>
                 </a:solidFill>
-                <a:latin typeface="Carlito" pitchFamily="34" charset="0"/>
-                <a:ea typeface="Carlito" pitchFamily="34" charset="-122"/>
-                <a:cs typeface="Carlito" pitchFamily="34" charset="-120"/>
+                <a:latin typeface="Inter" pitchFamily="34" charset="0"/>
+                <a:ea typeface="Inter" pitchFamily="34" charset="-122"/>
+                <a:cs typeface="Inter" pitchFamily="34" charset="-120"/>
               </a:rPr>
               <a:t>Splendorlux Felt / Velvet</a:t>
             </a:r>
@@ -19645,9 +19657,9 @@
                 <a:solidFill>
                   <a:srgbClr val="5C4A33"/>
                 </a:solidFill>
-                <a:latin typeface="Carlito" pitchFamily="34" charset="0"/>
-                <a:ea typeface="Carlito" pitchFamily="34" charset="-122"/>
-                <a:cs typeface="Carlito" pitchFamily="34" charset="-120"/>
+                <a:latin typeface="Inter" pitchFamily="34" charset="0"/>
+                <a:ea typeface="Inter" pitchFamily="34" charset="-122"/>
+                <a:cs typeface="Inter" pitchFamily="34" charset="-120"/>
               </a:rPr>
               <a:t>Матовая дизайнерская бумага, плотность 300 г/м², бархатистая шероховатая поверхность.</a:t>
             </a:r>
@@ -19792,9 +19804,9 @@
                 <a:solidFill>
                   <a:srgbClr val="1A1F2E"/>
                 </a:solidFill>
-                <a:latin typeface="Carlito" pitchFamily="34" charset="0"/>
-                <a:ea typeface="Carlito" pitchFamily="34" charset="-122"/>
-                <a:cs typeface="Carlito" pitchFamily="34" charset="-120"/>
+                <a:latin typeface="Inter" pitchFamily="34" charset="0"/>
+                <a:ea typeface="Inter" pitchFamily="34" charset="-122"/>
+                <a:cs typeface="Inter" pitchFamily="34" charset="-120"/>
               </a:rPr>
               <a:t>Матовая офсетная печать</a:t>
             </a:r>
@@ -19834,9 +19846,9 @@
                 <a:solidFill>
                   <a:srgbClr val="4A5468"/>
                 </a:solidFill>
-                <a:latin typeface="Carlito" pitchFamily="34" charset="0"/>
-                <a:ea typeface="Carlito" pitchFamily="34" charset="-122"/>
-                <a:cs typeface="Carlito" pitchFamily="34" charset="-120"/>
+                <a:latin typeface="Inter" pitchFamily="34" charset="0"/>
+                <a:ea typeface="Inter" pitchFamily="34" charset="-122"/>
+                <a:cs typeface="Inter" pitchFamily="34" charset="-120"/>
               </a:rPr>
               <a:t>Преобладающий способ печати для всех носителей. Мягкое, небликующее покрытие.</a:t>
             </a:r>
@@ -19981,9 +19993,9 @@
                 <a:solidFill>
                   <a:srgbClr val="1A1F2E"/>
                 </a:solidFill>
-                <a:latin typeface="Carlito" pitchFamily="34" charset="0"/>
-                <a:ea typeface="Carlito" pitchFamily="34" charset="-122"/>
-                <a:cs typeface="Carlito" pitchFamily="34" charset="-120"/>
+                <a:latin typeface="Inter" pitchFamily="34" charset="0"/>
+                <a:ea typeface="Inter" pitchFamily="34" charset="-122"/>
+                <a:cs typeface="Inter" pitchFamily="34" charset="-120"/>
               </a:rPr>
               <a:t>Выборочный УФ-лак</a:t>
             </a:r>
@@ -20023,9 +20035,9 @@
                 <a:solidFill>
                   <a:srgbClr val="4A5468"/>
                 </a:solidFill>
-                <a:latin typeface="Carlito" pitchFamily="34" charset="0"/>
-                <a:ea typeface="Carlito" pitchFamily="34" charset="-122"/>
-                <a:cs typeface="Carlito" pitchFamily="34" charset="-120"/>
+                <a:latin typeface="Inter" pitchFamily="34" charset="0"/>
+                <a:ea typeface="Inter" pitchFamily="34" charset="-122"/>
+                <a:cs typeface="Inter" pitchFamily="34" charset="-120"/>
               </a:rPr>
               <a:t>Логотип на визитке покрывается глянцевым УФ-лаком — контраст с матовой бумагой.</a:t>
             </a:r>
@@ -20170,9 +20182,9 @@
                 <a:solidFill>
                   <a:srgbClr val="1A1F2E"/>
                 </a:solidFill>
-                <a:latin typeface="Carlito" pitchFamily="34" charset="0"/>
-                <a:ea typeface="Carlito" pitchFamily="34" charset="-122"/>
-                <a:cs typeface="Carlito" pitchFamily="34" charset="-120"/>
+                <a:latin typeface="Inter" pitchFamily="34" charset="0"/>
+                <a:ea typeface="Inter" pitchFamily="34" charset="-122"/>
+                <a:cs typeface="Inter" pitchFamily="34" charset="-120"/>
               </a:rPr>
               <a:t>Блинтовое тиснение</a:t>
             </a:r>
@@ -20212,9 +20224,9 @@
                 <a:solidFill>
                   <a:srgbClr val="4A5468"/>
                 </a:solidFill>
-                <a:latin typeface="Carlito" pitchFamily="34" charset="0"/>
-                <a:ea typeface="Carlito" pitchFamily="34" charset="-122"/>
-                <a:cs typeface="Carlito" pitchFamily="34" charset="-120"/>
+                <a:latin typeface="Inter" pitchFamily="34" charset="0"/>
+                <a:ea typeface="Inter" pitchFamily="34" charset="-122"/>
+                <a:cs typeface="Inter" pitchFamily="34" charset="-120"/>
               </a:rPr>
               <a:t>На конвертах и премиальных папках — бесцветное тиснение логотипа, создающее физический рельеф.</a:t>
             </a:r>
@@ -20231,7 +20243,7 @@
         <p:spPr>
           <a:xfrm>
             <a:off x="257175" y="200025"/>
-            <a:ext cx="1257779" cy="169999"/>
+            <a:ext cx="1152902" cy="169999"/>
           </a:xfrm>
           <a:prstGeom prst="rect">
             <a:avLst/>
@@ -20254,9 +20266,9 @@
                 <a:solidFill>
                   <a:srgbClr val="8B95A7"/>
                 </a:solidFill>
-                <a:latin typeface="Carlito" pitchFamily="34" charset="0"/>
-                <a:ea typeface="Carlito" pitchFamily="34" charset="-122"/>
-                <a:cs typeface="Carlito" pitchFamily="34" charset="-120"/>
+                <a:latin typeface="Inter" pitchFamily="34" charset="0"/>
+                <a:ea typeface="Inter" pitchFamily="34" charset="-122"/>
+                <a:cs typeface="Inter" pitchFamily="34" charset="-120"/>
               </a:rPr>
               <a:t>МИС АЛЬТЕРА</a:t>
             </a:r>
@@ -20272,8 +20284,8 @@
         </p:nvSpPr>
         <p:spPr>
           <a:xfrm>
-            <a:off x="8508095" y="4799595"/>
-            <a:ext cx="542768" cy="169999"/>
+            <a:off x="8534772" y="4799595"/>
+            <a:ext cx="504536" cy="169999"/>
           </a:xfrm>
           <a:prstGeom prst="rect">
             <a:avLst/>

</xml_diff>

<commit_message>
fix: remove embedded fonts (caused .pptx corruption)
- Reverted font embedding via <p:embeddedFontLst>
- .pptx now references 'Playfair Display' and 'Inter' as typeface
  but does NOT embed TTF files
- Relies on locally installed fonts (user has them on machine)
- Removed source_html/fonts/ directory from repo
- File size back to 1.8 MB (was 3.0 MB with embedded fonts)
</commit_message>
<xml_diff>
--- a/MIS_Altera_Brandbook.pptx
+++ b/MIS_Altera_Brandbook.pptx
@@ -1,18 +1,6 @@
 
 <file path=ppt/presentation.xml><?xml version="1.0" encoding="utf-8"?>
 <p:presentation xmlns:a="http://schemas.openxmlformats.org/drawingml/2006/main" xmlns:r="http://schemas.openxmlformats.org/officeDocument/2006/relationships" xmlns:p="http://schemas.openxmlformats.org/presentationml/2006/main" saveSubsetFonts="1" autoCompressPictures="0">
-  <p:embeddedFontLst>
-    <p:embeddedFont>
-      <p:font typeface="Inter"/>
-      <p:bold r:id="rId21"/>
-      <p:regular r:id="rId22"/>
-    </p:embeddedFont>
-    <p:embeddedFont>
-      <p:font typeface="Playfair Display"/>
-      <p:italic r:id="rId26"/>
-      <p:regular r:id="rId27"/>
-    </p:embeddedFont>
-  </p:embeddedFontLst>
   <p:sldMasterIdLst>
     <p:sldMasterId id="2147483648" r:id="rId1"/>
   </p:sldMasterIdLst>
@@ -5297,7 +5285,7 @@
       </p:sp>
       <p:pic>
         <p:nvPicPr>
-          <p:cNvPr id="4" name="Image 1" descr="/tmp/h2p-svg-1786015136546-ku8qn5.png">    </p:cNvPr>
+          <p:cNvPr id="4" name="Image 1" descr="/tmp/h2p-svg-1786015514487-fbsj79.png">    </p:cNvPr>
           <p:cNvPicPr>
             <a:picLocks noChangeAspect="1"/>
           </p:cNvPicPr>
@@ -8491,7 +8479,7 @@
       </p:grpSpPr>
       <p:pic>
         <p:nvPicPr>
-          <p:cNvPr id="2" name="Image 0" descr="/tmp/h2p-fit-1786015136310-8mb4rb.png">    </p:cNvPr>
+          <p:cNvPr id="2" name="Image 0" descr="/tmp/h2p-fit-1786015514083-asfud7.png">    </p:cNvPr>
           <p:cNvPicPr>
             <a:picLocks noChangeAspect="1"/>
           </p:cNvPicPr>

</xml_diff>

<commit_message>
feat: add slide 15 — logo lockups (horizontal + vertical) and clear-space rules
- New slide 15: two equal logo lockups (horizontal for UI, vertical for premium/splash)
- Specs per lockup: composition, alignment, proportions, padding, use-cases
- Clear-space rules by context: UI light (¼ height, 16-24px), print (½ height, ≥3mm), complex (1× height)
- Left-aligned exception for UI headers/sidebars (left=0, others per rules)
- Minimum size reminder (16mm print, 48px interface)
- Updated page numbers on slides 2-13 from /14 to /15
- Updated slides_brief.json with new entry
</commit_message>
<xml_diff>
--- a/MIS_Altera_Brandbook.pptx
+++ b/MIS_Altera_Brandbook.pptx
@@ -19,9 +19,10 @@
     <p:sldId id="267" r:id="rId13"/>
     <p:sldId id="268" r:id="rId14"/>
     <p:sldId id="269" r:id="rId15"/>
+    <p:sldId id="270" r:id="rId16"/>
   </p:sldIdLst>
   <p:notesMasterIdLst>
-    <p:notesMasterId r:id="rId16"/>
+    <p:notesMasterId r:id="rId17"/>
   </p:notesMasterIdLst>
   <p:sldSz cx="9144000" cy="5143500"/>
   <p:notesSz cx="5143500" cy="9144000"/>
@@ -979,6 +980,94 @@
             <a:fld id="{F7021451-1387-4CA6-816F-3879F97B5CBC}" type="slidenum">
               <a:rPr lang="en-US"/>
               <a:t>14</a:t>
+            </a:fld>
+            <a:endParaRPr lang="en-US"/>
+          </a:p>
+        </p:txBody>
+      </p:sp>
+    </p:spTree>
+    <p:extLst>
+      <p:ext uri="{BB962C8B-B14F-4D97-AF65-F5344CB8AC3E}">
+        <p14:creationId xmlns:p14="http://schemas.microsoft.com/office/powerpoint/2010/main" val="1024086991"/>
+      </p:ext>
+    </p:extLst>
+  </p:cSld>
+  <p:clrMapOvr>
+    <a:masterClrMapping/>
+  </p:clrMapOvr>
+</p:notes>
+</file>
+
+<file path=ppt/notesSlides/notesSlide15.xml><?xml version="1.0" encoding="utf-8"?>
+<p:notes xmlns:a="http://schemas.openxmlformats.org/drawingml/2006/main" xmlns:r="http://schemas.openxmlformats.org/officeDocument/2006/relationships" xmlns:p="http://schemas.openxmlformats.org/presentationml/2006/main">
+  <p:cSld>
+    <p:spTree>
+      <p:nvGrpSpPr>
+        <p:cNvPr id="1" name=""/>
+        <p:cNvGrpSpPr/>
+        <p:nvPr/>
+      </p:nvGrpSpPr>
+      <p:grpSpPr>
+        <a:xfrm>
+          <a:off x="0" y="0"/>
+          <a:ext cx="0" cy="0"/>
+          <a:chOff x="0" y="0"/>
+          <a:chExt cx="0" cy="0"/>
+        </a:xfrm>
+      </p:grpSpPr>
+      <p:sp>
+        <p:nvSpPr>
+          <p:cNvPr id="2" name="Slide Image Placeholder 1"/>
+          <p:cNvSpPr>
+            <a:spLocks noGrp="1" noRot="1" noChangeAspect="1"/>
+          </p:cNvSpPr>
+          <p:nvPr>
+            <p:ph type="sldImg"/>
+          </p:nvPr>
+        </p:nvSpPr>
+        <p:spPr/>
+      </p:sp>
+      <p:sp>
+        <p:nvSpPr>
+          <p:cNvPr id="3" name="Notes Placeholder 2"/>
+          <p:cNvSpPr>
+            <a:spLocks noGrp="1"/>
+          </p:cNvSpPr>
+          <p:nvPr>
+            <p:ph type="body" idx="1"/>
+          </p:nvPr>
+        </p:nvSpPr>
+        <p:spPr/>
+        <p:txBody>
+          <a:bodyPr/>
+          <a:lstStyle/>
+          <a:p>
+            <a:r>
+              <a:rPr lang="en-US" dirty="0"/>
+              <a:t/>
+            </a:r>
+            <a:endParaRPr lang="en-US" dirty="0"/>
+          </a:p>
+        </p:txBody>
+      </p:sp>
+      <p:sp>
+        <p:nvSpPr>
+          <p:cNvPr id="4" name="Slide Number Placeholder 3"/>
+          <p:cNvSpPr>
+            <a:spLocks noGrp="1"/>
+          </p:cNvSpPr>
+          <p:nvPr>
+            <p:ph type="sldNum" sz="quarter" idx="10"/>
+          </p:nvPr>
+        </p:nvSpPr>
+        <p:spPr/>
+        <p:txBody>
+          <a:bodyPr/>
+          <a:lstStyle/>
+          <a:p>
+            <a:fld id="{F7021451-1387-4CA6-816F-3879F97B5CBC}" type="slidenum">
+              <a:rPr lang="en-US"/>
+              <a:t>15</a:t>
             </a:fld>
             <a:endParaRPr lang="en-US"/>
           </a:p>
@@ -3950,7 +4039,7 @@
                 <a:ea typeface="Liberation Sans Narrow" pitchFamily="34" charset="-122"/>
                 <a:cs typeface="Liberation Sans Narrow" pitchFamily="34" charset="-120"/>
               </a:rPr>
-              <a:t>10 / 14</a:t>
+              <a:t>10 / 15</a:t>
             </a:r>
             <a:endParaRPr lang="en-US" sz="800" dirty="0"/>
           </a:p>
@@ -5187,7 +5276,7 @@
                 <a:ea typeface="Liberation Sans Narrow" pitchFamily="34" charset="-122"/>
                 <a:cs typeface="Liberation Sans Narrow" pitchFamily="34" charset="-120"/>
               </a:rPr>
-              <a:t>11 / 14</a:t>
+              <a:t>11 / 15</a:t>
             </a:r>
             <a:endParaRPr lang="en-US" sz="800" dirty="0"/>
           </a:p>
@@ -5285,7 +5374,7 @@
       </p:sp>
       <p:pic>
         <p:nvPicPr>
-          <p:cNvPr id="4" name="Image 1" descr="/tmp/h2p-svg-1786015514487-fbsj79.png">    </p:cNvPr>
+          <p:cNvPr id="4" name="Image 1" descr="/tmp/h2p-svg-1786016957646-8hby9p.png">    </p:cNvPr>
           <p:cNvPicPr>
             <a:picLocks noChangeAspect="1"/>
           </p:cNvPicPr>
@@ -7216,7 +7305,7 @@
                 <a:ea typeface="Liberation Sans Narrow" pitchFamily="34" charset="-122"/>
                 <a:cs typeface="Liberation Sans Narrow" pitchFamily="34" charset="-120"/>
               </a:rPr>
-              <a:t>12 / 14</a:t>
+              <a:t>12 / 15</a:t>
             </a:r>
             <a:endParaRPr lang="en-US" sz="800" dirty="0"/>
           </a:p>
@@ -8439,7 +8528,7 @@
                 <a:ea typeface="Liberation Sans Narrow" pitchFamily="34" charset="-122"/>
                 <a:cs typeface="Liberation Sans Narrow" pitchFamily="34" charset="-120"/>
               </a:rPr>
-              <a:t>13 / 14</a:t>
+              <a:t>13 / 15</a:t>
             </a:r>
             <a:endParaRPr lang="en-US" sz="800" dirty="0"/>
           </a:p>
@@ -8479,7 +8568,7 @@
       </p:grpSpPr>
       <p:pic>
         <p:nvPicPr>
-          <p:cNvPr id="2" name="Image 0" descr="/tmp/h2p-fit-1786015514083-asfud7.png">    </p:cNvPr>
+          <p:cNvPr id="2" name="Image 0" descr="/tmp/h2p-fit-1786016957629-686d8h.png">    </p:cNvPr>
           <p:cNvPicPr>
             <a:picLocks noChangeAspect="1"/>
           </p:cNvPicPr>
@@ -8972,6 +9061,2349 @@
                 <a:cs typeface="Inter" pitchFamily="34" charset="-120"/>
               </a:rPr>
               <a:t>МИС АЛЬТЕРА · БРЕНД-БУК · 2026</a:t>
+            </a:r>
+            <a:endParaRPr lang="en-US" sz="800" dirty="0"/>
+          </a:p>
+        </p:txBody>
+      </p:sp>
+    </p:spTree>
+  </p:cSld>
+  <p:clrMapOvr>
+    <a:masterClrMapping/>
+  </p:clrMapOvr>
+</p:sld>
+</file>
+
+<file path=ppt/slides/slide15.xml><?xml version="1.0" encoding="utf-8"?>
+<p:sld xmlns:a="http://schemas.openxmlformats.org/drawingml/2006/main" xmlns:r="http://schemas.openxmlformats.org/officeDocument/2006/relationships" xmlns:p="http://schemas.openxmlformats.org/presentationml/2006/main">
+  <p:cSld name="Slide 15">
+    <p:bg>
+      <p:bgPr>
+        <a:solidFill>
+          <a:srgbClr val="F9FAFB"/>
+        </a:solidFill>
+      </p:bgPr>
+    </p:bg>
+    <p:spTree>
+      <p:nvGrpSpPr>
+        <p:cNvPr id="1" name=""/>
+        <p:cNvGrpSpPr/>
+        <p:nvPr/>
+      </p:nvGrpSpPr>
+      <p:grpSpPr>
+        <a:xfrm>
+          <a:off x="0" y="0"/>
+          <a:ext cx="0" cy="0"/>
+          <a:chOff x="0" y="0"/>
+          <a:chExt cx="0" cy="0"/>
+        </a:xfrm>
+      </p:grpSpPr>
+      <p:pic>
+        <p:nvPicPr>
+          <p:cNvPr id="2" name="Image 0" descr="preencoded.png">    </p:cNvPr>
+          <p:cNvPicPr>
+            <a:picLocks noChangeAspect="1"/>
+          </p:cNvPicPr>
+          <p:nvPr/>
+        </p:nvPicPr>
+        <p:blipFill>
+          <a:blip r:embed="rId1">
+            <a:alphaModFix amt="16000"/>
+          </a:blip>
+          <a:stretch>
+            <a:fillRect/>
+          </a:stretch>
+        </p:blipFill>
+        <p:spPr>
+          <a:xfrm>
+            <a:off x="7858125" y="-642937"/>
+            <a:ext cx="2000250" cy="2000250"/>
+          </a:xfrm>
+          <a:prstGeom prst="rect">
+            <a:avLst/>
+          </a:prstGeom>
+        </p:spPr>
+      </p:pic>
+      <p:sp>
+        <p:nvSpPr>
+          <p:cNvPr id="3" name="Text 0"/>
+          <p:cNvSpPr/>
+          <p:nvPr/>
+        </p:nvSpPr>
+        <p:spPr>
+          <a:xfrm>
+            <a:off x="7858125" y="-642937"/>
+            <a:ext cx="2000250" cy="2000250"/>
+          </a:xfrm>
+          <a:prstGeom prst="ellipse">
+            <a:avLst/>
+          </a:prstGeom>
+          <a:solidFill>
+            <a:srgbClr val="FFFFFF">
+              <a:alpha val="0"/>
+            </a:srgbClr>
+          </a:solidFill>
+          <a:ln/>
+        </p:spPr>
+        <p:txBody>
+          <a:bodyPr wrap="square" rtlCol="0" anchor="ctr"/>
+          <a:lstStyle/>
+          <a:p>
+            <a:pPr indent="0" marL="0">
+              <a:buNone/>
+            </a:pPr>
+            <a:endParaRPr lang="en-US" dirty="0"/>
+          </a:p>
+        </p:txBody>
+      </p:sp>
+      <p:pic>
+        <p:nvPicPr>
+          <p:cNvPr id="4" name="Image 1" descr="preencoded.png">    </p:cNvPr>
+          <p:cNvPicPr>
+            <a:picLocks noChangeAspect="1"/>
+          </p:cNvPicPr>
+          <p:nvPr/>
+        </p:nvPicPr>
+        <p:blipFill>
+          <a:blip r:embed="rId2">
+            <a:alphaModFix amt="22000"/>
+          </a:blip>
+          <a:stretch>
+            <a:fillRect/>
+          </a:stretch>
+        </p:blipFill>
+        <p:spPr>
+          <a:xfrm>
+            <a:off x="-428625" y="4286250"/>
+            <a:ext cx="1428750" cy="1428750"/>
+          </a:xfrm>
+          <a:prstGeom prst="rect">
+            <a:avLst/>
+          </a:prstGeom>
+        </p:spPr>
+      </p:pic>
+      <p:sp>
+        <p:nvSpPr>
+          <p:cNvPr id="5" name="Text 1"/>
+          <p:cNvSpPr/>
+          <p:nvPr/>
+        </p:nvSpPr>
+        <p:spPr>
+          <a:xfrm>
+            <a:off x="-428625" y="4286250"/>
+            <a:ext cx="1428750" cy="1428750"/>
+          </a:xfrm>
+          <a:prstGeom prst="ellipse">
+            <a:avLst/>
+          </a:prstGeom>
+          <a:solidFill>
+            <a:srgbClr val="FFFFFF">
+              <a:alpha val="0"/>
+            </a:srgbClr>
+          </a:solidFill>
+          <a:ln/>
+        </p:spPr>
+        <p:txBody>
+          <a:bodyPr wrap="square" rtlCol="0" anchor="ctr"/>
+          <a:lstStyle/>
+          <a:p>
+            <a:pPr indent="0" marL="0">
+              <a:buNone/>
+            </a:pPr>
+            <a:endParaRPr lang="en-US" dirty="0"/>
+          </a:p>
+        </p:txBody>
+      </p:sp>
+      <p:sp>
+        <p:nvSpPr>
+          <p:cNvPr id="6" name="Shape 2"/>
+          <p:cNvSpPr/>
+          <p:nvPr/>
+        </p:nvSpPr>
+        <p:spPr>
+          <a:xfrm>
+            <a:off x="600075" y="2704021"/>
+            <a:ext cx="3771900" cy="0"/>
+          </a:xfrm>
+          <a:prstGeom prst="line">
+            <a:avLst/>
+          </a:prstGeom>
+          <a:noFill/>
+          <a:ln w="7144">
+            <a:solidFill>
+              <a:srgbClr val="1A1F2E"/>
+            </a:solidFill>
+            <a:prstDash val="solid"/>
+          </a:ln>
+        </p:spPr>
+      </p:sp>
+      <p:sp>
+        <p:nvSpPr>
+          <p:cNvPr id="7" name="Shape 3"/>
+          <p:cNvSpPr/>
+          <p:nvPr/>
+        </p:nvSpPr>
+        <p:spPr>
+          <a:xfrm>
+            <a:off x="4772025" y="3290032"/>
+            <a:ext cx="3771900" cy="0"/>
+          </a:xfrm>
+          <a:prstGeom prst="line">
+            <a:avLst/>
+          </a:prstGeom>
+          <a:noFill/>
+          <a:ln w="7144">
+            <a:solidFill>
+              <a:srgbClr val="1A1F2E"/>
+            </a:solidFill>
+            <a:prstDash val="solid"/>
+          </a:ln>
+        </p:spPr>
+      </p:sp>
+      <p:sp>
+        <p:nvSpPr>
+          <p:cNvPr id="8" name="Text 4"/>
+          <p:cNvSpPr/>
+          <p:nvPr/>
+        </p:nvSpPr>
+        <p:spPr>
+          <a:xfrm>
+            <a:off x="457200" y="342900"/>
+            <a:ext cx="8636000" cy="169999"/>
+          </a:xfrm>
+          <a:prstGeom prst="rect">
+            <a:avLst/>
+          </a:prstGeom>
+          <a:noFill/>
+          <a:ln/>
+        </p:spPr>
+        <p:txBody>
+          <a:bodyPr wrap="square" lIns="0" tIns="0" rIns="0" bIns="0" rtlCol="0" anchor="t"/>
+          <a:lstStyle/>
+          <a:p>
+            <a:pPr algn="l" indent="0" marL="0">
+              <a:lnSpc>
+                <a:spcPts val="1133"/>
+              </a:lnSpc>
+              <a:buNone/>
+            </a:pPr>
+            <a:r>
+              <a:rPr lang="en-US" sz="800" spc="161" kern="0" dirty="0">
+                <a:solidFill>
+                  <a:srgbClr val="46B0A3"/>
+                </a:solidFill>
+                <a:latin typeface="Inter" pitchFamily="34" charset="0"/>
+                <a:ea typeface="Inter" pitchFamily="34" charset="-122"/>
+                <a:cs typeface="Inter" pitchFamily="34" charset="-120"/>
+              </a:rPr>
+              <a:t>15 — КОМПОНОВКА И ОХРАННОЕ ПОЛЕ</a:t>
+            </a:r>
+            <a:endParaRPr lang="en-US" sz="800" dirty="0"/>
+          </a:p>
+        </p:txBody>
+      </p:sp>
+      <p:sp>
+        <p:nvSpPr>
+          <p:cNvPr id="9" name="Text 5"/>
+          <p:cNvSpPr/>
+          <p:nvPr/>
+        </p:nvSpPr>
+        <p:spPr>
+          <a:xfrm>
+            <a:off x="457200" y="558217"/>
+            <a:ext cx="8636000" cy="276423"/>
+          </a:xfrm>
+          <a:prstGeom prst="rect">
+            <a:avLst/>
+          </a:prstGeom>
+          <a:noFill/>
+          <a:ln/>
+        </p:spPr>
+        <p:txBody>
+          <a:bodyPr wrap="square" lIns="0" tIns="0" rIns="0" bIns="0" rtlCol="0" anchor="t"/>
+          <a:lstStyle/>
+          <a:p>
+            <a:pPr algn="l" indent="0" marL="0">
+              <a:lnSpc>
+                <a:spcPts val="2016"/>
+              </a:lnSpc>
+              <a:buNone/>
+            </a:pPr>
+            <a:r>
+              <a:rPr lang="en-US" sz="1800" b="1" dirty="0">
+                <a:solidFill>
+                  <a:srgbClr val="1A1F2E"/>
+                </a:solidFill>
+                <a:latin typeface="Playfair Display" pitchFamily="34" charset="0"/>
+                <a:ea typeface="Playfair Display" pitchFamily="34" charset="-122"/>
+                <a:cs typeface="Playfair Display" pitchFamily="34" charset="-120"/>
+              </a:rPr>
+              <a:t>Горизонтальная и вертикальная версии фирменного блока.</a:t>
+            </a:r>
+            <a:endParaRPr lang="en-US" sz="1800" dirty="0"/>
+          </a:p>
+        </p:txBody>
+      </p:sp>
+      <p:sp>
+        <p:nvSpPr>
+          <p:cNvPr id="10" name="Text 6"/>
+          <p:cNvSpPr/>
+          <p:nvPr/>
+        </p:nvSpPr>
+        <p:spPr>
+          <a:xfrm>
+            <a:off x="457200" y="871314"/>
+            <a:ext cx="6286500" cy="339999"/>
+          </a:xfrm>
+          <a:prstGeom prst="rect">
+            <a:avLst/>
+          </a:prstGeom>
+          <a:noFill/>
+          <a:ln/>
+        </p:spPr>
+        <p:txBody>
+          <a:bodyPr wrap="square" lIns="0" tIns="0" rIns="0" bIns="0" rtlCol="0" anchor="t"/>
+          <a:lstStyle/>
+          <a:p>
+            <a:pPr algn="l" indent="0" marL="0">
+              <a:lnSpc>
+                <a:spcPts val="1133"/>
+              </a:lnSpc>
+              <a:buNone/>
+            </a:pPr>
+            <a:r>
+              <a:rPr lang="en-US" sz="800" dirty="0">
+                <a:solidFill>
+                  <a:srgbClr val="4A5468"/>
+                </a:solidFill>
+                <a:latin typeface="Inter" pitchFamily="34" charset="0"/>
+                <a:ea typeface="Inter" pitchFamily="34" charset="-122"/>
+                <a:cs typeface="Inter" pitchFamily="34" charset="-120"/>
+              </a:rPr>
+              <a:t>Две равноправные компоновки знака и текста. Правила охранного поля различаются для интерфейса, полиграфии и сложных композиций.</a:t>
+            </a:r>
+            <a:endParaRPr lang="en-US" sz="800" dirty="0"/>
+          </a:p>
+        </p:txBody>
+      </p:sp>
+      <p:sp>
+        <p:nvSpPr>
+          <p:cNvPr id="11" name="Text 7"/>
+          <p:cNvSpPr/>
+          <p:nvPr/>
+        </p:nvSpPr>
+        <p:spPr>
+          <a:xfrm>
+            <a:off x="457200" y="1273373"/>
+            <a:ext cx="4057650" cy="1714500"/>
+          </a:xfrm>
+          <a:prstGeom prst="roundRect">
+            <a:avLst>
+              <a:gd name="adj" fmla="val 13333"/>
+            </a:avLst>
+          </a:prstGeom>
+          <a:solidFill>
+            <a:srgbClr val="F9FAFB"/>
+          </a:solidFill>
+          <a:ln/>
+          <a:effectLst>
+            <a:outerShdw sx="100000" sy="100000" kx="0" ky="0" algn="bl" rotWithShape="0" blurRad="190500" dist="107763" dir="2700000">
+              <a:srgbClr val="AEB8C8">
+                <a:alpha val="45000"/>
+              </a:srgbClr>
+            </a:outerShdw>
+          </a:effectLst>
+        </p:spPr>
+        <p:txBody>
+          <a:bodyPr wrap="square" rtlCol="0" anchor="ctr"/>
+          <a:lstStyle/>
+          <a:p>
+            <a:pPr indent="0" marL="0">
+              <a:buNone/>
+            </a:pPr>
+            <a:endParaRPr lang="en-US" dirty="0"/>
+          </a:p>
+        </p:txBody>
+      </p:sp>
+      <p:sp>
+        <p:nvSpPr>
+          <p:cNvPr id="12" name="Text 8"/>
+          <p:cNvSpPr/>
+          <p:nvPr/>
+        </p:nvSpPr>
+        <p:spPr>
+          <a:xfrm>
+            <a:off x="600075" y="1401961"/>
+            <a:ext cx="2981734" cy="215183"/>
+          </a:xfrm>
+          <a:prstGeom prst="rect">
+            <a:avLst/>
+          </a:prstGeom>
+          <a:noFill/>
+          <a:ln/>
+        </p:spPr>
+        <p:txBody>
+          <a:bodyPr wrap="none" lIns="0" tIns="0" rIns="0" bIns="0" rtlCol="0" anchor="t"/>
+          <a:lstStyle/>
+          <a:p>
+            <a:pPr algn="l" indent="0" marL="0">
+              <a:lnSpc>
+                <a:spcPts val="1569"/>
+              </a:lnSpc>
+              <a:buNone/>
+            </a:pPr>
+            <a:r>
+              <a:rPr lang="en-US" sz="1013" dirty="0">
+                <a:solidFill>
+                  <a:srgbClr val="1A1F2E"/>
+                </a:solidFill>
+                <a:latin typeface="Playfair Display" pitchFamily="34" charset="0"/>
+                <a:ea typeface="Playfair Display" pitchFamily="34" charset="-122"/>
+                <a:cs typeface="Playfair Display" pitchFamily="34" charset="-120"/>
+              </a:rPr>
+              <a:t>Горизонтальная</a:t>
+            </a:r>
+            <a:endParaRPr lang="en-US" sz="1013" dirty="0"/>
+          </a:p>
+        </p:txBody>
+      </p:sp>
+      <p:sp>
+        <p:nvSpPr>
+          <p:cNvPr id="13" name="Text 9"/>
+          <p:cNvSpPr/>
+          <p:nvPr/>
+        </p:nvSpPr>
+        <p:spPr>
+          <a:xfrm>
+            <a:off x="3573237" y="1415516"/>
+            <a:ext cx="821598" cy="172022"/>
+          </a:xfrm>
+          <a:prstGeom prst="roundRect">
+            <a:avLst>
+              <a:gd name="adj" fmla="val 5531545"/>
+            </a:avLst>
+          </a:prstGeom>
+          <a:solidFill>
+            <a:srgbClr val="5ECEC1">
+              <a:alpha val="12000"/>
+            </a:srgbClr>
+          </a:solidFill>
+          <a:ln/>
+        </p:spPr>
+        <p:txBody>
+          <a:bodyPr wrap="square" rtlCol="0" anchor="ctr"/>
+          <a:lstStyle/>
+          <a:p>
+            <a:pPr indent="0" marL="0">
+              <a:buNone/>
+            </a:pPr>
+            <a:endParaRPr lang="en-US" dirty="0"/>
+          </a:p>
+        </p:txBody>
+      </p:sp>
+      <p:sp>
+        <p:nvSpPr>
+          <p:cNvPr id="14" name="Text 10"/>
+          <p:cNvSpPr/>
+          <p:nvPr/>
+        </p:nvSpPr>
+        <p:spPr>
+          <a:xfrm>
+            <a:off x="3596097" y="1424732"/>
+            <a:ext cx="775878" cy="153591"/>
+          </a:xfrm>
+          <a:prstGeom prst="rect">
+            <a:avLst/>
+          </a:prstGeom>
+          <a:noFill/>
+          <a:ln/>
+        </p:spPr>
+        <p:txBody>
+          <a:bodyPr wrap="none" lIns="0" tIns="0" rIns="0" bIns="0" rtlCol="0" anchor="ctr"/>
+          <a:lstStyle/>
+          <a:p>
+            <a:pPr algn="ctr" indent="0" marL="0">
+              <a:lnSpc>
+                <a:spcPts val="872"/>
+              </a:lnSpc>
+              <a:buNone/>
+            </a:pPr>
+            <a:r>
+              <a:rPr lang="en-US" sz="800" spc="68" kern="0" dirty="0">
+                <a:solidFill>
+                  <a:srgbClr val="46B0A3"/>
+                </a:solidFill>
+                <a:latin typeface="Inter" pitchFamily="34" charset="0"/>
+                <a:ea typeface="Inter" pitchFamily="34" charset="-122"/>
+                <a:cs typeface="Inter" pitchFamily="34" charset="-120"/>
+              </a:rPr>
+              <a:t>ОСНОВНАЯ · UI</a:t>
+            </a:r>
+            <a:endParaRPr lang="en-US" sz="800" dirty="0"/>
+          </a:p>
+        </p:txBody>
+      </p:sp>
+      <p:sp>
+        <p:nvSpPr>
+          <p:cNvPr id="15" name="Text 11"/>
+          <p:cNvSpPr/>
+          <p:nvPr/>
+        </p:nvSpPr>
+        <p:spPr>
+          <a:xfrm>
+            <a:off x="600075" y="1672642"/>
+            <a:ext cx="3771900" cy="628650"/>
+          </a:xfrm>
+          <a:prstGeom prst="roundRect">
+            <a:avLst>
+              <a:gd name="adj" fmla="val 21212"/>
+            </a:avLst>
+          </a:prstGeom>
+          <a:solidFill>
+            <a:srgbClr val="F1F4F6"/>
+          </a:solidFill>
+          <a:ln/>
+        </p:spPr>
+        <p:txBody>
+          <a:bodyPr wrap="square" rtlCol="0" anchor="ctr"/>
+          <a:lstStyle/>
+          <a:p>
+            <a:pPr indent="0" marL="0">
+              <a:buNone/>
+            </a:pPr>
+            <a:endParaRPr lang="en-US" dirty="0"/>
+          </a:p>
+        </p:txBody>
+      </p:sp>
+      <p:sp>
+        <p:nvSpPr>
+          <p:cNvPr id="16" name="Text 12"/>
+          <p:cNvSpPr/>
+          <p:nvPr/>
+        </p:nvSpPr>
+        <p:spPr>
+          <a:xfrm>
+            <a:off x="1577876" y="1786942"/>
+            <a:ext cx="400050" cy="400050"/>
+          </a:xfrm>
+          <a:prstGeom prst="ellipse">
+            <a:avLst/>
+          </a:prstGeom>
+          <a:solidFill>
+            <a:srgbClr val="5ECEC1"/>
+          </a:solidFill>
+          <a:ln/>
+        </p:spPr>
+        <p:txBody>
+          <a:bodyPr wrap="square" rtlCol="0" anchor="ctr"/>
+          <a:lstStyle/>
+          <a:p>
+            <a:pPr indent="0" marL="0">
+              <a:buNone/>
+            </a:pPr>
+            <a:endParaRPr lang="en-US" dirty="0"/>
+          </a:p>
+        </p:txBody>
+      </p:sp>
+      <p:sp>
+        <p:nvSpPr>
+          <p:cNvPr id="17" name="Text 13"/>
+          <p:cNvSpPr/>
+          <p:nvPr/>
+        </p:nvSpPr>
+        <p:spPr>
+          <a:xfrm>
+            <a:off x="1612166" y="1821232"/>
+            <a:ext cx="331470" cy="331470"/>
+          </a:xfrm>
+          <a:prstGeom prst="rect">
+            <a:avLst/>
+          </a:prstGeom>
+          <a:noFill/>
+          <a:ln/>
+        </p:spPr>
+        <p:txBody>
+          <a:bodyPr wrap="none" lIns="0" tIns="0" rIns="0" bIns="0" rtlCol="0" anchor="ctr"/>
+          <a:lstStyle/>
+          <a:p>
+            <a:pPr algn="ctr" indent="0" marL="0">
+              <a:buNone/>
+            </a:pPr>
+            <a:r>
+              <a:rPr lang="en-US" sz="2250" dirty="0">
+                <a:solidFill>
+                  <a:srgbClr val="FFFFFF"/>
+                </a:solidFill>
+                <a:latin typeface="Segoe UI Symbol" pitchFamily="34" charset="0"/>
+                <a:ea typeface="Segoe UI Symbol" pitchFamily="34" charset="-122"/>
+                <a:cs typeface="Segoe UI Symbol" pitchFamily="34" charset="-120"/>
+              </a:rPr>
+              <a:t>↻</a:t>
+            </a:r>
+            <a:endParaRPr lang="en-US" sz="2250" dirty="0"/>
+          </a:p>
+        </p:txBody>
+      </p:sp>
+      <p:sp>
+        <p:nvSpPr>
+          <p:cNvPr id="18" name="Text 14"/>
+          <p:cNvSpPr/>
+          <p:nvPr/>
+        </p:nvSpPr>
+        <p:spPr>
+          <a:xfrm>
+            <a:off x="2135088" y="1842976"/>
+            <a:ext cx="1888629" cy="310900"/>
+          </a:xfrm>
+          <a:prstGeom prst="rect">
+            <a:avLst/>
+          </a:prstGeom>
+          <a:noFill/>
+          <a:ln/>
+        </p:spPr>
+        <p:txBody>
+          <a:bodyPr wrap="none" lIns="0" tIns="0" rIns="0" bIns="0" rtlCol="0" anchor="t"/>
+          <a:lstStyle/>
+          <a:p>
+            <a:pPr algn="l" indent="0" marL="0">
+              <a:lnSpc>
+                <a:spcPts val="2267"/>
+              </a:lnSpc>
+              <a:buNone/>
+            </a:pPr>
+            <a:r>
+              <a:rPr lang="en-US" sz="1463" b="1" spc="468" kern="0" dirty="0">
+                <a:solidFill>
+                  <a:srgbClr val="1A1F2E"/>
+                </a:solidFill>
+                <a:latin typeface="Playfair Display" pitchFamily="34" charset="0"/>
+                <a:ea typeface="Playfair Display" pitchFamily="34" charset="-122"/>
+                <a:cs typeface="Playfair Display" pitchFamily="34" charset="-120"/>
+              </a:rPr>
+              <a:t>АЛЬТЕРА</a:t>
+            </a:r>
+            <a:endParaRPr lang="en-US" sz="1463" dirty="0"/>
+          </a:p>
+        </p:txBody>
+      </p:sp>
+      <p:sp>
+        <p:nvSpPr>
+          <p:cNvPr id="19" name="Text 15"/>
+          <p:cNvSpPr/>
+          <p:nvPr/>
+        </p:nvSpPr>
+        <p:spPr>
+          <a:xfrm>
+            <a:off x="600075" y="2372730"/>
+            <a:ext cx="1982819" cy="158981"/>
+          </a:xfrm>
+          <a:prstGeom prst="rect">
+            <a:avLst/>
+          </a:prstGeom>
+          <a:noFill/>
+          <a:ln/>
+        </p:spPr>
+        <p:txBody>
+          <a:bodyPr wrap="square" lIns="0" tIns="0" rIns="0" bIns="0" rtlCol="0" anchor="t"/>
+          <a:lstStyle/>
+          <a:p>
+            <a:pPr algn="l" indent="0" marL="0">
+              <a:lnSpc>
+                <a:spcPts val="897"/>
+              </a:lnSpc>
+              <a:buNone/>
+            </a:pPr>
+            <a:r>
+              <a:rPr lang="en-US" sz="800" dirty="0">
+                <a:solidFill>
+                  <a:srgbClr val="1A1F2E"/>
+                </a:solidFill>
+                <a:latin typeface="Inter" pitchFamily="34" charset="0"/>
+                <a:ea typeface="Inter" pitchFamily="34" charset="-122"/>
+                <a:cs typeface="Inter" pitchFamily="34" charset="-120"/>
+              </a:rPr>
+              <a:t>Композиция:</a:t>
+            </a:r>
+            <a:pPr algn="l" indent="0" marL="0">
+              <a:lnSpc>
+                <a:spcPts val="897"/>
+              </a:lnSpc>
+              <a:buNone/>
+            </a:pPr>
+            <a:r>
+              <a:rPr lang="en-US" sz="800" dirty="0">
+                <a:solidFill>
+                  <a:srgbClr val="4A5468"/>
+                </a:solidFill>
+                <a:latin typeface="Inter" pitchFamily="34" charset="0"/>
+                <a:ea typeface="Inter" pitchFamily="34" charset="-122"/>
+                <a:cs typeface="Inter" pitchFamily="34" charset="-120"/>
+              </a:rPr>
+              <a:t> знак слева, текст справа</a:t>
+            </a:r>
+            <a:endParaRPr lang="en-US" sz="800" dirty="0"/>
+          </a:p>
+        </p:txBody>
+      </p:sp>
+      <p:sp>
+        <p:nvSpPr>
+          <p:cNvPr id="20" name="Text 16"/>
+          <p:cNvSpPr/>
+          <p:nvPr/>
+        </p:nvSpPr>
+        <p:spPr>
+          <a:xfrm>
+            <a:off x="2536031" y="2372730"/>
+            <a:ext cx="1945672" cy="158981"/>
+          </a:xfrm>
+          <a:prstGeom prst="rect">
+            <a:avLst/>
+          </a:prstGeom>
+          <a:noFill/>
+          <a:ln/>
+        </p:spPr>
+        <p:txBody>
+          <a:bodyPr wrap="square" lIns="0" tIns="0" rIns="0" bIns="0" rtlCol="0" anchor="t"/>
+          <a:lstStyle/>
+          <a:p>
+            <a:pPr algn="l" indent="0" marL="0">
+              <a:lnSpc>
+                <a:spcPts val="897"/>
+              </a:lnSpc>
+              <a:buNone/>
+            </a:pPr>
+            <a:r>
+              <a:rPr lang="en-US" sz="800" dirty="0">
+                <a:solidFill>
+                  <a:srgbClr val="1A1F2E"/>
+                </a:solidFill>
+                <a:latin typeface="Inter" pitchFamily="34" charset="0"/>
+                <a:ea typeface="Inter" pitchFamily="34" charset="-122"/>
+                <a:cs typeface="Inter" pitchFamily="34" charset="-120"/>
+              </a:rPr>
+              <a:t>Выравнивание:</a:t>
+            </a:r>
+            <a:pPr algn="l" indent="0" marL="0">
+              <a:lnSpc>
+                <a:spcPts val="897"/>
+              </a:lnSpc>
+              <a:buNone/>
+            </a:pPr>
+            <a:r>
+              <a:rPr lang="en-US" sz="800" dirty="0">
+                <a:solidFill>
+                  <a:srgbClr val="4A5468"/>
+                </a:solidFill>
+                <a:latin typeface="Inter" pitchFamily="34" charset="0"/>
+                <a:ea typeface="Inter" pitchFamily="34" charset="-122"/>
+                <a:cs typeface="Inter" pitchFamily="34" charset="-120"/>
+              </a:rPr>
+              <a:t> по базовой линии текста</a:t>
+            </a:r>
+            <a:endParaRPr lang="en-US" sz="800" dirty="0"/>
+          </a:p>
+        </p:txBody>
+      </p:sp>
+      <p:sp>
+        <p:nvSpPr>
+          <p:cNvPr id="21" name="Text 17"/>
+          <p:cNvSpPr/>
+          <p:nvPr/>
+        </p:nvSpPr>
+        <p:spPr>
+          <a:xfrm>
+            <a:off x="600075" y="2515158"/>
+            <a:ext cx="1982819" cy="158981"/>
+          </a:xfrm>
+          <a:prstGeom prst="rect">
+            <a:avLst/>
+          </a:prstGeom>
+          <a:noFill/>
+          <a:ln/>
+        </p:spPr>
+        <p:txBody>
+          <a:bodyPr wrap="square" lIns="0" tIns="0" rIns="0" bIns="0" rtlCol="0" anchor="t"/>
+          <a:lstStyle/>
+          <a:p>
+            <a:pPr algn="l" indent="0" marL="0">
+              <a:lnSpc>
+                <a:spcPts val="897"/>
+              </a:lnSpc>
+              <a:buNone/>
+            </a:pPr>
+            <a:r>
+              <a:rPr lang="en-US" sz="619" dirty="0">
+                <a:solidFill>
+                  <a:srgbClr val="1A1F2E"/>
+                </a:solidFill>
+                <a:latin typeface="Inter" pitchFamily="34" charset="0"/>
+                <a:ea typeface="Inter" pitchFamily="34" charset="-122"/>
+                <a:cs typeface="Inter" pitchFamily="34" charset="-120"/>
+              </a:rPr>
+              <a:t>Пропорция знака к тексту:</a:t>
+            </a:r>
+            <a:pPr algn="l" indent="0" marL="0">
+              <a:lnSpc>
+                <a:spcPts val="897"/>
+              </a:lnSpc>
+              <a:buNone/>
+            </a:pPr>
+            <a:r>
+              <a:rPr lang="en-US" sz="619" dirty="0">
+                <a:solidFill>
+                  <a:srgbClr val="4A5468"/>
+                </a:solidFill>
+                <a:latin typeface="Liberation Sans Narrow" pitchFamily="34" charset="0"/>
+                <a:ea typeface="Liberation Sans Narrow" pitchFamily="34" charset="-122"/>
+                <a:cs typeface="Liberation Sans Narrow" pitchFamily="34" charset="-120"/>
+              </a:rPr>
+              <a:t> 1 : 1,2 (или 1 : 1,5)</a:t>
+            </a:r>
+            <a:endParaRPr lang="en-US" sz="619" dirty="0"/>
+          </a:p>
+        </p:txBody>
+      </p:sp>
+      <p:sp>
+        <p:nvSpPr>
+          <p:cNvPr id="22" name="Text 18"/>
+          <p:cNvSpPr/>
+          <p:nvPr/>
+        </p:nvSpPr>
+        <p:spPr>
+          <a:xfrm>
+            <a:off x="2536031" y="2515158"/>
+            <a:ext cx="1945672" cy="158981"/>
+          </a:xfrm>
+          <a:prstGeom prst="rect">
+            <a:avLst/>
+          </a:prstGeom>
+          <a:noFill/>
+          <a:ln/>
+        </p:spPr>
+        <p:txBody>
+          <a:bodyPr wrap="square" lIns="0" tIns="0" rIns="0" bIns="0" rtlCol="0" anchor="t"/>
+          <a:lstStyle/>
+          <a:p>
+            <a:pPr algn="l" indent="0" marL="0">
+              <a:lnSpc>
+                <a:spcPts val="897"/>
+              </a:lnSpc>
+              <a:buNone/>
+            </a:pPr>
+            <a:r>
+              <a:rPr lang="en-US" sz="800" dirty="0">
+                <a:solidFill>
+                  <a:srgbClr val="1A1F2E"/>
+                </a:solidFill>
+                <a:latin typeface="Inter" pitchFamily="34" charset="0"/>
+                <a:ea typeface="Inter" pitchFamily="34" charset="-122"/>
+                <a:cs typeface="Inter" pitchFamily="34" charset="-120"/>
+              </a:rPr>
+              <a:t>Отступ знак ↔ текст:</a:t>
+            </a:r>
+            <a:pPr algn="l" indent="0" marL="0">
+              <a:lnSpc>
+                <a:spcPts val="897"/>
+              </a:lnSpc>
+              <a:buNone/>
+            </a:pPr>
+            <a:r>
+              <a:rPr lang="en-US" sz="800" dirty="0">
+                <a:solidFill>
+                  <a:srgbClr val="4A5468"/>
+                </a:solidFill>
+                <a:latin typeface="Inter" pitchFamily="34" charset="0"/>
+                <a:ea typeface="Inter" pitchFamily="34" charset="-122"/>
+                <a:cs typeface="Inter" pitchFamily="34" charset="-120"/>
+              </a:rPr>
+              <a:t> ¼ высоты знака</a:t>
+            </a:r>
+            <a:endParaRPr lang="en-US" sz="800" dirty="0"/>
+          </a:p>
+        </p:txBody>
+      </p:sp>
+      <p:sp>
+        <p:nvSpPr>
+          <p:cNvPr id="23" name="Text 19"/>
+          <p:cNvSpPr/>
+          <p:nvPr/>
+        </p:nvSpPr>
+        <p:spPr>
+          <a:xfrm>
+            <a:off x="600075" y="2700449"/>
+            <a:ext cx="3771900" cy="173124"/>
+          </a:xfrm>
+          <a:prstGeom prst="rect">
+            <a:avLst/>
+          </a:prstGeom>
+          <a:noFill/>
+          <a:ln/>
+        </p:spPr>
+        <p:txBody>
+          <a:bodyPr wrap="square" lIns="0" tIns="57150" rIns="0" bIns="0" rtlCol="0" anchor="t"/>
+          <a:lstStyle/>
+          <a:p>
+            <a:pPr algn="l" indent="0" marL="0">
+              <a:lnSpc>
+                <a:spcPts val="928"/>
+              </a:lnSpc>
+              <a:buNone/>
+            </a:pPr>
+            <a:r>
+              <a:rPr lang="en-US" sz="800" b="1" dirty="0">
+                <a:solidFill>
+                  <a:srgbClr val="1A1F2E"/>
+                </a:solidFill>
+                <a:latin typeface="Inter" pitchFamily="34" charset="0"/>
+                <a:ea typeface="Inter" pitchFamily="34" charset="-122"/>
+                <a:cs typeface="Inter" pitchFamily="34" charset="-120"/>
+              </a:rPr>
+              <a:t>Применение:</a:t>
+            </a:r>
+            <a:pPr algn="l" indent="0" marL="0">
+              <a:lnSpc>
+                <a:spcPts val="928"/>
+              </a:lnSpc>
+              <a:buNone/>
+            </a:pPr>
+            <a:r>
+              <a:rPr lang="en-US" sz="800" dirty="0">
+                <a:solidFill>
+                  <a:srgbClr val="8B95A7"/>
+                </a:solidFill>
+                <a:latin typeface="Inter" pitchFamily="34" charset="0"/>
+                <a:ea typeface="Inter" pitchFamily="34" charset="-122"/>
+                <a:cs typeface="Inter" pitchFamily="34" charset="-120"/>
+              </a:rPr>
+              <a:t> шапка веб-интерфейса, презентации, бланки, визитки.</a:t>
+            </a:r>
+            <a:endParaRPr lang="en-US" sz="800" dirty="0"/>
+          </a:p>
+        </p:txBody>
+      </p:sp>
+      <p:sp>
+        <p:nvSpPr>
+          <p:cNvPr id="24" name="Text 20"/>
+          <p:cNvSpPr/>
+          <p:nvPr/>
+        </p:nvSpPr>
+        <p:spPr>
+          <a:xfrm>
+            <a:off x="4629150" y="1273373"/>
+            <a:ext cx="4057650" cy="1714500"/>
+          </a:xfrm>
+          <a:prstGeom prst="roundRect">
+            <a:avLst>
+              <a:gd name="adj" fmla="val 13333"/>
+            </a:avLst>
+          </a:prstGeom>
+          <a:solidFill>
+            <a:srgbClr val="F9FAFB"/>
+          </a:solidFill>
+          <a:ln/>
+          <a:effectLst>
+            <a:outerShdw sx="100000" sy="100000" kx="0" ky="0" algn="bl" rotWithShape="0" blurRad="190500" dist="107763" dir="2700000">
+              <a:srgbClr val="AEB8C8">
+                <a:alpha val="45000"/>
+              </a:srgbClr>
+            </a:outerShdw>
+          </a:effectLst>
+        </p:spPr>
+        <p:txBody>
+          <a:bodyPr wrap="square" rtlCol="0" anchor="ctr"/>
+          <a:lstStyle/>
+          <a:p>
+            <a:pPr indent="0" marL="0">
+              <a:buNone/>
+            </a:pPr>
+            <a:endParaRPr lang="en-US" dirty="0"/>
+          </a:p>
+        </p:txBody>
+      </p:sp>
+      <p:sp>
+        <p:nvSpPr>
+          <p:cNvPr id="25" name="Text 21"/>
+          <p:cNvSpPr/>
+          <p:nvPr/>
+        </p:nvSpPr>
+        <p:spPr>
+          <a:xfrm>
+            <a:off x="4772025" y="1401961"/>
+            <a:ext cx="2564606" cy="215183"/>
+          </a:xfrm>
+          <a:prstGeom prst="rect">
+            <a:avLst/>
+          </a:prstGeom>
+          <a:noFill/>
+          <a:ln/>
+        </p:spPr>
+        <p:txBody>
+          <a:bodyPr wrap="none" lIns="0" tIns="0" rIns="0" bIns="0" rtlCol="0" anchor="t"/>
+          <a:lstStyle/>
+          <a:p>
+            <a:pPr algn="l" indent="0" marL="0">
+              <a:lnSpc>
+                <a:spcPts val="1569"/>
+              </a:lnSpc>
+              <a:buNone/>
+            </a:pPr>
+            <a:r>
+              <a:rPr lang="en-US" sz="1013" dirty="0">
+                <a:solidFill>
+                  <a:srgbClr val="1A1F2E"/>
+                </a:solidFill>
+                <a:latin typeface="Playfair Display" pitchFamily="34" charset="0"/>
+                <a:ea typeface="Playfair Display" pitchFamily="34" charset="-122"/>
+                <a:cs typeface="Playfair Display" pitchFamily="34" charset="-120"/>
+              </a:rPr>
+              <a:t>Вертикальная</a:t>
+            </a:r>
+            <a:endParaRPr lang="en-US" sz="1013" dirty="0"/>
+          </a:p>
+        </p:txBody>
+      </p:sp>
+      <p:sp>
+        <p:nvSpPr>
+          <p:cNvPr id="26" name="Text 22"/>
+          <p:cNvSpPr/>
+          <p:nvPr/>
+        </p:nvSpPr>
+        <p:spPr>
+          <a:xfrm>
+            <a:off x="7328059" y="1415516"/>
+            <a:ext cx="1238726" cy="172022"/>
+          </a:xfrm>
+          <a:prstGeom prst="roundRect">
+            <a:avLst>
+              <a:gd name="adj" fmla="val 5531545"/>
+            </a:avLst>
+          </a:prstGeom>
+          <a:solidFill>
+            <a:srgbClr val="C9A96E">
+              <a:alpha val="16000"/>
+            </a:srgbClr>
+          </a:solidFill>
+          <a:ln/>
+        </p:spPr>
+        <p:txBody>
+          <a:bodyPr wrap="square" rtlCol="0" anchor="ctr"/>
+          <a:lstStyle/>
+          <a:p>
+            <a:pPr indent="0" marL="0">
+              <a:buNone/>
+            </a:pPr>
+            <a:endParaRPr lang="en-US" dirty="0"/>
+          </a:p>
+        </p:txBody>
+      </p:sp>
+      <p:sp>
+        <p:nvSpPr>
+          <p:cNvPr id="27" name="Text 23"/>
+          <p:cNvSpPr/>
+          <p:nvPr/>
+        </p:nvSpPr>
+        <p:spPr>
+          <a:xfrm>
+            <a:off x="7350919" y="1424732"/>
+            <a:ext cx="1193006" cy="153591"/>
+          </a:xfrm>
+          <a:prstGeom prst="rect">
+            <a:avLst/>
+          </a:prstGeom>
+          <a:noFill/>
+          <a:ln/>
+        </p:spPr>
+        <p:txBody>
+          <a:bodyPr wrap="none" lIns="0" tIns="0" rIns="0" bIns="0" rtlCol="0" anchor="ctr"/>
+          <a:lstStyle/>
+          <a:p>
+            <a:pPr algn="ctr" indent="0" marL="0">
+              <a:lnSpc>
+                <a:spcPts val="872"/>
+              </a:lnSpc>
+              <a:buNone/>
+            </a:pPr>
+            <a:r>
+              <a:rPr lang="en-US" sz="800" spc="68" kern="0" dirty="0">
+                <a:solidFill>
+                  <a:srgbClr val="C9A96E"/>
+                </a:solidFill>
+                <a:latin typeface="Inter" pitchFamily="34" charset="0"/>
+                <a:ea typeface="Inter" pitchFamily="34" charset="-122"/>
+                <a:cs typeface="Inter" pitchFamily="34" charset="-120"/>
+              </a:rPr>
+              <a:t>ПРЕМИАЛЬНАЯ · SPLASH</a:t>
+            </a:r>
+            <a:endParaRPr lang="en-US" sz="800" dirty="0"/>
+          </a:p>
+        </p:txBody>
+      </p:sp>
+      <p:sp>
+        <p:nvSpPr>
+          <p:cNvPr id="28" name="Text 24"/>
+          <p:cNvSpPr/>
+          <p:nvPr/>
+        </p:nvSpPr>
+        <p:spPr>
+          <a:xfrm>
+            <a:off x="4772025" y="1672642"/>
+            <a:ext cx="3771900" cy="1100807"/>
+          </a:xfrm>
+          <a:prstGeom prst="roundRect">
+            <a:avLst>
+              <a:gd name="adj" fmla="val 12114"/>
+            </a:avLst>
+          </a:prstGeom>
+          <a:solidFill>
+            <a:srgbClr val="F1F4F6"/>
+          </a:solidFill>
+          <a:ln/>
+        </p:spPr>
+        <p:txBody>
+          <a:bodyPr wrap="square" rtlCol="0" anchor="ctr"/>
+          <a:lstStyle/>
+          <a:p>
+            <a:pPr indent="0" marL="0">
+              <a:buNone/>
+            </a:pPr>
+            <a:endParaRPr lang="en-US" dirty="0"/>
+          </a:p>
+        </p:txBody>
+      </p:sp>
+      <p:sp>
+        <p:nvSpPr>
+          <p:cNvPr id="29" name="Text 25"/>
+          <p:cNvSpPr/>
+          <p:nvPr/>
+        </p:nvSpPr>
+        <p:spPr>
+          <a:xfrm>
+            <a:off x="6400800" y="1786942"/>
+            <a:ext cx="514350" cy="514350"/>
+          </a:xfrm>
+          <a:prstGeom prst="ellipse">
+            <a:avLst/>
+          </a:prstGeom>
+          <a:solidFill>
+            <a:srgbClr val="5ECEC1"/>
+          </a:solidFill>
+          <a:ln/>
+        </p:spPr>
+        <p:txBody>
+          <a:bodyPr wrap="square" rtlCol="0" anchor="ctr"/>
+          <a:lstStyle/>
+          <a:p>
+            <a:pPr indent="0" marL="0">
+              <a:buNone/>
+            </a:pPr>
+            <a:endParaRPr lang="en-US" dirty="0"/>
+          </a:p>
+        </p:txBody>
+      </p:sp>
+      <p:sp>
+        <p:nvSpPr>
+          <p:cNvPr id="30" name="Text 26"/>
+          <p:cNvSpPr/>
+          <p:nvPr/>
+        </p:nvSpPr>
+        <p:spPr>
+          <a:xfrm>
+            <a:off x="6440448" y="1826590"/>
+            <a:ext cx="435054" cy="435054"/>
+          </a:xfrm>
+          <a:prstGeom prst="rect">
+            <a:avLst/>
+          </a:prstGeom>
+          <a:noFill/>
+          <a:ln/>
+        </p:spPr>
+        <p:txBody>
+          <a:bodyPr wrap="none" lIns="0" tIns="0" rIns="0" bIns="0" rtlCol="0" anchor="ctr"/>
+          <a:lstStyle/>
+          <a:p>
+            <a:pPr algn="ctr" indent="0" marL="0">
+              <a:buNone/>
+            </a:pPr>
+            <a:r>
+              <a:rPr lang="en-US" sz="2953" dirty="0">
+                <a:solidFill>
+                  <a:srgbClr val="FFFFFF"/>
+                </a:solidFill>
+                <a:latin typeface="Segoe UI Symbol" pitchFamily="34" charset="0"/>
+                <a:ea typeface="Segoe UI Symbol" pitchFamily="34" charset="-122"/>
+                <a:cs typeface="Segoe UI Symbol" pitchFamily="34" charset="-120"/>
+              </a:rPr>
+              <a:t>↻</a:t>
+            </a:r>
+            <a:endParaRPr lang="en-US" sz="2953" dirty="0"/>
+          </a:p>
+        </p:txBody>
+      </p:sp>
+      <p:sp>
+        <p:nvSpPr>
+          <p:cNvPr id="31" name="Text 27"/>
+          <p:cNvSpPr/>
+          <p:nvPr/>
+        </p:nvSpPr>
+        <p:spPr>
+          <a:xfrm>
+            <a:off x="5852796" y="2415592"/>
+            <a:ext cx="1610358" cy="243557"/>
+          </a:xfrm>
+          <a:prstGeom prst="rect">
+            <a:avLst/>
+          </a:prstGeom>
+          <a:noFill/>
+          <a:ln/>
+        </p:spPr>
+        <p:txBody>
+          <a:bodyPr wrap="none" lIns="0" tIns="0" rIns="0" bIns="0" rtlCol="0" anchor="t"/>
+          <a:lstStyle/>
+          <a:p>
+            <a:pPr algn="ctr" indent="0" marL="0">
+              <a:lnSpc>
+                <a:spcPts val="1918"/>
+              </a:lnSpc>
+              <a:buNone/>
+            </a:pPr>
+            <a:r>
+              <a:rPr lang="en-US" sz="1238" b="1" spc="396" kern="0" dirty="0">
+                <a:solidFill>
+                  <a:srgbClr val="1A1F2E"/>
+                </a:solidFill>
+                <a:latin typeface="Playfair Display" pitchFamily="34" charset="0"/>
+                <a:ea typeface="Playfair Display" pitchFamily="34" charset="-122"/>
+                <a:cs typeface="Playfair Display" pitchFamily="34" charset="-120"/>
+              </a:rPr>
+              <a:t>АЛЬТЕРА</a:t>
+            </a:r>
+            <a:endParaRPr lang="en-US" sz="1238" dirty="0"/>
+          </a:p>
+        </p:txBody>
+      </p:sp>
+      <p:sp>
+        <p:nvSpPr>
+          <p:cNvPr id="32" name="Text 28"/>
+          <p:cNvSpPr/>
+          <p:nvPr/>
+        </p:nvSpPr>
+        <p:spPr>
+          <a:xfrm>
+            <a:off x="4772025" y="2844887"/>
+            <a:ext cx="1835944" cy="91440"/>
+          </a:xfrm>
+          <a:prstGeom prst="rect">
+            <a:avLst/>
+          </a:prstGeom>
+          <a:noFill/>
+          <a:ln/>
+        </p:spPr>
+        <p:txBody>
+          <a:bodyPr wrap="square" lIns="0" tIns="0" rIns="0" bIns="0" rtlCol="0" anchor="t"/>
+          <a:lstStyle/>
+          <a:p>
+            <a:pPr algn="l" indent="0" marL="0">
+              <a:lnSpc>
+                <a:spcPts val="897"/>
+              </a:lnSpc>
+              <a:buNone/>
+            </a:pPr>
+            <a:r>
+              <a:rPr lang="en-US" sz="800" dirty="0">
+                <a:solidFill>
+                  <a:srgbClr val="1A1F2E"/>
+                </a:solidFill>
+                <a:latin typeface="Inter" pitchFamily="34" charset="0"/>
+                <a:ea typeface="Inter" pitchFamily="34" charset="-122"/>
+                <a:cs typeface="Inter" pitchFamily="34" charset="-120"/>
+              </a:rPr>
+              <a:t>Композиция:</a:t>
+            </a:r>
+            <a:pPr algn="l" indent="0" marL="0">
+              <a:lnSpc>
+                <a:spcPts val="897"/>
+              </a:lnSpc>
+              <a:buNone/>
+            </a:pPr>
+            <a:r>
+              <a:rPr lang="en-US" sz="800" dirty="0">
+                <a:solidFill>
+                  <a:srgbClr val="4A5468"/>
+                </a:solidFill>
+                <a:latin typeface="Inter" pitchFamily="34" charset="0"/>
+                <a:ea typeface="Inter" pitchFamily="34" charset="-122"/>
+                <a:cs typeface="Inter" pitchFamily="34" charset="-120"/>
+              </a:rPr>
+              <a:t> знак сверху, текст по центру снизу</a:t>
+            </a:r>
+            <a:endParaRPr lang="en-US" sz="800" dirty="0"/>
+          </a:p>
+        </p:txBody>
+      </p:sp>
+      <p:sp>
+        <p:nvSpPr>
+          <p:cNvPr id="33" name="Text 29"/>
+          <p:cNvSpPr/>
+          <p:nvPr/>
+        </p:nvSpPr>
+        <p:spPr>
+          <a:xfrm>
+            <a:off x="6707981" y="2844887"/>
+            <a:ext cx="1835944" cy="91440"/>
+          </a:xfrm>
+          <a:prstGeom prst="rect">
+            <a:avLst/>
+          </a:prstGeom>
+          <a:noFill/>
+          <a:ln/>
+        </p:spPr>
+        <p:txBody>
+          <a:bodyPr wrap="square" lIns="0" tIns="0" rIns="0" bIns="0" rtlCol="0" anchor="t"/>
+          <a:lstStyle/>
+          <a:p>
+            <a:pPr algn="l" indent="0" marL="0">
+              <a:lnSpc>
+                <a:spcPts val="897"/>
+              </a:lnSpc>
+              <a:buNone/>
+            </a:pPr>
+            <a:r>
+              <a:rPr lang="en-US" sz="800" dirty="0">
+                <a:solidFill>
+                  <a:srgbClr val="1A1F2E"/>
+                </a:solidFill>
+                <a:latin typeface="Inter" pitchFamily="34" charset="0"/>
+                <a:ea typeface="Inter" pitchFamily="34" charset="-122"/>
+                <a:cs typeface="Inter" pitchFamily="34" charset="-120"/>
+              </a:rPr>
+              <a:t>Выравнивание:</a:t>
+            </a:r>
+            <a:pPr algn="l" indent="0" marL="0">
+              <a:lnSpc>
+                <a:spcPts val="897"/>
+              </a:lnSpc>
+              <a:buNone/>
+            </a:pPr>
+            <a:r>
+              <a:rPr lang="en-US" sz="800" dirty="0">
+                <a:solidFill>
+                  <a:srgbClr val="4A5468"/>
+                </a:solidFill>
+                <a:latin typeface="Inter" pitchFamily="34" charset="0"/>
+                <a:ea typeface="Inter" pitchFamily="34" charset="-122"/>
+                <a:cs typeface="Inter" pitchFamily="34" charset="-120"/>
+              </a:rPr>
+              <a:t> строго по оси симметрии</a:t>
+            </a:r>
+            <a:endParaRPr lang="en-US" sz="800" dirty="0"/>
+          </a:p>
+        </p:txBody>
+      </p:sp>
+      <p:sp>
+        <p:nvSpPr>
+          <p:cNvPr id="34" name="Text 30"/>
+          <p:cNvSpPr/>
+          <p:nvPr/>
+        </p:nvSpPr>
+        <p:spPr>
+          <a:xfrm>
+            <a:off x="4772025" y="3101169"/>
+            <a:ext cx="1982819" cy="91440"/>
+          </a:xfrm>
+          <a:prstGeom prst="rect">
+            <a:avLst/>
+          </a:prstGeom>
+          <a:noFill/>
+          <a:ln/>
+        </p:spPr>
+        <p:txBody>
+          <a:bodyPr wrap="square" lIns="0" tIns="0" rIns="0" bIns="0" rtlCol="0" anchor="t"/>
+          <a:lstStyle/>
+          <a:p>
+            <a:pPr algn="l" indent="0" marL="0">
+              <a:lnSpc>
+                <a:spcPts val="897"/>
+              </a:lnSpc>
+              <a:buNone/>
+            </a:pPr>
+            <a:r>
+              <a:rPr lang="en-US" sz="800" dirty="0">
+                <a:solidFill>
+                  <a:srgbClr val="1A1F2E"/>
+                </a:solidFill>
+                <a:latin typeface="Inter" pitchFamily="34" charset="0"/>
+                <a:ea typeface="Inter" pitchFamily="34" charset="-122"/>
+                <a:cs typeface="Inter" pitchFamily="34" charset="-120"/>
+              </a:rPr>
+              <a:t>Отступ знак ↔ текст:</a:t>
+            </a:r>
+            <a:pPr algn="l" indent="0" marL="0">
+              <a:lnSpc>
+                <a:spcPts val="897"/>
+              </a:lnSpc>
+              <a:buNone/>
+            </a:pPr>
+            <a:r>
+              <a:rPr lang="en-US" sz="800" dirty="0">
+                <a:solidFill>
+                  <a:srgbClr val="4A5468"/>
+                </a:solidFill>
+                <a:latin typeface="Inter" pitchFamily="34" charset="0"/>
+                <a:ea typeface="Inter" pitchFamily="34" charset="-122"/>
+                <a:cs typeface="Inter" pitchFamily="34" charset="-120"/>
+              </a:rPr>
+              <a:t> ½ высоты знака</a:t>
+            </a:r>
+            <a:endParaRPr lang="en-US" sz="800" dirty="0"/>
+          </a:p>
+        </p:txBody>
+      </p:sp>
+      <p:sp>
+        <p:nvSpPr>
+          <p:cNvPr id="35" name="Text 31"/>
+          <p:cNvSpPr/>
+          <p:nvPr/>
+        </p:nvSpPr>
+        <p:spPr>
+          <a:xfrm>
+            <a:off x="6707981" y="3101169"/>
+            <a:ext cx="1945672" cy="91440"/>
+          </a:xfrm>
+          <a:prstGeom prst="rect">
+            <a:avLst/>
+          </a:prstGeom>
+          <a:noFill/>
+          <a:ln/>
+        </p:spPr>
+        <p:txBody>
+          <a:bodyPr wrap="square" lIns="0" tIns="0" rIns="0" bIns="0" rtlCol="0" anchor="t"/>
+          <a:lstStyle/>
+          <a:p>
+            <a:pPr algn="l" indent="0" marL="0">
+              <a:lnSpc>
+                <a:spcPts val="897"/>
+              </a:lnSpc>
+              <a:buNone/>
+            </a:pPr>
+            <a:r>
+              <a:rPr lang="en-US" sz="800" dirty="0">
+                <a:solidFill>
+                  <a:srgbClr val="1A1F2E"/>
+                </a:solidFill>
+                <a:latin typeface="Inter" pitchFamily="34" charset="0"/>
+                <a:ea typeface="Inter" pitchFamily="34" charset="-122"/>
+                <a:cs typeface="Inter" pitchFamily="34" charset="-120"/>
+              </a:rPr>
+              <a:t>Эффект:</a:t>
+            </a:r>
+            <a:pPr algn="l" indent="0" marL="0">
+              <a:lnSpc>
+                <a:spcPts val="897"/>
+              </a:lnSpc>
+              <a:buNone/>
+            </a:pPr>
+            <a:r>
+              <a:rPr lang="en-US" sz="800" dirty="0">
+                <a:solidFill>
+                  <a:srgbClr val="4A5468"/>
+                </a:solidFill>
+                <a:latin typeface="Inter" pitchFamily="34" charset="0"/>
+                <a:ea typeface="Inter" pitchFamily="34" charset="-122"/>
+                <a:cs typeface="Inter" pitchFamily="34" charset="-120"/>
+              </a:rPr>
+              <a:t> «воздух» и цельность блока</a:t>
+            </a:r>
+            <a:endParaRPr lang="en-US" sz="800" dirty="0"/>
+          </a:p>
+        </p:txBody>
+      </p:sp>
+      <p:sp>
+        <p:nvSpPr>
+          <p:cNvPr id="36" name="Text 32"/>
+          <p:cNvSpPr/>
+          <p:nvPr/>
+        </p:nvSpPr>
+        <p:spPr>
+          <a:xfrm>
+            <a:off x="4772025" y="3286460"/>
+            <a:ext cx="3771900" cy="91440"/>
+          </a:xfrm>
+          <a:prstGeom prst="rect">
+            <a:avLst/>
+          </a:prstGeom>
+          <a:noFill/>
+          <a:ln/>
+        </p:spPr>
+        <p:txBody>
+          <a:bodyPr wrap="square" lIns="0" tIns="57150" rIns="0" bIns="0" rtlCol="0" anchor="t"/>
+          <a:lstStyle/>
+          <a:p>
+            <a:pPr algn="l" indent="0" marL="0">
+              <a:lnSpc>
+                <a:spcPts val="928"/>
+              </a:lnSpc>
+              <a:buNone/>
+            </a:pPr>
+            <a:r>
+              <a:rPr lang="en-US" sz="800" b="1" dirty="0">
+                <a:solidFill>
+                  <a:srgbClr val="1A1F2E"/>
+                </a:solidFill>
+                <a:latin typeface="Inter" pitchFamily="34" charset="0"/>
+                <a:ea typeface="Inter" pitchFamily="34" charset="-122"/>
+                <a:cs typeface="Inter" pitchFamily="34" charset="-120"/>
+              </a:rPr>
+              <a:t>Применение:</a:t>
+            </a:r>
+            <a:pPr algn="l" indent="0" marL="0">
+              <a:lnSpc>
+                <a:spcPts val="928"/>
+              </a:lnSpc>
+              <a:buNone/>
+            </a:pPr>
+            <a:r>
+              <a:rPr lang="en-US" sz="800" dirty="0">
+                <a:solidFill>
+                  <a:srgbClr val="8B95A7"/>
+                </a:solidFill>
+                <a:latin typeface="Inter" pitchFamily="34" charset="0"/>
+                <a:ea typeface="Inter" pitchFamily="34" charset="-122"/>
+                <a:cs typeface="Inter" pitchFamily="34" charset="-120"/>
+              </a:rPr>
+              <a:t> splash-скрины, заставки видео, обложки буклетов и плакатов.</a:t>
+            </a:r>
+            <a:endParaRPr lang="en-US" sz="800" dirty="0"/>
+          </a:p>
+        </p:txBody>
+      </p:sp>
+      <p:sp>
+        <p:nvSpPr>
+          <p:cNvPr id="37" name="Text 33"/>
+          <p:cNvSpPr/>
+          <p:nvPr/>
+        </p:nvSpPr>
+        <p:spPr>
+          <a:xfrm>
+            <a:off x="457200" y="3102173"/>
+            <a:ext cx="4993928" cy="1428750"/>
+          </a:xfrm>
+          <a:prstGeom prst="roundRect">
+            <a:avLst>
+              <a:gd name="adj" fmla="val 16000"/>
+            </a:avLst>
+          </a:prstGeom>
+          <a:solidFill>
+            <a:srgbClr val="F9FAFB"/>
+          </a:solidFill>
+          <a:ln/>
+          <a:effectLst>
+            <a:outerShdw sx="100000" sy="100000" kx="0" ky="0" algn="bl" rotWithShape="0" blurRad="190500" dist="107763" dir="2700000">
+              <a:srgbClr val="AEB8C8">
+                <a:alpha val="45000"/>
+              </a:srgbClr>
+            </a:outerShdw>
+          </a:effectLst>
+        </p:spPr>
+        <p:txBody>
+          <a:bodyPr wrap="square" rtlCol="0" anchor="ctr"/>
+          <a:lstStyle/>
+          <a:p>
+            <a:pPr indent="0" marL="0">
+              <a:buNone/>
+            </a:pPr>
+            <a:endParaRPr lang="en-US" dirty="0"/>
+          </a:p>
+        </p:txBody>
+      </p:sp>
+      <p:sp>
+        <p:nvSpPr>
+          <p:cNvPr id="38" name="Text 34"/>
+          <p:cNvSpPr/>
+          <p:nvPr/>
+        </p:nvSpPr>
+        <p:spPr>
+          <a:xfrm>
+            <a:off x="614363" y="3230761"/>
+            <a:ext cx="4789331" cy="191314"/>
+          </a:xfrm>
+          <a:prstGeom prst="rect">
+            <a:avLst/>
+          </a:prstGeom>
+          <a:noFill/>
+          <a:ln/>
+        </p:spPr>
+        <p:txBody>
+          <a:bodyPr wrap="square" lIns="0" tIns="0" rIns="0" bIns="0" rtlCol="0" anchor="t"/>
+          <a:lstStyle/>
+          <a:p>
+            <a:pPr algn="l" indent="0" marL="0">
+              <a:lnSpc>
+                <a:spcPts val="1395"/>
+              </a:lnSpc>
+              <a:buNone/>
+            </a:pPr>
+            <a:r>
+              <a:rPr lang="en-US" sz="900" dirty="0">
+                <a:solidFill>
+                  <a:srgbClr val="1A1F2E"/>
+                </a:solidFill>
+                <a:latin typeface="Playfair Display" pitchFamily="34" charset="0"/>
+                <a:ea typeface="Playfair Display" pitchFamily="34" charset="-122"/>
+                <a:cs typeface="Playfair Display" pitchFamily="34" charset="-120"/>
+              </a:rPr>
+              <a:t>Охранное поле комбинированного логотипа</a:t>
+            </a:r>
+            <a:endParaRPr lang="en-US" sz="900" dirty="0"/>
+          </a:p>
+        </p:txBody>
+      </p:sp>
+      <p:sp>
+        <p:nvSpPr>
+          <p:cNvPr id="39" name="Text 35"/>
+          <p:cNvSpPr/>
+          <p:nvPr/>
+        </p:nvSpPr>
+        <p:spPr>
+          <a:xfrm>
+            <a:off x="614363" y="3450766"/>
+            <a:ext cx="4679603" cy="165784"/>
+          </a:xfrm>
+          <a:prstGeom prst="rect">
+            <a:avLst/>
+          </a:prstGeom>
+          <a:noFill/>
+          <a:ln/>
+        </p:spPr>
+        <p:txBody>
+          <a:bodyPr wrap="square" lIns="0" tIns="0" rIns="0" bIns="0" rtlCol="0" anchor="t">
+            <a:normAutofit/>
+          </a:bodyPr>
+          <a:lstStyle/>
+          <a:p>
+            <a:pPr algn="l" indent="0" marL="0">
+              <a:lnSpc>
+                <a:spcPts val="959"/>
+              </a:lnSpc>
+              <a:buNone/>
+            </a:pPr>
+            <a:r>
+              <a:rPr lang="en-US" sz="800" dirty="0">
+                <a:solidFill>
+                  <a:srgbClr val="8B95A7"/>
+                </a:solidFill>
+                <a:latin typeface="Inter" pitchFamily="34" charset="0"/>
+                <a:ea typeface="Inter" pitchFamily="34" charset="-122"/>
+                <a:cs typeface="Inter" pitchFamily="34" charset="-120"/>
+              </a:rPr>
+              <a:t>Единица измерения — высота всего блока (знака или текста).</a:t>
+            </a:r>
+            <a:endParaRPr lang="en-US" sz="800" dirty="0"/>
+          </a:p>
+        </p:txBody>
+      </p:sp>
+      <p:sp>
+        <p:nvSpPr>
+          <p:cNvPr id="40" name="Text 36"/>
+          <p:cNvSpPr/>
+          <p:nvPr/>
+        </p:nvSpPr>
+        <p:spPr>
+          <a:xfrm>
+            <a:off x="614363" y="3642339"/>
+            <a:ext cx="651532" cy="164021"/>
+          </a:xfrm>
+          <a:prstGeom prst="roundRect">
+            <a:avLst>
+              <a:gd name="adj" fmla="val 5801376"/>
+            </a:avLst>
+          </a:prstGeom>
+          <a:solidFill>
+            <a:srgbClr val="5ECEC1">
+              <a:alpha val="12000"/>
+            </a:srgbClr>
+          </a:solidFill>
+          <a:ln/>
+        </p:spPr>
+        <p:txBody>
+          <a:bodyPr wrap="square" rtlCol="0" anchor="ctr"/>
+          <a:lstStyle/>
+          <a:p>
+            <a:pPr indent="0" marL="0">
+              <a:buNone/>
+            </a:pPr>
+            <a:endParaRPr lang="en-US" dirty="0"/>
+          </a:p>
+        </p:txBody>
+      </p:sp>
+      <p:sp>
+        <p:nvSpPr>
+          <p:cNvPr id="41" name="Text 37"/>
+          <p:cNvSpPr/>
+          <p:nvPr/>
+        </p:nvSpPr>
+        <p:spPr>
+          <a:xfrm>
+            <a:off x="598651" y="3651126"/>
+            <a:ext cx="682955" cy="146447"/>
+          </a:xfrm>
+          <a:prstGeom prst="rect">
+            <a:avLst/>
+          </a:prstGeom>
+          <a:noFill/>
+          <a:ln/>
+        </p:spPr>
+        <p:txBody>
+          <a:bodyPr wrap="none" lIns="0" tIns="0" rIns="0" bIns="0" rtlCol="0" anchor="ctr"/>
+          <a:lstStyle/>
+          <a:p>
+            <a:pPr algn="ctr" indent="0" marL="0">
+              <a:lnSpc>
+                <a:spcPts val="816"/>
+              </a:lnSpc>
+              <a:buNone/>
+            </a:pPr>
+            <a:r>
+              <a:rPr lang="en-US" sz="800" spc="34" kern="0" dirty="0">
+                <a:solidFill>
+                  <a:srgbClr val="46B0A3"/>
+                </a:solidFill>
+                <a:latin typeface="Inter" pitchFamily="34" charset="0"/>
+                <a:ea typeface="Inter" pitchFamily="34" charset="-122"/>
+                <a:cs typeface="Inter" pitchFamily="34" charset="-120"/>
+              </a:rPr>
+              <a:t>UI · СВЕТЛАЯ</a:t>
+            </a:r>
+            <a:endParaRPr lang="en-US" sz="800" dirty="0"/>
+          </a:p>
+        </p:txBody>
+      </p:sp>
+      <p:sp>
+        <p:nvSpPr>
+          <p:cNvPr id="42" name="Text 38"/>
+          <p:cNvSpPr/>
+          <p:nvPr/>
+        </p:nvSpPr>
+        <p:spPr>
+          <a:xfrm>
+            <a:off x="1337332" y="3643982"/>
+            <a:ext cx="3956633" cy="159020"/>
+          </a:xfrm>
+          <a:prstGeom prst="rect">
+            <a:avLst/>
+          </a:prstGeom>
+          <a:noFill/>
+          <a:ln/>
+        </p:spPr>
+        <p:txBody>
+          <a:bodyPr wrap="square" lIns="0" tIns="0" rIns="0" bIns="0" rtlCol="0" anchor="t"/>
+          <a:lstStyle/>
+          <a:p>
+            <a:pPr algn="l" indent="0" marL="0">
+              <a:lnSpc>
+                <a:spcPts val="979"/>
+              </a:lnSpc>
+              <a:buNone/>
+            </a:pPr>
+            <a:r>
+              <a:rPr lang="en-US" sz="800" dirty="0">
+                <a:solidFill>
+                  <a:srgbClr val="1A1F2E"/>
+                </a:solidFill>
+                <a:latin typeface="Inter" pitchFamily="34" charset="0"/>
+                <a:ea typeface="Inter" pitchFamily="34" charset="-122"/>
+                <a:cs typeface="Inter" pitchFamily="34" charset="-120"/>
+              </a:rPr>
+              <a:t>¼ высоты логотипа до края контейнера. ≈ 16–24 пикселя для интерфейса.</a:t>
+            </a:r>
+            <a:endParaRPr lang="en-US" sz="800" dirty="0"/>
+          </a:p>
+        </p:txBody>
+      </p:sp>
+      <p:sp>
+        <p:nvSpPr>
+          <p:cNvPr id="43" name="Text 39"/>
+          <p:cNvSpPr/>
+          <p:nvPr/>
+        </p:nvSpPr>
+        <p:spPr>
+          <a:xfrm>
+            <a:off x="614363" y="3845936"/>
+            <a:ext cx="678656" cy="164021"/>
+          </a:xfrm>
+          <a:prstGeom prst="roundRect">
+            <a:avLst>
+              <a:gd name="adj" fmla="val 5801376"/>
+            </a:avLst>
+          </a:prstGeom>
+          <a:solidFill>
+            <a:srgbClr val="C9A96E">
+              <a:alpha val="16000"/>
+            </a:srgbClr>
+          </a:solidFill>
+          <a:ln/>
+        </p:spPr>
+        <p:txBody>
+          <a:bodyPr wrap="square" rtlCol="0" anchor="ctr"/>
+          <a:lstStyle/>
+          <a:p>
+            <a:pPr indent="0" marL="0">
+              <a:buNone/>
+            </a:pPr>
+            <a:endParaRPr lang="en-US" dirty="0"/>
+          </a:p>
+        </p:txBody>
+      </p:sp>
+      <p:sp>
+        <p:nvSpPr>
+          <p:cNvPr id="44" name="Text 40"/>
+          <p:cNvSpPr/>
+          <p:nvPr/>
+        </p:nvSpPr>
+        <p:spPr>
+          <a:xfrm>
+            <a:off x="614363" y="3854723"/>
+            <a:ext cx="678656" cy="146447"/>
+          </a:xfrm>
+          <a:prstGeom prst="rect">
+            <a:avLst/>
+          </a:prstGeom>
+          <a:noFill/>
+          <a:ln/>
+        </p:spPr>
+        <p:txBody>
+          <a:bodyPr wrap="none" lIns="0" tIns="0" rIns="0" bIns="0" rtlCol="0" anchor="ctr"/>
+          <a:lstStyle/>
+          <a:p>
+            <a:pPr algn="ctr" indent="0" marL="0">
+              <a:lnSpc>
+                <a:spcPts val="816"/>
+              </a:lnSpc>
+              <a:buNone/>
+            </a:pPr>
+            <a:r>
+              <a:rPr lang="en-US" sz="800" spc="34" kern="0" dirty="0">
+                <a:solidFill>
+                  <a:srgbClr val="C9A96E"/>
+                </a:solidFill>
+                <a:latin typeface="Inter" pitchFamily="34" charset="0"/>
+                <a:ea typeface="Inter" pitchFamily="34" charset="-122"/>
+                <a:cs typeface="Inter" pitchFamily="34" charset="-120"/>
+              </a:rPr>
+              <a:t>ПОЛИГРАФИЯ</a:t>
+            </a:r>
+            <a:endParaRPr lang="en-US" sz="800" dirty="0"/>
+          </a:p>
+        </p:txBody>
+      </p:sp>
+      <p:sp>
+        <p:nvSpPr>
+          <p:cNvPr id="45" name="Text 41"/>
+          <p:cNvSpPr/>
+          <p:nvPr/>
+        </p:nvSpPr>
+        <p:spPr>
+          <a:xfrm>
+            <a:off x="1364456" y="3847579"/>
+            <a:ext cx="3929509" cy="159020"/>
+          </a:xfrm>
+          <a:prstGeom prst="rect">
+            <a:avLst/>
+          </a:prstGeom>
+          <a:noFill/>
+          <a:ln/>
+        </p:spPr>
+        <p:txBody>
+          <a:bodyPr wrap="square" lIns="0" tIns="0" rIns="0" bIns="0" rtlCol="0" anchor="t"/>
+          <a:lstStyle/>
+          <a:p>
+            <a:pPr algn="l" indent="0" marL="0">
+              <a:lnSpc>
+                <a:spcPts val="979"/>
+              </a:lnSpc>
+              <a:buNone/>
+            </a:pPr>
+            <a:r>
+              <a:rPr lang="en-US" sz="800" dirty="0">
+                <a:solidFill>
+                  <a:srgbClr val="1A1F2E"/>
+                </a:solidFill>
+                <a:latin typeface="Inter" pitchFamily="34" charset="0"/>
+                <a:ea typeface="Inter" pitchFamily="34" charset="-122"/>
+                <a:cs typeface="Inter" pitchFamily="34" charset="-120"/>
+              </a:rPr>
+              <a:t>½ высоты логотипа, но не менее 3 мм. Визитки, бланки, конверты.</a:t>
+            </a:r>
+            <a:endParaRPr lang="en-US" sz="800" dirty="0"/>
+          </a:p>
+        </p:txBody>
+      </p:sp>
+      <p:sp>
+        <p:nvSpPr>
+          <p:cNvPr id="46" name="Text 42"/>
+          <p:cNvSpPr/>
+          <p:nvPr/>
+        </p:nvSpPr>
+        <p:spPr>
+          <a:xfrm>
+            <a:off x="614363" y="4049533"/>
+            <a:ext cx="557213" cy="164021"/>
+          </a:xfrm>
+          <a:prstGeom prst="roundRect">
+            <a:avLst>
+              <a:gd name="adj" fmla="val 5801376"/>
+            </a:avLst>
+          </a:prstGeom>
+          <a:solidFill>
+            <a:srgbClr val="8B95A7">
+              <a:alpha val="18000"/>
+            </a:srgbClr>
+          </a:solidFill>
+          <a:ln/>
+        </p:spPr>
+        <p:txBody>
+          <a:bodyPr wrap="square" rtlCol="0" anchor="ctr"/>
+          <a:lstStyle/>
+          <a:p>
+            <a:pPr indent="0" marL="0">
+              <a:buNone/>
+            </a:pPr>
+            <a:endParaRPr lang="en-US" dirty="0"/>
+          </a:p>
+        </p:txBody>
+      </p:sp>
+      <p:sp>
+        <p:nvSpPr>
+          <p:cNvPr id="47" name="Text 43"/>
+          <p:cNvSpPr/>
+          <p:nvPr/>
+        </p:nvSpPr>
+        <p:spPr>
+          <a:xfrm>
+            <a:off x="614363" y="4058320"/>
+            <a:ext cx="557213" cy="146447"/>
+          </a:xfrm>
+          <a:prstGeom prst="rect">
+            <a:avLst/>
+          </a:prstGeom>
+          <a:noFill/>
+          <a:ln/>
+        </p:spPr>
+        <p:txBody>
+          <a:bodyPr wrap="none" lIns="0" tIns="0" rIns="0" bIns="0" rtlCol="0" anchor="ctr"/>
+          <a:lstStyle/>
+          <a:p>
+            <a:pPr algn="ctr" indent="0" marL="0">
+              <a:lnSpc>
+                <a:spcPts val="816"/>
+              </a:lnSpc>
+              <a:buNone/>
+            </a:pPr>
+            <a:r>
+              <a:rPr lang="en-US" sz="800" spc="34" kern="0" dirty="0">
+                <a:solidFill>
+                  <a:srgbClr val="4A5468"/>
+                </a:solidFill>
+                <a:latin typeface="Inter" pitchFamily="34" charset="0"/>
+                <a:ea typeface="Inter" pitchFamily="34" charset="-122"/>
+                <a:cs typeface="Inter" pitchFamily="34" charset="-120"/>
+              </a:rPr>
+              <a:t>СЛОЖНЫЕ</a:t>
+            </a:r>
+            <a:endParaRPr lang="en-US" sz="800" dirty="0"/>
+          </a:p>
+        </p:txBody>
+      </p:sp>
+      <p:sp>
+        <p:nvSpPr>
+          <p:cNvPr id="48" name="Text 44"/>
+          <p:cNvSpPr/>
+          <p:nvPr/>
+        </p:nvSpPr>
+        <p:spPr>
+          <a:xfrm>
+            <a:off x="1243013" y="4051176"/>
+            <a:ext cx="4050953" cy="159020"/>
+          </a:xfrm>
+          <a:prstGeom prst="rect">
+            <a:avLst/>
+          </a:prstGeom>
+          <a:noFill/>
+          <a:ln/>
+        </p:spPr>
+        <p:txBody>
+          <a:bodyPr wrap="square" lIns="0" tIns="0" rIns="0" bIns="0" rtlCol="0" anchor="t"/>
+          <a:lstStyle/>
+          <a:p>
+            <a:pPr algn="l" indent="0" marL="0">
+              <a:lnSpc>
+                <a:spcPts val="979"/>
+              </a:lnSpc>
+              <a:buNone/>
+            </a:pPr>
+            <a:r>
+              <a:rPr lang="en-US" sz="800" dirty="0">
+                <a:solidFill>
+                  <a:srgbClr val="1A1F2E"/>
+                </a:solidFill>
+                <a:latin typeface="Inter" pitchFamily="34" charset="0"/>
+                <a:ea typeface="Inter" pitchFamily="34" charset="-122"/>
+                <a:cs typeface="Inter" pitchFamily="34" charset="-120"/>
+              </a:rPr>
+              <a:t>1 высота логотипа во все стороны. Плакаты, баннеры с другими элементами.</a:t>
+            </a:r>
+            <a:endParaRPr lang="en-US" sz="800" dirty="0"/>
+          </a:p>
+        </p:txBody>
+      </p:sp>
+      <p:sp>
+        <p:nvSpPr>
+          <p:cNvPr id="49" name="Text 45"/>
+          <p:cNvSpPr/>
+          <p:nvPr/>
+        </p:nvSpPr>
+        <p:spPr>
+          <a:xfrm>
+            <a:off x="5565428" y="3102173"/>
+            <a:ext cx="3121372" cy="457200"/>
+          </a:xfrm>
+          <a:prstGeom prst="roundRect">
+            <a:avLst>
+              <a:gd name="adj" fmla="val 25000"/>
+            </a:avLst>
+          </a:prstGeom>
+          <a:solidFill>
+            <a:srgbClr val="5ECEC1">
+              <a:alpha val="12000"/>
+            </a:srgbClr>
+          </a:solidFill>
+          <a:ln/>
+        </p:spPr>
+        <p:txBody>
+          <a:bodyPr wrap="square" rtlCol="0" anchor="ctr"/>
+          <a:lstStyle/>
+          <a:p>
+            <a:pPr indent="0" marL="0">
+              <a:buNone/>
+            </a:pPr>
+            <a:endParaRPr lang="en-US" dirty="0"/>
+          </a:p>
+        </p:txBody>
+      </p:sp>
+      <p:sp>
+        <p:nvSpPr>
+          <p:cNvPr id="50" name="Text 46"/>
+          <p:cNvSpPr/>
+          <p:nvPr/>
+        </p:nvSpPr>
+        <p:spPr>
+          <a:xfrm>
+            <a:off x="5694015" y="3252192"/>
+            <a:ext cx="157163" cy="157163"/>
+          </a:xfrm>
+          <a:prstGeom prst="rect">
+            <a:avLst/>
+          </a:prstGeom>
+          <a:noFill/>
+          <a:ln/>
+        </p:spPr>
+        <p:txBody>
+          <a:bodyPr wrap="none" lIns="0" tIns="0" rIns="0" bIns="0" rtlCol="0" anchor="ctr"/>
+          <a:lstStyle/>
+          <a:p>
+            <a:pPr algn="ctr" indent="0" marL="0">
+              <a:buNone/>
+            </a:pPr>
+            <a:r>
+              <a:rPr lang="en-US" sz="1547" dirty="0">
+                <a:solidFill>
+                  <a:srgbClr val="46B0A3"/>
+                </a:solidFill>
+                <a:latin typeface="Segoe UI Symbol" pitchFamily="34" charset="0"/>
+                <a:ea typeface="Segoe UI Symbol" pitchFamily="34" charset="-122"/>
+                <a:cs typeface="Segoe UI Symbol" pitchFamily="34" charset="-120"/>
+              </a:rPr>
+              <a:t>←</a:t>
+            </a:r>
+            <a:endParaRPr lang="en-US" sz="1547" dirty="0"/>
+          </a:p>
+        </p:txBody>
+      </p:sp>
+      <p:sp>
+        <p:nvSpPr>
+          <p:cNvPr id="51" name="Text 47"/>
+          <p:cNvSpPr/>
+          <p:nvPr/>
+        </p:nvSpPr>
+        <p:spPr>
+          <a:xfrm>
+            <a:off x="5936903" y="3152180"/>
+            <a:ext cx="2621310" cy="307181"/>
+          </a:xfrm>
+          <a:prstGeom prst="rect">
+            <a:avLst/>
+          </a:prstGeom>
+          <a:noFill/>
+          <a:ln/>
+        </p:spPr>
+        <p:txBody>
+          <a:bodyPr wrap="square" lIns="0" tIns="0" rIns="0" bIns="0" rtlCol="0" anchor="t"/>
+          <a:lstStyle/>
+          <a:p>
+            <a:pPr algn="l" indent="0" marL="0">
+              <a:lnSpc>
+                <a:spcPts val="938"/>
+              </a:lnSpc>
+              <a:buNone/>
+            </a:pPr>
+            <a:r>
+              <a:rPr lang="en-US" sz="800" dirty="0">
+                <a:solidFill>
+                  <a:srgbClr val="46B0A3"/>
+                </a:solidFill>
+                <a:latin typeface="Inter" pitchFamily="34" charset="0"/>
+                <a:ea typeface="Inter" pitchFamily="34" charset="-122"/>
+                <a:cs typeface="Inter" pitchFamily="34" charset="-120"/>
+              </a:rPr>
+              <a:t>Левофланговое расположение</a:t>
+            </a:r>
+            <a:endParaRPr lang="en-US" sz="800" dirty="0"/>
+          </a:p>
+          <a:p>
+            <a:pPr algn="l" indent="0" marL="0">
+              <a:lnSpc>
+                <a:spcPts val="938"/>
+              </a:lnSpc>
+              <a:buNone/>
+            </a:pPr>
+            <a:r>
+              <a:rPr lang="en-US" sz="800" dirty="0">
+                <a:solidFill>
+                  <a:srgbClr val="1A1F2E"/>
+                </a:solidFill>
+                <a:latin typeface="Inter" pitchFamily="34" charset="0"/>
+                <a:ea typeface="Inter" pitchFamily="34" charset="-122"/>
+                <a:cs typeface="Inter" pitchFamily="34" charset="-120"/>
+              </a:rPr>
+              <a:t>В хедерах и сайдбарах UI левое поле = 0. Правое, верхнее и нижнее — по правилам выше.</a:t>
+            </a:r>
+            <a:endParaRPr lang="en-US" sz="800" dirty="0"/>
+          </a:p>
+        </p:txBody>
+      </p:sp>
+      <p:sp>
+        <p:nvSpPr>
+          <p:cNvPr id="52" name="Text 48"/>
+          <p:cNvSpPr/>
+          <p:nvPr/>
+        </p:nvSpPr>
+        <p:spPr>
+          <a:xfrm>
+            <a:off x="5565428" y="3645098"/>
+            <a:ext cx="3121372" cy="457200"/>
+          </a:xfrm>
+          <a:prstGeom prst="roundRect">
+            <a:avLst>
+              <a:gd name="adj" fmla="val 25000"/>
+            </a:avLst>
+          </a:prstGeom>
+          <a:solidFill>
+            <a:srgbClr val="C9A96E">
+              <a:alpha val="16000"/>
+            </a:srgbClr>
+          </a:solidFill>
+          <a:ln/>
+        </p:spPr>
+        <p:txBody>
+          <a:bodyPr wrap="square" rtlCol="0" anchor="ctr"/>
+          <a:lstStyle/>
+          <a:p>
+            <a:pPr indent="0" marL="0">
+              <a:buNone/>
+            </a:pPr>
+            <a:endParaRPr lang="en-US" dirty="0"/>
+          </a:p>
+        </p:txBody>
+      </p:sp>
+      <p:sp>
+        <p:nvSpPr>
+          <p:cNvPr id="53" name="Text 49"/>
+          <p:cNvSpPr/>
+          <p:nvPr/>
+        </p:nvSpPr>
+        <p:spPr>
+          <a:xfrm>
+            <a:off x="5694015" y="3795117"/>
+            <a:ext cx="157163" cy="157163"/>
+          </a:xfrm>
+          <a:prstGeom prst="rect">
+            <a:avLst/>
+          </a:prstGeom>
+          <a:noFill/>
+          <a:ln/>
+        </p:spPr>
+        <p:txBody>
+          <a:bodyPr wrap="none" lIns="0" tIns="0" rIns="0" bIns="0" rtlCol="0" anchor="ctr"/>
+          <a:lstStyle/>
+          <a:p>
+            <a:pPr algn="ctr" indent="0" marL="0">
+              <a:buNone/>
+            </a:pPr>
+            <a:r>
+              <a:rPr lang="en-US" sz="1547" dirty="0">
+                <a:solidFill>
+                  <a:srgbClr val="C9A96E"/>
+                </a:solidFill>
+                <a:latin typeface="Segoe UI Symbol" pitchFamily="34" charset="0"/>
+                <a:ea typeface="Segoe UI Symbol" pitchFamily="34" charset="-122"/>
+                <a:cs typeface="Segoe UI Symbol" pitchFamily="34" charset="-120"/>
+              </a:rPr>
+              <a:t>✦</a:t>
+            </a:r>
+            <a:endParaRPr lang="en-US" sz="1547" dirty="0"/>
+          </a:p>
+        </p:txBody>
+      </p:sp>
+      <p:sp>
+        <p:nvSpPr>
+          <p:cNvPr id="54" name="Text 50"/>
+          <p:cNvSpPr/>
+          <p:nvPr/>
+        </p:nvSpPr>
+        <p:spPr>
+          <a:xfrm>
+            <a:off x="5936903" y="3695105"/>
+            <a:ext cx="2621310" cy="307181"/>
+          </a:xfrm>
+          <a:prstGeom prst="rect">
+            <a:avLst/>
+          </a:prstGeom>
+          <a:noFill/>
+          <a:ln/>
+        </p:spPr>
+        <p:txBody>
+          <a:bodyPr wrap="square" lIns="0" tIns="0" rIns="0" bIns="0" rtlCol="0" anchor="t"/>
+          <a:lstStyle/>
+          <a:p>
+            <a:pPr algn="l" indent="0" marL="0">
+              <a:lnSpc>
+                <a:spcPts val="938"/>
+              </a:lnSpc>
+              <a:buNone/>
+            </a:pPr>
+            <a:r>
+              <a:rPr lang="en-US" sz="800" dirty="0">
+                <a:solidFill>
+                  <a:srgbClr val="C9A96E"/>
+                </a:solidFill>
+                <a:latin typeface="Inter" pitchFamily="34" charset="0"/>
+                <a:ea typeface="Inter" pitchFamily="34" charset="-122"/>
+                <a:cs typeface="Inter" pitchFamily="34" charset="-120"/>
+              </a:rPr>
+              <a:t>Минимальный размер</a:t>
+            </a:r>
+            <a:endParaRPr lang="en-US" sz="800" dirty="0"/>
+          </a:p>
+          <a:p>
+            <a:pPr algn="l" indent="0" marL="0">
+              <a:lnSpc>
+                <a:spcPts val="938"/>
+              </a:lnSpc>
+              <a:buNone/>
+            </a:pPr>
+            <a:r>
+              <a:rPr lang="en-US" sz="800" dirty="0">
+                <a:solidFill>
+                  <a:srgbClr val="1A1F2E"/>
+                </a:solidFill>
+                <a:latin typeface="Inter" pitchFamily="34" charset="0"/>
+                <a:ea typeface="Inter" pitchFamily="34" charset="-122"/>
+                <a:cs typeface="Inter" pitchFamily="34" charset="-120"/>
+              </a:rPr>
+              <a:t>Печать — 16 мм. Интерфейс — 48 px. Меньше — нельзя: теряется читаемость.</a:t>
+            </a:r>
+            <a:endParaRPr lang="en-US" sz="800" dirty="0"/>
+          </a:p>
+        </p:txBody>
+      </p:sp>
+      <p:sp>
+        <p:nvSpPr>
+          <p:cNvPr id="55" name="Text 51"/>
+          <p:cNvSpPr/>
+          <p:nvPr/>
+        </p:nvSpPr>
+        <p:spPr>
+          <a:xfrm>
+            <a:off x="257175" y="200025"/>
+            <a:ext cx="1152902" cy="169999"/>
+          </a:xfrm>
+          <a:prstGeom prst="rect">
+            <a:avLst/>
+          </a:prstGeom>
+          <a:noFill/>
+          <a:ln/>
+        </p:spPr>
+        <p:txBody>
+          <a:bodyPr wrap="none" lIns="0" tIns="0" rIns="0" bIns="0" rtlCol="0" anchor="t"/>
+          <a:lstStyle/>
+          <a:p>
+            <a:pPr algn="l" indent="0" marL="0">
+              <a:lnSpc>
+                <a:spcPts val="1133"/>
+              </a:lnSpc>
+              <a:buNone/>
+            </a:pPr>
+            <a:r>
+              <a:rPr lang="en-US" sz="800" spc="132" kern="0" dirty="0">
+                <a:solidFill>
+                  <a:srgbClr val="8B95A7"/>
+                </a:solidFill>
+                <a:latin typeface="Inter" pitchFamily="34" charset="0"/>
+                <a:ea typeface="Inter" pitchFamily="34" charset="-122"/>
+                <a:cs typeface="Inter" pitchFamily="34" charset="-120"/>
+              </a:rPr>
+              <a:t>МИС АЛЬТЕРА</a:t>
+            </a:r>
+            <a:endParaRPr lang="en-US" sz="800" dirty="0"/>
+          </a:p>
+        </p:txBody>
+      </p:sp>
+      <p:sp>
+        <p:nvSpPr>
+          <p:cNvPr id="56" name="Text 52"/>
+          <p:cNvSpPr/>
+          <p:nvPr/>
+        </p:nvSpPr>
+        <p:spPr>
+          <a:xfrm>
+            <a:off x="8556203" y="4799595"/>
+            <a:ext cx="473822" cy="169999"/>
+          </a:xfrm>
+          <a:prstGeom prst="rect">
+            <a:avLst/>
+          </a:prstGeom>
+          <a:noFill/>
+          <a:ln/>
+        </p:spPr>
+        <p:txBody>
+          <a:bodyPr wrap="none" lIns="0" tIns="0" rIns="0" bIns="0" rtlCol="0" anchor="t"/>
+          <a:lstStyle/>
+          <a:p>
+            <a:pPr algn="l" indent="0" marL="0">
+              <a:lnSpc>
+                <a:spcPts val="1133"/>
+              </a:lnSpc>
+              <a:buNone/>
+            </a:pPr>
+            <a:r>
+              <a:rPr lang="en-US" sz="800" spc="59" kern="0" dirty="0">
+                <a:solidFill>
+                  <a:srgbClr val="8B95A7"/>
+                </a:solidFill>
+                <a:latin typeface="Liberation Sans Narrow" pitchFamily="34" charset="0"/>
+                <a:ea typeface="Liberation Sans Narrow" pitchFamily="34" charset="-122"/>
+                <a:cs typeface="Liberation Sans Narrow" pitchFamily="34" charset="-120"/>
+              </a:rPr>
+              <a:t>15 / 15</a:t>
             </a:r>
             <a:endParaRPr lang="en-US" sz="800" dirty="0"/>
           </a:p>
@@ -10549,7 +12981,7 @@
                 <a:ea typeface="Liberation Sans Narrow" pitchFamily="34" charset="-122"/>
                 <a:cs typeface="Liberation Sans Narrow" pitchFamily="34" charset="-120"/>
               </a:rPr>
-              <a:t>02 / 14</a:t>
+              <a:t>02 / 15</a:t>
             </a:r>
             <a:endParaRPr lang="en-US" sz="800" dirty="0"/>
           </a:p>
@@ -11615,7 +14047,7 @@
                 <a:ea typeface="Liberation Sans Narrow" pitchFamily="34" charset="-122"/>
                 <a:cs typeface="Liberation Sans Narrow" pitchFamily="34" charset="-120"/>
               </a:rPr>
-              <a:t>03 / 14</a:t>
+              <a:t>03 / 15</a:t>
             </a:r>
             <a:endParaRPr lang="en-US" sz="800" dirty="0"/>
           </a:p>
@@ -13020,7 +15452,7 @@
                 <a:ea typeface="Liberation Sans Narrow" pitchFamily="34" charset="-122"/>
                 <a:cs typeface="Liberation Sans Narrow" pitchFamily="34" charset="-120"/>
               </a:rPr>
-              <a:t>04 / 14</a:t>
+              <a:t>04 / 15</a:t>
             </a:r>
             <a:endParaRPr lang="en-US" sz="800" dirty="0"/>
           </a:p>
@@ -14468,7 +16900,7 @@
                 <a:ea typeface="Liberation Sans Narrow" pitchFamily="34" charset="-122"/>
                 <a:cs typeface="Liberation Sans Narrow" pitchFamily="34" charset="-120"/>
               </a:rPr>
-              <a:t>05 / 14</a:t>
+              <a:t>05 / 15</a:t>
             </a:r>
             <a:endParaRPr lang="en-US" sz="800" dirty="0"/>
           </a:p>
@@ -16687,7 +19119,7 @@
                 <a:ea typeface="Liberation Sans Narrow" pitchFamily="34" charset="-122"/>
                 <a:cs typeface="Liberation Sans Narrow" pitchFamily="34" charset="-120"/>
               </a:rPr>
-              <a:t>06 / 14</a:t>
+              <a:t>06 / 15</a:t>
             </a:r>
             <a:endParaRPr lang="en-US" sz="800" dirty="0"/>
           </a:p>
@@ -17926,7 +20358,7 @@
                 <a:ea typeface="Liberation Sans Narrow" pitchFamily="34" charset="-122"/>
                 <a:cs typeface="Liberation Sans Narrow" pitchFamily="34" charset="-120"/>
               </a:rPr>
-              <a:t>07 / 14</a:t>
+              <a:t>07 / 15</a:t>
             </a:r>
             <a:endParaRPr lang="en-US" sz="800" dirty="0"/>
           </a:p>
@@ -19044,7 +21476,7 @@
                 <a:ea typeface="Liberation Sans Narrow" pitchFamily="34" charset="-122"/>
                 <a:cs typeface="Liberation Sans Narrow" pitchFamily="34" charset="-120"/>
               </a:rPr>
-              <a:t>08 / 14</a:t>
+              <a:t>08 / 15</a:t>
             </a:r>
             <a:endParaRPr lang="en-US" sz="800" dirty="0"/>
           </a:p>
@@ -20300,7 +22732,7 @@
                 <a:ea typeface="Liberation Sans Narrow" pitchFamily="34" charset="-122"/>
                 <a:cs typeface="Liberation Sans Narrow" pitchFamily="34" charset="-120"/>
               </a:rPr>
-              <a:t>09 / 14</a:t>
+              <a:t>09 / 15</a:t>
             </a:r>
             <a:endParaRPr lang="en-US" sz="800" dirty="0"/>
           </a:p>

</xml_diff>